<commit_message>
vault backup: 2026-08-11 20:01:08
</commit_message>
<xml_diff>
--- a/CdBd 기능 문서 구조 설계.pptx
+++ b/CdBd 기능 문서 구조 설계.pptx
@@ -4548,7 +4548,7 @@
                 <a:ea typeface="Pretendard Medium" pitchFamily="34" charset="-122"/>
                 <a:cs typeface="Pretendard Medium" pitchFamily="34" charset="-120"/>
               </a:rPr>
-              <a:t>실제 파일의 일부입니다 — 전체 96개 기능을 이렇게 한 줄씩. 내용은 복제하지 않고 ‘위치’만 가리킵니다.</a:t>
+              <a:t>실제 파일의 일부입니다 — CdBd 페이지 기능 약 40개(카드 15종 포함)를 이렇게 한 줄씩. 내용은 복제하지 않고 ‘위치’만 가리킵니다.</a:t>
             </a:r>
             <a:endParaRPr lang="en-US" sz="1150" dirty="0"/>
           </a:p>
@@ -4739,7 +4739,7 @@
                 <a:ea typeface="Pretendard" pitchFamily="34" charset="-122"/>
                 <a:cs typeface="Pretendard" pitchFamily="34" charset="-120"/>
               </a:rPr>
-              <a:t>목록이 가리키는 실제 볼트는 이렇게 생겼습니다.</a:t>
+              <a:t>‘4. 카드 기능 정의’ 폴더 안엔 카드 15종이 낱개 파일(4-3~4-17)로 들어 있습니다.</a:t>
             </a:r>
             <a:endParaRPr lang="en-US" sz="1500" dirty="0"/>
           </a:p>
@@ -4832,7 +4832,7 @@
         <p:spPr>
           <a:xfrm>
             <a:off x="777240" y="2377440"/>
-            <a:ext cx="6126480" cy="3611880"/>
+            <a:ext cx="4937760" cy="3611880"/>
           </a:xfrm>
           <a:prstGeom prst="roundRect">
             <a:avLst>
@@ -4858,8 +4858,8 @@
         </p:nvSpPr>
         <p:spPr>
           <a:xfrm>
-            <a:off x="1069848" y="2578608"/>
-            <a:ext cx="3593592" cy="301752"/>
+            <a:off x="1051560" y="2578608"/>
+            <a:ext cx="2697480" cy="310896"/>
           </a:xfrm>
           <a:prstGeom prst="rect">
             <a:avLst/>
@@ -4878,7 +4878,7 @@
               <a:buNone/>
             </a:pPr>
             <a:r>
-              <a:rPr lang="en-US" sz="1150" dirty="0">
+              <a:rPr lang="en-US" sz="1100" dirty="0">
                 <a:solidFill>
                   <a:srgbClr val="1D1D1F"/>
                 </a:solidFill>
@@ -4888,7 +4888,7 @@
               </a:rPr>
               <a:t>cdbd-design-system/</a:t>
             </a:r>
-            <a:endParaRPr lang="en-US" sz="1150" dirty="0"/>
+            <a:endParaRPr lang="en-US" sz="1100" dirty="0"/>
           </a:p>
         </p:txBody>
       </p:sp>
@@ -4900,8 +4900,8 @@
         </p:nvSpPr>
         <p:spPr>
           <a:xfrm>
-            <a:off x="1069848" y="2880360"/>
-            <a:ext cx="3593592" cy="301752"/>
+            <a:off x="1051560" y="2889504"/>
+            <a:ext cx="2697480" cy="310896"/>
           </a:xfrm>
           <a:prstGeom prst="rect">
             <a:avLst/>
@@ -4920,7 +4920,7 @@
               <a:buNone/>
             </a:pPr>
             <a:r>
-              <a:rPr lang="en-US" sz="1150" dirty="0">
+              <a:rPr lang="en-US" sz="1100" dirty="0">
                 <a:solidFill>
                   <a:srgbClr val="1D1D1F"/>
                 </a:solidFill>
@@ -4930,7 +4930,7 @@
               </a:rPr>
               <a:t>├─ CLAUDE.md</a:t>
             </a:r>
-            <a:endParaRPr lang="en-US" sz="1150" dirty="0"/>
+            <a:endParaRPr lang="en-US" sz="1100" dirty="0"/>
           </a:p>
         </p:txBody>
       </p:sp>
@@ -4942,8 +4942,8 @@
         </p:nvSpPr>
         <p:spPr>
           <a:xfrm>
-            <a:off x="4754880" y="2880360"/>
-            <a:ext cx="2075688" cy="301752"/>
+            <a:off x="3840480" y="2889504"/>
+            <a:ext cx="1783080" cy="310896"/>
           </a:xfrm>
           <a:prstGeom prst="rect">
             <a:avLst/>
@@ -4962,7 +4962,7 @@
               <a:buNone/>
             </a:pPr>
             <a:r>
-              <a:rPr lang="en-US" sz="1100" dirty="0">
+              <a:rPr lang="en-US" sz="1050" dirty="0">
                 <a:solidFill>
                   <a:srgbClr val="6C4CFF"/>
                 </a:solidFill>
@@ -4970,9 +4970,9 @@
                 <a:ea typeface="Pretendard" pitchFamily="34" charset="-122"/>
                 <a:cs typeface="Pretendard" pitchFamily="34" charset="-120"/>
               </a:rPr>
-              <a:t>@_기능별 경로 가이드.md</a:t>
-            </a:r>
-            <a:endParaRPr lang="en-US" sz="1100" dirty="0"/>
+              <a:t>@경로 가이드</a:t>
+            </a:r>
+            <a:endParaRPr lang="en-US" sz="1050" dirty="0"/>
           </a:p>
         </p:txBody>
       </p:sp>
@@ -4984,8 +4984,8 @@
         </p:nvSpPr>
         <p:spPr>
           <a:xfrm>
-            <a:off x="1069848" y="3182112"/>
-            <a:ext cx="3593592" cy="301752"/>
+            <a:off x="1051560" y="3200400"/>
+            <a:ext cx="2697480" cy="310896"/>
           </a:xfrm>
           <a:prstGeom prst="rect">
             <a:avLst/>
@@ -5004,7 +5004,7 @@
               <a:buNone/>
             </a:pPr>
             <a:r>
-              <a:rPr lang="en-US" sz="1150" dirty="0">
+              <a:rPr lang="en-US" sz="1100" dirty="0">
                 <a:solidFill>
                   <a:srgbClr val="6C4CFF"/>
                 </a:solidFill>
@@ -5014,7 +5014,7 @@
               </a:rPr>
               <a:t>├─ _기능별 경로 가이드.md</a:t>
             </a:r>
-            <a:endParaRPr lang="en-US" sz="1150" dirty="0"/>
+            <a:endParaRPr lang="en-US" sz="1100" dirty="0"/>
           </a:p>
         </p:txBody>
       </p:sp>
@@ -5026,8 +5026,8 @@
         </p:nvSpPr>
         <p:spPr>
           <a:xfrm>
-            <a:off x="4754880" y="3182112"/>
-            <a:ext cx="2075688" cy="301752"/>
+            <a:off x="3840480" y="3200400"/>
+            <a:ext cx="1783080" cy="310896"/>
           </a:xfrm>
           <a:prstGeom prst="rect">
             <a:avLst/>
@@ -5046,7 +5046,7 @@
               <a:buNone/>
             </a:pPr>
             <a:r>
-              <a:rPr lang="en-US" sz="1100" dirty="0">
+              <a:rPr lang="en-US" sz="1050" dirty="0">
                 <a:solidFill>
                   <a:srgbClr val="6C4CFF"/>
                 </a:solidFill>
@@ -5054,9 +5054,9 @@
                 <a:ea typeface="Pretendard" pitchFamily="34" charset="-122"/>
                 <a:cs typeface="Pretendard" pitchFamily="34" charset="-120"/>
               </a:rPr>
-              <a:t>이 볼트 기능 목록</a:t>
-            </a:r>
-            <a:endParaRPr lang="en-US" sz="1100" dirty="0"/>
+              <a:t>기능 목록</a:t>
+            </a:r>
+            <a:endParaRPr lang="en-US" sz="1050" dirty="0"/>
           </a:p>
         </p:txBody>
       </p:sp>
@@ -5068,8 +5068,8 @@
         </p:nvSpPr>
         <p:spPr>
           <a:xfrm>
-            <a:off x="1069848" y="3483864"/>
-            <a:ext cx="3593592" cy="301752"/>
+            <a:off x="1051560" y="3511296"/>
+            <a:ext cx="2697480" cy="310896"/>
           </a:xfrm>
           <a:prstGeom prst="rect">
             <a:avLst/>
@@ -5088,7 +5088,7 @@
               <a:buNone/>
             </a:pPr>
             <a:r>
-              <a:rPr lang="en-US" sz="1150" dirty="0">
+              <a:rPr lang="en-US" sz="1100" dirty="0">
                 <a:solidFill>
                   <a:srgbClr val="1D1D1F"/>
                 </a:solidFill>
@@ -5098,7 +5098,7 @@
               </a:rPr>
               <a:t>├─ .claude/skills/</a:t>
             </a:r>
-            <a:endParaRPr lang="en-US" sz="1150" dirty="0"/>
+            <a:endParaRPr lang="en-US" sz="1100" dirty="0"/>
           </a:p>
         </p:txBody>
       </p:sp>
@@ -5110,8 +5110,8 @@
         </p:nvSpPr>
         <p:spPr>
           <a:xfrm>
-            <a:off x="1069848" y="3785616"/>
-            <a:ext cx="3593592" cy="301752"/>
+            <a:off x="1051560" y="3822192"/>
+            <a:ext cx="2697480" cy="310896"/>
           </a:xfrm>
           <a:prstGeom prst="rect">
             <a:avLst/>
@@ -5130,7 +5130,7 @@
               <a:buNone/>
             </a:pPr>
             <a:r>
-              <a:rPr lang="en-US" sz="1150" dirty="0">
+              <a:rPr lang="en-US" sz="1100" dirty="0">
                 <a:solidFill>
                   <a:srgbClr val="1D1D1F"/>
                 </a:solidFill>
@@ -5138,9 +5138,9 @@
                 <a:ea typeface="Pretendard Medium" pitchFamily="34" charset="-122"/>
                 <a:cs typeface="Pretendard Medium" pitchFamily="34" charset="-120"/>
               </a:rPr>
-              <a:t>│    ├─ cdbd-icon-use/</a:t>
-            </a:r>
-            <a:endParaRPr lang="en-US" sz="1150" dirty="0"/>
+              <a:t>│   ├─ cdbd-icon-use/</a:t>
+            </a:r>
+            <a:endParaRPr lang="en-US" sz="1100" dirty="0"/>
           </a:p>
         </p:txBody>
       </p:sp>
@@ -5152,8 +5152,8 @@
         </p:nvSpPr>
         <p:spPr>
           <a:xfrm>
-            <a:off x="4754880" y="3785616"/>
-            <a:ext cx="2075688" cy="301752"/>
+            <a:off x="3840480" y="3822192"/>
+            <a:ext cx="1783080" cy="310896"/>
           </a:xfrm>
           <a:prstGeom prst="rect">
             <a:avLst/>
@@ -5172,7 +5172,7 @@
               <a:buNone/>
             </a:pPr>
             <a:r>
-              <a:rPr lang="en-US" sz="1100" dirty="0">
+              <a:rPr lang="en-US" sz="1050" dirty="0">
                 <a:solidFill>
                   <a:srgbClr val="6C4CFF"/>
                 </a:solidFill>
@@ -5180,9 +5180,9 @@
                 <a:ea typeface="Pretendard" pitchFamily="34" charset="-122"/>
                 <a:cs typeface="Pretendard" pitchFamily="34" charset="-120"/>
               </a:rPr>
-              <a:t>아이콘 배치·교체</a:t>
-            </a:r>
-            <a:endParaRPr lang="en-US" sz="1100" dirty="0"/>
+              <a:t>아이콘 배치</a:t>
+            </a:r>
+            <a:endParaRPr lang="en-US" sz="1050" dirty="0"/>
           </a:p>
         </p:txBody>
       </p:sp>
@@ -5194,8 +5194,8 @@
         </p:nvSpPr>
         <p:spPr>
           <a:xfrm>
-            <a:off x="1069848" y="4087368"/>
-            <a:ext cx="3593592" cy="301752"/>
+            <a:off x="1051560" y="4133088"/>
+            <a:ext cx="2697480" cy="310896"/>
           </a:xfrm>
           <a:prstGeom prst="rect">
             <a:avLst/>
@@ -5214,7 +5214,7 @@
               <a:buNone/>
             </a:pPr>
             <a:r>
-              <a:rPr lang="en-US" sz="1150" dirty="0">
+              <a:rPr lang="en-US" sz="1100" dirty="0">
                 <a:solidFill>
                   <a:srgbClr val="1D1D1F"/>
                 </a:solidFill>
@@ -5222,9 +5222,9 @@
                 <a:ea typeface="Pretendard Medium" pitchFamily="34" charset="-122"/>
                 <a:cs typeface="Pretendard Medium" pitchFamily="34" charset="-120"/>
               </a:rPr>
-              <a:t>│    └─ cdbd-icon-creation/</a:t>
-            </a:r>
-            <a:endParaRPr lang="en-US" sz="1150" dirty="0"/>
+              <a:t>│   └─ cdbd-icon-creation/</a:t>
+            </a:r>
+            <a:endParaRPr lang="en-US" sz="1100" dirty="0"/>
           </a:p>
         </p:txBody>
       </p:sp>
@@ -5236,8 +5236,8 @@
         </p:nvSpPr>
         <p:spPr>
           <a:xfrm>
-            <a:off x="4754880" y="4087368"/>
-            <a:ext cx="2075688" cy="301752"/>
+            <a:off x="3840480" y="4133088"/>
+            <a:ext cx="1783080" cy="310896"/>
           </a:xfrm>
           <a:prstGeom prst="rect">
             <a:avLst/>
@@ -5256,7 +5256,7 @@
               <a:buNone/>
             </a:pPr>
             <a:r>
-              <a:rPr lang="en-US" sz="1100" dirty="0">
+              <a:rPr lang="en-US" sz="1050" dirty="0">
                 <a:solidFill>
                   <a:srgbClr val="6C4CFF"/>
                 </a:solidFill>
@@ -5264,9 +5264,9 @@
                 <a:ea typeface="Pretendard" pitchFamily="34" charset="-122"/>
                 <a:cs typeface="Pretendard" pitchFamily="34" charset="-120"/>
               </a:rPr>
-              <a:t>신규 아이콘 제작</a:t>
-            </a:r>
-            <a:endParaRPr lang="en-US" sz="1100" dirty="0"/>
+              <a:t>아이콘 제작</a:t>
+            </a:r>
+            <a:endParaRPr lang="en-US" sz="1050" dirty="0"/>
           </a:p>
         </p:txBody>
       </p:sp>
@@ -5278,8 +5278,8 @@
         </p:nvSpPr>
         <p:spPr>
           <a:xfrm>
-            <a:off x="1069848" y="4389120"/>
-            <a:ext cx="3593592" cy="301752"/>
+            <a:off x="1051560" y="4443984"/>
+            <a:ext cx="2697480" cy="310896"/>
           </a:xfrm>
           <a:prstGeom prst="rect">
             <a:avLst/>
@@ -5298,7 +5298,7 @@
               <a:buNone/>
             </a:pPr>
             <a:r>
-              <a:rPr lang="en-US" sz="1150" dirty="0">
+              <a:rPr lang="en-US" sz="1100" dirty="0">
                 <a:solidFill>
                   <a:srgbClr val="1D1D1F"/>
                 </a:solidFill>
@@ -5308,7 +5308,7 @@
               </a:rPr>
               <a:t>└─ 디자인 시스템/</a:t>
             </a:r>
-            <a:endParaRPr lang="en-US" sz="1150" dirty="0"/>
+            <a:endParaRPr lang="en-US" sz="1100" dirty="0"/>
           </a:p>
         </p:txBody>
       </p:sp>
@@ -5320,8 +5320,8 @@
         </p:nvSpPr>
         <p:spPr>
           <a:xfrm>
-            <a:off x="1069848" y="4690872"/>
-            <a:ext cx="3593592" cy="301752"/>
+            <a:off x="1051560" y="4754880"/>
+            <a:ext cx="2697480" cy="310896"/>
           </a:xfrm>
           <a:prstGeom prst="rect">
             <a:avLst/>
@@ -5340,7 +5340,7 @@
               <a:buNone/>
             </a:pPr>
             <a:r>
-              <a:rPr lang="en-US" sz="1150" dirty="0">
+              <a:rPr lang="en-US" sz="1100" dirty="0">
                 <a:solidFill>
                   <a:srgbClr val="1D1D1F"/>
                 </a:solidFill>
@@ -5348,9 +5348,9 @@
                 <a:ea typeface="Pretendard Medium" pitchFamily="34" charset="-122"/>
                 <a:cs typeface="Pretendard Medium" pitchFamily="34" charset="-120"/>
               </a:rPr>
-              <a:t>     ├─ 1. 스타일/</a:t>
-            </a:r>
-            <a:endParaRPr lang="en-US" sz="1150" dirty="0"/>
+              <a:t>    ├─ 1. 스타일/</a:t>
+            </a:r>
+            <a:endParaRPr lang="en-US" sz="1100" dirty="0"/>
           </a:p>
         </p:txBody>
       </p:sp>
@@ -5362,8 +5362,8 @@
         </p:nvSpPr>
         <p:spPr>
           <a:xfrm>
-            <a:off x="4754880" y="4690872"/>
-            <a:ext cx="2075688" cy="301752"/>
+            <a:off x="3840480" y="4754880"/>
+            <a:ext cx="1783080" cy="310896"/>
           </a:xfrm>
           <a:prstGeom prst="rect">
             <a:avLst/>
@@ -5382,7 +5382,7 @@
               <a:buNone/>
             </a:pPr>
             <a:r>
-              <a:rPr lang="en-US" sz="1100" dirty="0">
+              <a:rPr lang="en-US" sz="1050" dirty="0">
                 <a:solidFill>
                   <a:srgbClr val="6C4CFF"/>
                 </a:solidFill>
@@ -5390,7 +5390,49 @@
                 <a:ea typeface="Pretendard" pitchFamily="34" charset="-122"/>
                 <a:cs typeface="Pretendard" pitchFamily="34" charset="-120"/>
               </a:rPr>
-              <a:t>컬러 · 폰트</a:t>
+              <a:t>컬러·폰트</a:t>
+            </a:r>
+            <a:endParaRPr lang="en-US" sz="1050" dirty="0"/>
+          </a:p>
+        </p:txBody>
+      </p:sp>
+      <p:sp>
+        <p:nvSpPr>
+          <p:cNvPr id="22" name="Text 20"/>
+          <p:cNvSpPr/>
+          <p:nvPr/>
+        </p:nvSpPr>
+        <p:spPr>
+          <a:xfrm>
+            <a:off x="1051560" y="5065776"/>
+            <a:ext cx="2697480" cy="310896"/>
+          </a:xfrm>
+          <a:prstGeom prst="rect">
+            <a:avLst/>
+          </a:prstGeom>
+          <a:noFill/>
+          <a:ln/>
+        </p:spPr>
+        <p:txBody>
+          <a:bodyPr wrap="square" lIns="0" tIns="0" rIns="0" bIns="0" rtlCol="0" anchor="ctr"/>
+          <a:lstStyle/>
+          <a:p>
+            <a:pPr algn="l" indent="0" marL="0">
+              <a:lnSpc>
+                <a:spcPct val="100000"/>
+              </a:lnSpc>
+              <a:buNone/>
+            </a:pPr>
+            <a:r>
+              <a:rPr lang="en-US" sz="1100" dirty="0">
+                <a:solidFill>
+                  <a:srgbClr val="6C4CFF"/>
+                </a:solidFill>
+                <a:latin typeface="Pretendard SemiBold" pitchFamily="34" charset="0"/>
+                <a:ea typeface="Pretendard SemiBold" pitchFamily="34" charset="-122"/>
+                <a:cs typeface="Pretendard SemiBold" pitchFamily="34" charset="-120"/>
+              </a:rPr>
+              <a:t>    ├─ 4. 카드 기능 정의/</a:t>
             </a:r>
             <a:endParaRPr lang="en-US" sz="1100" dirty="0"/>
           </a:p>
@@ -5398,14 +5440,14 @@
       </p:sp>
       <p:sp>
         <p:nvSpPr>
-          <p:cNvPr id="22" name="Text 20"/>
-          <p:cNvSpPr/>
-          <p:nvPr/>
-        </p:nvSpPr>
-        <p:spPr>
-          <a:xfrm>
-            <a:off x="1069848" y="4992624"/>
-            <a:ext cx="3593592" cy="301752"/>
+          <p:cNvPr id="23" name="Text 21"/>
+          <p:cNvSpPr/>
+          <p:nvPr/>
+        </p:nvSpPr>
+        <p:spPr>
+          <a:xfrm>
+            <a:off x="3840480" y="5065776"/>
+            <a:ext cx="1783080" cy="310896"/>
           </a:xfrm>
           <a:prstGeom prst="rect">
             <a:avLst/>
@@ -5424,7 +5466,49 @@
               <a:buNone/>
             </a:pPr>
             <a:r>
-              <a:rPr lang="en-US" sz="1150" dirty="0">
+              <a:rPr lang="en-US" sz="1050" dirty="0">
+                <a:solidFill>
+                  <a:srgbClr val="6C4CFF"/>
+                </a:solidFill>
+                <a:latin typeface="Pretendard" pitchFamily="34" charset="0"/>
+                <a:ea typeface="Pretendard" pitchFamily="34" charset="-122"/>
+                <a:cs typeface="Pretendard" pitchFamily="34" charset="-120"/>
+              </a:rPr>
+              <a:t>카드 15종 →</a:t>
+            </a:r>
+            <a:endParaRPr lang="en-US" sz="1050" dirty="0"/>
+          </a:p>
+        </p:txBody>
+      </p:sp>
+      <p:sp>
+        <p:nvSpPr>
+          <p:cNvPr id="24" name="Text 22"/>
+          <p:cNvSpPr/>
+          <p:nvPr/>
+        </p:nvSpPr>
+        <p:spPr>
+          <a:xfrm>
+            <a:off x="1051560" y="5376672"/>
+            <a:ext cx="2697480" cy="310896"/>
+          </a:xfrm>
+          <a:prstGeom prst="rect">
+            <a:avLst/>
+          </a:prstGeom>
+          <a:noFill/>
+          <a:ln/>
+        </p:spPr>
+        <p:txBody>
+          <a:bodyPr wrap="square" lIns="0" tIns="0" rIns="0" bIns="0" rtlCol="0" anchor="ctr"/>
+          <a:lstStyle/>
+          <a:p>
+            <a:pPr algn="l" indent="0" marL="0">
+              <a:lnSpc>
+                <a:spcPct val="100000"/>
+              </a:lnSpc>
+              <a:buNone/>
+            </a:pPr>
+            <a:r>
+              <a:rPr lang="en-US" sz="1100" dirty="0">
                 <a:solidFill>
                   <a:srgbClr val="1D1D1F"/>
                 </a:solidFill>
@@ -5432,22 +5516,22 @@
                 <a:ea typeface="Pretendard Medium" pitchFamily="34" charset="-122"/>
                 <a:cs typeface="Pretendard Medium" pitchFamily="34" charset="-120"/>
               </a:rPr>
-              <a:t>     ├─ 4. 카드 기능 정의/</a:t>
-            </a:r>
-            <a:endParaRPr lang="en-US" sz="1150" dirty="0"/>
-          </a:p>
-        </p:txBody>
-      </p:sp>
-      <p:sp>
-        <p:nvSpPr>
-          <p:cNvPr id="23" name="Text 21"/>
-          <p:cNvSpPr/>
-          <p:nvPr/>
-        </p:nvSpPr>
-        <p:spPr>
-          <a:xfrm>
-            <a:off x="4754880" y="4992624"/>
-            <a:ext cx="2075688" cy="301752"/>
+              <a:t>    └─ 5. 신규 기획 가이드/</a:t>
+            </a:r>
+            <a:endParaRPr lang="en-US" sz="1100" dirty="0"/>
+          </a:p>
+        </p:txBody>
+      </p:sp>
+      <p:sp>
+        <p:nvSpPr>
+          <p:cNvPr id="25" name="Text 23"/>
+          <p:cNvSpPr/>
+          <p:nvPr/>
+        </p:nvSpPr>
+        <p:spPr>
+          <a:xfrm>
+            <a:off x="3840480" y="5376672"/>
+            <a:ext cx="1783080" cy="310896"/>
           </a:xfrm>
           <a:prstGeom prst="rect">
             <a:avLst/>
@@ -5466,7 +5550,7 @@
               <a:buNone/>
             </a:pPr>
             <a:r>
-              <a:rPr lang="en-US" sz="1100" dirty="0">
+              <a:rPr lang="en-US" sz="1050" dirty="0">
                 <a:solidFill>
                   <a:srgbClr val="6C4CFF"/>
                 </a:solidFill>
@@ -5474,156 +5558,30 @@
                 <a:ea typeface="Pretendard" pitchFamily="34" charset="-122"/>
                 <a:cs typeface="Pretendard" pitchFamily="34" charset="-120"/>
               </a:rPr>
-              <a:t>4-1 ~ 4-17</a:t>
-            </a:r>
-            <a:endParaRPr lang="en-US" sz="1100" dirty="0"/>
-          </a:p>
-        </p:txBody>
-      </p:sp>
-      <p:sp>
-        <p:nvSpPr>
-          <p:cNvPr id="24" name="Text 22"/>
-          <p:cNvSpPr/>
-          <p:nvPr/>
-        </p:nvSpPr>
-        <p:spPr>
-          <a:xfrm>
-            <a:off x="1069848" y="5294376"/>
-            <a:ext cx="3593592" cy="301752"/>
-          </a:xfrm>
-          <a:prstGeom prst="rect">
-            <a:avLst/>
-          </a:prstGeom>
-          <a:noFill/>
-          <a:ln/>
-        </p:spPr>
-        <p:txBody>
-          <a:bodyPr wrap="square" lIns="0" tIns="0" rIns="0" bIns="0" rtlCol="0" anchor="ctr"/>
-          <a:lstStyle/>
-          <a:p>
-            <a:pPr algn="l" indent="0" marL="0">
-              <a:lnSpc>
-                <a:spcPct val="100000"/>
-              </a:lnSpc>
-              <a:buNone/>
-            </a:pPr>
-            <a:r>
-              <a:rPr lang="en-US" sz="1150" dirty="0">
-                <a:solidFill>
-                  <a:srgbClr val="1D1D1F"/>
-                </a:solidFill>
-                <a:latin typeface="Pretendard Medium" pitchFamily="34" charset="0"/>
-                <a:ea typeface="Pretendard Medium" pitchFamily="34" charset="-122"/>
-                <a:cs typeface="Pretendard Medium" pitchFamily="34" charset="-120"/>
-              </a:rPr>
-              <a:t>     └─ 5. 신규 기획 가이드/</a:t>
-            </a:r>
-            <a:endParaRPr lang="en-US" sz="1150" dirty="0"/>
-          </a:p>
-        </p:txBody>
-      </p:sp>
-      <p:sp>
-        <p:nvSpPr>
-          <p:cNvPr id="25" name="Text 23"/>
-          <p:cNvSpPr/>
-          <p:nvPr/>
-        </p:nvSpPr>
-        <p:spPr>
-          <a:xfrm>
-            <a:off x="4754880" y="5294376"/>
-            <a:ext cx="2075688" cy="301752"/>
-          </a:xfrm>
-          <a:prstGeom prst="rect">
-            <a:avLst/>
-          </a:prstGeom>
-          <a:noFill/>
-          <a:ln/>
-        </p:spPr>
-        <p:txBody>
-          <a:bodyPr wrap="square" lIns="0" tIns="0" rIns="0" bIns="0" rtlCol="0" anchor="ctr"/>
-          <a:lstStyle/>
-          <a:p>
-            <a:pPr algn="l" indent="0" marL="0">
-              <a:lnSpc>
-                <a:spcPct val="100000"/>
-              </a:lnSpc>
-              <a:buNone/>
-            </a:pPr>
-            <a:r>
-              <a:rPr lang="en-US" sz="1100" dirty="0">
-                <a:solidFill>
-                  <a:srgbClr val="6C4CFF"/>
-                </a:solidFill>
-                <a:latin typeface="Pretendard" pitchFamily="34" charset="0"/>
-                <a:ea typeface="Pretendard" pitchFamily="34" charset="-122"/>
-                <a:cs typeface="Pretendard" pitchFamily="34" charset="-120"/>
-              </a:rPr>
-              <a:t>5-1 ~ 5-5</a:t>
-            </a:r>
-            <a:endParaRPr lang="en-US" sz="1100" dirty="0"/>
-          </a:p>
-        </p:txBody>
-      </p:sp>
-      <p:sp>
-        <p:nvSpPr>
-          <p:cNvPr id="26" name="Text 24"/>
-          <p:cNvSpPr/>
-          <p:nvPr/>
-        </p:nvSpPr>
-        <p:spPr>
-          <a:xfrm>
-            <a:off x="7360920" y="2395728"/>
-            <a:ext cx="4053535" cy="274320"/>
-          </a:xfrm>
-          <a:prstGeom prst="rect">
-            <a:avLst/>
-          </a:prstGeom>
-          <a:noFill/>
-          <a:ln/>
-        </p:spPr>
-        <p:txBody>
-          <a:bodyPr wrap="square" lIns="0" tIns="0" rIns="0" bIns="0" rtlCol="0" anchor="t"/>
-          <a:lstStyle/>
-          <a:p>
-            <a:pPr algn="l" indent="0" marL="0">
-              <a:lnSpc>
-                <a:spcPct val="130000"/>
-              </a:lnSpc>
-              <a:buNone/>
-            </a:pPr>
-            <a:r>
-              <a:rPr lang="en-US" sz="1300" dirty="0">
-                <a:solidFill>
-                  <a:srgbClr val="6C4CFF"/>
-                </a:solidFill>
-                <a:latin typeface="Pretendard SemiBold" pitchFamily="34" charset="0"/>
-                <a:ea typeface="Pretendard SemiBold" pitchFamily="34" charset="-122"/>
-                <a:cs typeface="Pretendard SemiBold" pitchFamily="34" charset="-120"/>
-              </a:rPr>
-              <a:t>이 볼트에서 이렇게 말하면</a:t>
-            </a:r>
-            <a:endParaRPr lang="en-US" sz="1300" dirty="0"/>
-          </a:p>
-        </p:txBody>
-      </p:sp>
-      <p:sp>
-        <p:nvSpPr>
-          <p:cNvPr id="27" name="Shape 25"/>
-          <p:cNvSpPr/>
-          <p:nvPr/>
-        </p:nvSpPr>
-        <p:spPr>
-          <a:xfrm>
-            <a:off x="7360920" y="2834640"/>
-            <a:ext cx="4053535" cy="896112"/>
+              <a:t>제작 5종</a:t>
+            </a:r>
+            <a:endParaRPr lang="en-US" sz="1050" dirty="0"/>
+          </a:p>
+        </p:txBody>
+      </p:sp>
+      <p:sp>
+        <p:nvSpPr>
+          <p:cNvPr id="26" name="Shape 24"/>
+          <p:cNvSpPr/>
+          <p:nvPr/>
+        </p:nvSpPr>
+        <p:spPr>
+          <a:xfrm>
+            <a:off x="5989320" y="2377440"/>
+            <a:ext cx="5425135" cy="3611880"/>
           </a:xfrm>
           <a:prstGeom prst="roundRect">
             <a:avLst>
-              <a:gd name="adj" fmla="val 10204"/>
+              <a:gd name="adj" fmla="val 3038"/>
             </a:avLst>
           </a:prstGeom>
           <a:solidFill>
-            <a:srgbClr val="FFFFFF"/>
+            <a:srgbClr val="F5F5F7"/>
           </a:solidFill>
           <a:ln w="12700">
             <a:solidFill>
@@ -5635,14 +5593,14 @@
       </p:sp>
       <p:sp>
         <p:nvSpPr>
-          <p:cNvPr id="28" name="Text 26"/>
-          <p:cNvSpPr/>
-          <p:nvPr/>
-        </p:nvSpPr>
-        <p:spPr>
-          <a:xfrm>
-            <a:off x="7580376" y="2999232"/>
-            <a:ext cx="3614623" cy="274320"/>
+          <p:cNvPr id="27" name="Text 25"/>
+          <p:cNvSpPr/>
+          <p:nvPr/>
+        </p:nvSpPr>
+        <p:spPr>
+          <a:xfrm>
+            <a:off x="6263640" y="2578608"/>
+            <a:ext cx="4876495" cy="274320"/>
           </a:xfrm>
           <a:prstGeom prst="rect">
             <a:avLst/>
@@ -5661,108 +5619,39 @@
               <a:buNone/>
             </a:pPr>
             <a:r>
-              <a:rPr lang="en-US" sz="1250" dirty="0">
-                <a:solidFill>
-                  <a:srgbClr val="1D1D1F"/>
-                </a:solidFill>
-                <a:latin typeface="Pretendard SemiBold" pitchFamily="34" charset="0"/>
-                <a:ea typeface="Pretendard SemiBold" pitchFamily="34" charset="-122"/>
-                <a:cs typeface="Pretendard SemiBold" pitchFamily="34" charset="-120"/>
-              </a:rPr>
-              <a:t>“아이콘 바꿔줘”</a:t>
-            </a:r>
-            <a:endParaRPr lang="en-US" sz="1250" dirty="0"/>
-          </a:p>
-        </p:txBody>
-      </p:sp>
-      <p:sp>
-        <p:nvSpPr>
-          <p:cNvPr id="29" name="Text 27"/>
-          <p:cNvSpPr/>
-          <p:nvPr/>
-        </p:nvSpPr>
-        <p:spPr>
-          <a:xfrm>
-            <a:off x="7580376" y="3328416"/>
-            <a:ext cx="3614623" cy="274320"/>
-          </a:xfrm>
-          <a:prstGeom prst="rect">
-            <a:avLst/>
-          </a:prstGeom>
-          <a:noFill/>
-          <a:ln/>
-        </p:spPr>
-        <p:txBody>
-          <a:bodyPr wrap="square" lIns="0" tIns="0" rIns="0" bIns="0" rtlCol="0" anchor="t"/>
-          <a:lstStyle/>
-          <a:p>
-            <a:pPr algn="l" indent="0" marL="0">
-              <a:lnSpc>
-                <a:spcPct val="130000"/>
-              </a:lnSpc>
-              <a:buNone/>
-            </a:pPr>
-            <a:r>
-              <a:rPr lang="en-US" sz="1100" dirty="0">
-                <a:solidFill>
-                  <a:srgbClr val="55555A"/>
+              <a:rPr lang="en-US" sz="1350" b="1" dirty="0">
+                <a:solidFill>
+                  <a:srgbClr val="6C4CFF"/>
                 </a:solidFill>
                 <a:latin typeface="Pretendard" pitchFamily="34" charset="0"/>
                 <a:ea typeface="Pretendard" pitchFamily="34" charset="-122"/>
                 <a:cs typeface="Pretendard" pitchFamily="34" charset="-120"/>
               </a:rPr>
-              <a:t>→ skills/cdbd-icon-use/</a:t>
-            </a:r>
-            <a:endParaRPr lang="en-US" sz="1100" dirty="0"/>
-          </a:p>
-        </p:txBody>
-      </p:sp>
-      <p:sp>
-        <p:nvSpPr>
-          <p:cNvPr id="30" name="Shape 28"/>
-          <p:cNvSpPr/>
-          <p:nvPr/>
-        </p:nvSpPr>
-        <p:spPr>
-          <a:xfrm>
-            <a:off x="7360920" y="3867912"/>
-            <a:ext cx="4053535" cy="896112"/>
-          </a:xfrm>
-          <a:prstGeom prst="roundRect">
-            <a:avLst>
-              <a:gd name="adj" fmla="val 10204"/>
-            </a:avLst>
-          </a:prstGeom>
-          <a:solidFill>
-            <a:srgbClr val="FFFFFF"/>
-          </a:solidFill>
-          <a:ln w="12700">
-            <a:solidFill>
-              <a:srgbClr val="E5E7EB"/>
-            </a:solidFill>
-            <a:prstDash val="solid"/>
-          </a:ln>
-        </p:spPr>
-      </p:sp>
-      <p:sp>
-        <p:nvSpPr>
-          <p:cNvPr id="31" name="Text 29"/>
-          <p:cNvSpPr/>
-          <p:nvPr/>
-        </p:nvSpPr>
-        <p:spPr>
-          <a:xfrm>
-            <a:off x="7580376" y="4032504"/>
-            <a:ext cx="3614623" cy="274320"/>
-          </a:xfrm>
-          <a:prstGeom prst="rect">
-            <a:avLst/>
-          </a:prstGeom>
-          <a:noFill/>
-          <a:ln/>
-        </p:spPr>
-        <p:txBody>
-          <a:bodyPr wrap="square" lIns="0" tIns="0" rIns="0" bIns="0" rtlCol="0" anchor="t"/>
+              <a:t>4. 카드 기능 정의/ — 카드 15종</a:t>
+            </a:r>
+            <a:endParaRPr lang="en-US" sz="1350" dirty="0"/>
+          </a:p>
+        </p:txBody>
+      </p:sp>
+      <p:sp>
+        <p:nvSpPr>
+          <p:cNvPr id="28" name="Text 26"/>
+          <p:cNvSpPr/>
+          <p:nvPr/>
+        </p:nvSpPr>
+        <p:spPr>
+          <a:xfrm>
+            <a:off x="6263640" y="3127248"/>
+            <a:ext cx="457200" cy="274320"/>
+          </a:xfrm>
+          <a:prstGeom prst="rect">
+            <a:avLst/>
+          </a:prstGeom>
+          <a:noFill/>
+          <a:ln/>
+        </p:spPr>
+        <p:txBody>
+          <a:bodyPr wrap="square" lIns="0" tIns="0" rIns="0" bIns="0" rtlCol="0" anchor="ctr"/>
           <a:lstStyle/>
           <a:p>
             <a:pPr algn="l" indent="0" marL="0">
@@ -5772,108 +5661,39 @@
               <a:buNone/>
             </a:pPr>
             <a:r>
-              <a:rPr lang="en-US" sz="1250" dirty="0">
-                <a:solidFill>
-                  <a:srgbClr val="1D1D1F"/>
-                </a:solidFill>
-                <a:latin typeface="Pretendard SemiBold" pitchFamily="34" charset="0"/>
-                <a:ea typeface="Pretendard SemiBold" pitchFamily="34" charset="-122"/>
-                <a:cs typeface="Pretendard SemiBold" pitchFamily="34" charset="-120"/>
-              </a:rPr>
-              <a:t>“카드 스펙 알려줘”</a:t>
-            </a:r>
-            <a:endParaRPr lang="en-US" sz="1250" dirty="0"/>
-          </a:p>
-        </p:txBody>
-      </p:sp>
-      <p:sp>
-        <p:nvSpPr>
-          <p:cNvPr id="32" name="Text 30"/>
-          <p:cNvSpPr/>
-          <p:nvPr/>
-        </p:nvSpPr>
-        <p:spPr>
-          <a:xfrm>
-            <a:off x="7580376" y="4361688"/>
-            <a:ext cx="3614623" cy="274320"/>
-          </a:xfrm>
-          <a:prstGeom prst="rect">
-            <a:avLst/>
-          </a:prstGeom>
-          <a:noFill/>
-          <a:ln/>
-        </p:spPr>
-        <p:txBody>
-          <a:bodyPr wrap="square" lIns="0" tIns="0" rIns="0" bIns="0" rtlCol="0" anchor="t"/>
-          <a:lstStyle/>
-          <a:p>
-            <a:pPr algn="l" indent="0" marL="0">
-              <a:lnSpc>
-                <a:spcPct val="130000"/>
-              </a:lnSpc>
-              <a:buNone/>
-            </a:pPr>
-            <a:r>
-              <a:rPr lang="en-US" sz="1100" dirty="0">
-                <a:solidFill>
-                  <a:srgbClr val="55555A"/>
+              <a:rPr lang="en-US" sz="1050" b="1" dirty="0">
+                <a:solidFill>
+                  <a:srgbClr val="6C4CFF"/>
                 </a:solidFill>
                 <a:latin typeface="Pretendard" pitchFamily="34" charset="0"/>
                 <a:ea typeface="Pretendard" pitchFamily="34" charset="-122"/>
                 <a:cs typeface="Pretendard" pitchFamily="34" charset="-120"/>
               </a:rPr>
-              <a:t>→ 4. 카드 기능 정의/</a:t>
-            </a:r>
-            <a:endParaRPr lang="en-US" sz="1100" dirty="0"/>
-          </a:p>
-        </p:txBody>
-      </p:sp>
-      <p:sp>
-        <p:nvSpPr>
-          <p:cNvPr id="33" name="Shape 31"/>
-          <p:cNvSpPr/>
-          <p:nvPr/>
-        </p:nvSpPr>
-        <p:spPr>
-          <a:xfrm>
-            <a:off x="7360920" y="4901184"/>
-            <a:ext cx="4053535" cy="896112"/>
-          </a:xfrm>
-          <a:prstGeom prst="roundRect">
-            <a:avLst>
-              <a:gd name="adj" fmla="val 10204"/>
-            </a:avLst>
-          </a:prstGeom>
-          <a:solidFill>
-            <a:srgbClr val="FFFFFF"/>
-          </a:solidFill>
-          <a:ln w="12700">
-            <a:solidFill>
-              <a:srgbClr val="E5E7EB"/>
-            </a:solidFill>
-            <a:prstDash val="solid"/>
-          </a:ln>
-        </p:spPr>
-      </p:sp>
-      <p:sp>
-        <p:nvSpPr>
-          <p:cNvPr id="34" name="Text 32"/>
-          <p:cNvSpPr/>
-          <p:nvPr/>
-        </p:nvSpPr>
-        <p:spPr>
-          <a:xfrm>
-            <a:off x="7580376" y="5065776"/>
-            <a:ext cx="3614623" cy="274320"/>
-          </a:xfrm>
-          <a:prstGeom prst="rect">
-            <a:avLst/>
-          </a:prstGeom>
-          <a:noFill/>
-          <a:ln/>
-        </p:spPr>
-        <p:txBody>
-          <a:bodyPr wrap="square" lIns="0" tIns="0" rIns="0" bIns="0" rtlCol="0" anchor="t"/>
+              <a:t>4-3</a:t>
+            </a:r>
+            <a:endParaRPr lang="en-US" sz="1050" dirty="0"/>
+          </a:p>
+        </p:txBody>
+      </p:sp>
+      <p:sp>
+        <p:nvSpPr>
+          <p:cNvPr id="29" name="Text 27"/>
+          <p:cNvSpPr/>
+          <p:nvPr/>
+        </p:nvSpPr>
+        <p:spPr>
+          <a:xfrm>
+            <a:off x="6720840" y="3127248"/>
+            <a:ext cx="1168298" cy="274320"/>
+          </a:xfrm>
+          <a:prstGeom prst="rect">
+            <a:avLst/>
+          </a:prstGeom>
+          <a:noFill/>
+          <a:ln/>
+        </p:spPr>
+        <p:txBody>
+          <a:bodyPr wrap="square" lIns="0" tIns="0" rIns="0" bIns="0" rtlCol="0" anchor="ctr"/>
           <a:lstStyle/>
           <a:p>
             <a:pPr algn="l" indent="0" marL="0">
@@ -5883,39 +5703,39 @@
               <a:buNone/>
             </a:pPr>
             <a:r>
-              <a:rPr lang="en-US" sz="1250" dirty="0">
+              <a:rPr lang="en-US" sz="1150" dirty="0">
                 <a:solidFill>
                   <a:srgbClr val="1D1D1F"/>
                 </a:solidFill>
-                <a:latin typeface="Pretendard SemiBold" pitchFamily="34" charset="0"/>
-                <a:ea typeface="Pretendard SemiBold" pitchFamily="34" charset="-122"/>
-                <a:cs typeface="Pretendard SemiBold" pitchFamily="34" charset="-120"/>
-              </a:rPr>
-              <a:t>“개발 문서 만들어줘”</a:t>
-            </a:r>
-            <a:endParaRPr lang="en-US" sz="1250" dirty="0"/>
-          </a:p>
-        </p:txBody>
-      </p:sp>
-      <p:sp>
-        <p:nvSpPr>
-          <p:cNvPr id="35" name="Text 33"/>
-          <p:cNvSpPr/>
-          <p:nvPr/>
-        </p:nvSpPr>
-        <p:spPr>
-          <a:xfrm>
-            <a:off x="7580376" y="5394960"/>
-            <a:ext cx="3614623" cy="274320"/>
-          </a:xfrm>
-          <a:prstGeom prst="rect">
-            <a:avLst/>
-          </a:prstGeom>
-          <a:noFill/>
-          <a:ln/>
-        </p:spPr>
-        <p:txBody>
-          <a:bodyPr wrap="square" lIns="0" tIns="0" rIns="0" bIns="0" rtlCol="0" anchor="t"/>
+                <a:latin typeface="Pretendard Medium" pitchFamily="34" charset="0"/>
+                <a:ea typeface="Pretendard Medium" pitchFamily="34" charset="-122"/>
+                <a:cs typeface="Pretendard Medium" pitchFamily="34" charset="-120"/>
+              </a:rPr>
+              <a:t>메뉴</a:t>
+            </a:r>
+            <a:endParaRPr lang="en-US" sz="1150" dirty="0"/>
+          </a:p>
+        </p:txBody>
+      </p:sp>
+      <p:sp>
+        <p:nvSpPr>
+          <p:cNvPr id="30" name="Text 28"/>
+          <p:cNvSpPr/>
+          <p:nvPr/>
+        </p:nvSpPr>
+        <p:spPr>
+          <a:xfrm>
+            <a:off x="7889138" y="3127248"/>
+            <a:ext cx="457200" cy="274320"/>
+          </a:xfrm>
+          <a:prstGeom prst="rect">
+            <a:avLst/>
+          </a:prstGeom>
+          <a:noFill/>
+          <a:ln/>
+        </p:spPr>
+        <p:txBody>
+          <a:bodyPr wrap="square" lIns="0" tIns="0" rIns="0" bIns="0" rtlCol="0" anchor="ctr"/>
           <a:lstStyle/>
           <a:p>
             <a:pPr algn="l" indent="0" marL="0">
@@ -5925,17 +5745,1193 @@
               <a:buNone/>
             </a:pPr>
             <a:r>
-              <a:rPr lang="en-US" sz="1100" dirty="0">
-                <a:solidFill>
-                  <a:srgbClr val="55555A"/>
+              <a:rPr lang="en-US" sz="1050" b="1" dirty="0">
+                <a:solidFill>
+                  <a:srgbClr val="6C4CFF"/>
                 </a:solidFill>
                 <a:latin typeface="Pretendard" pitchFamily="34" charset="0"/>
                 <a:ea typeface="Pretendard" pitchFamily="34" charset="-122"/>
                 <a:cs typeface="Pretendard" pitchFamily="34" charset="-120"/>
               </a:rPr>
-              <a:t>→ 5-5. 개발 문서 제작 가이드.md</a:t>
-            </a:r>
-            <a:endParaRPr lang="en-US" sz="1100" dirty="0"/>
+              <a:t>4-4</a:t>
+            </a:r>
+            <a:endParaRPr lang="en-US" sz="1050" dirty="0"/>
+          </a:p>
+        </p:txBody>
+      </p:sp>
+      <p:sp>
+        <p:nvSpPr>
+          <p:cNvPr id="31" name="Text 29"/>
+          <p:cNvSpPr/>
+          <p:nvPr/>
+        </p:nvSpPr>
+        <p:spPr>
+          <a:xfrm>
+            <a:off x="8346338" y="3127248"/>
+            <a:ext cx="1168298" cy="274320"/>
+          </a:xfrm>
+          <a:prstGeom prst="rect">
+            <a:avLst/>
+          </a:prstGeom>
+          <a:noFill/>
+          <a:ln/>
+        </p:spPr>
+        <p:txBody>
+          <a:bodyPr wrap="square" lIns="0" tIns="0" rIns="0" bIns="0" rtlCol="0" anchor="ctr"/>
+          <a:lstStyle/>
+          <a:p>
+            <a:pPr algn="l" indent="0" marL="0">
+              <a:lnSpc>
+                <a:spcPct val="130000"/>
+              </a:lnSpc>
+              <a:buNone/>
+            </a:pPr>
+            <a:r>
+              <a:rPr lang="en-US" sz="1150" dirty="0">
+                <a:solidFill>
+                  <a:srgbClr val="1D1D1F"/>
+                </a:solidFill>
+                <a:latin typeface="Pretendard Medium" pitchFamily="34" charset="0"/>
+                <a:ea typeface="Pretendard Medium" pitchFamily="34" charset="-122"/>
+                <a:cs typeface="Pretendard Medium" pitchFamily="34" charset="-120"/>
+              </a:rPr>
+              <a:t>프로필</a:t>
+            </a:r>
+            <a:endParaRPr lang="en-US" sz="1150" dirty="0"/>
+          </a:p>
+        </p:txBody>
+      </p:sp>
+      <p:sp>
+        <p:nvSpPr>
+          <p:cNvPr id="32" name="Text 30"/>
+          <p:cNvSpPr/>
+          <p:nvPr/>
+        </p:nvSpPr>
+        <p:spPr>
+          <a:xfrm>
+            <a:off x="9514637" y="3127248"/>
+            <a:ext cx="457200" cy="274320"/>
+          </a:xfrm>
+          <a:prstGeom prst="rect">
+            <a:avLst/>
+          </a:prstGeom>
+          <a:noFill/>
+          <a:ln/>
+        </p:spPr>
+        <p:txBody>
+          <a:bodyPr wrap="square" lIns="0" tIns="0" rIns="0" bIns="0" rtlCol="0" anchor="ctr"/>
+          <a:lstStyle/>
+          <a:p>
+            <a:pPr algn="l" indent="0" marL="0">
+              <a:lnSpc>
+                <a:spcPct val="130000"/>
+              </a:lnSpc>
+              <a:buNone/>
+            </a:pPr>
+            <a:r>
+              <a:rPr lang="en-US" sz="1050" b="1" dirty="0">
+                <a:solidFill>
+                  <a:srgbClr val="6C4CFF"/>
+                </a:solidFill>
+                <a:latin typeface="Pretendard" pitchFamily="34" charset="0"/>
+                <a:ea typeface="Pretendard" pitchFamily="34" charset="-122"/>
+                <a:cs typeface="Pretendard" pitchFamily="34" charset="-120"/>
+              </a:rPr>
+              <a:t>4-5</a:t>
+            </a:r>
+            <a:endParaRPr lang="en-US" sz="1050" dirty="0"/>
+          </a:p>
+        </p:txBody>
+      </p:sp>
+      <p:sp>
+        <p:nvSpPr>
+          <p:cNvPr id="33" name="Text 31"/>
+          <p:cNvSpPr/>
+          <p:nvPr/>
+        </p:nvSpPr>
+        <p:spPr>
+          <a:xfrm>
+            <a:off x="9971837" y="3127248"/>
+            <a:ext cx="1168298" cy="274320"/>
+          </a:xfrm>
+          <a:prstGeom prst="rect">
+            <a:avLst/>
+          </a:prstGeom>
+          <a:noFill/>
+          <a:ln/>
+        </p:spPr>
+        <p:txBody>
+          <a:bodyPr wrap="square" lIns="0" tIns="0" rIns="0" bIns="0" rtlCol="0" anchor="ctr"/>
+          <a:lstStyle/>
+          <a:p>
+            <a:pPr algn="l" indent="0" marL="0">
+              <a:lnSpc>
+                <a:spcPct val="130000"/>
+              </a:lnSpc>
+              <a:buNone/>
+            </a:pPr>
+            <a:r>
+              <a:rPr lang="en-US" sz="1150" dirty="0">
+                <a:solidFill>
+                  <a:srgbClr val="1D1D1F"/>
+                </a:solidFill>
+                <a:latin typeface="Pretendard Medium" pitchFamily="34" charset="0"/>
+                <a:ea typeface="Pretendard Medium" pitchFamily="34" charset="-122"/>
+                <a:cs typeface="Pretendard Medium" pitchFamily="34" charset="-120"/>
+              </a:rPr>
+              <a:t>텍스트</a:t>
+            </a:r>
+            <a:endParaRPr lang="en-US" sz="1150" dirty="0"/>
+          </a:p>
+        </p:txBody>
+      </p:sp>
+      <p:sp>
+        <p:nvSpPr>
+          <p:cNvPr id="34" name="Text 32"/>
+          <p:cNvSpPr/>
+          <p:nvPr/>
+        </p:nvSpPr>
+        <p:spPr>
+          <a:xfrm>
+            <a:off x="6263640" y="3630168"/>
+            <a:ext cx="457200" cy="274320"/>
+          </a:xfrm>
+          <a:prstGeom prst="rect">
+            <a:avLst/>
+          </a:prstGeom>
+          <a:noFill/>
+          <a:ln/>
+        </p:spPr>
+        <p:txBody>
+          <a:bodyPr wrap="square" lIns="0" tIns="0" rIns="0" bIns="0" rtlCol="0" anchor="ctr"/>
+          <a:lstStyle/>
+          <a:p>
+            <a:pPr algn="l" indent="0" marL="0">
+              <a:lnSpc>
+                <a:spcPct val="130000"/>
+              </a:lnSpc>
+              <a:buNone/>
+            </a:pPr>
+            <a:r>
+              <a:rPr lang="en-US" sz="1050" b="1" dirty="0">
+                <a:solidFill>
+                  <a:srgbClr val="6C4CFF"/>
+                </a:solidFill>
+                <a:latin typeface="Pretendard" pitchFamily="34" charset="0"/>
+                <a:ea typeface="Pretendard" pitchFamily="34" charset="-122"/>
+                <a:cs typeface="Pretendard" pitchFamily="34" charset="-120"/>
+              </a:rPr>
+              <a:t>4-6</a:t>
+            </a:r>
+            <a:endParaRPr lang="en-US" sz="1050" dirty="0"/>
+          </a:p>
+        </p:txBody>
+      </p:sp>
+      <p:sp>
+        <p:nvSpPr>
+          <p:cNvPr id="35" name="Text 33"/>
+          <p:cNvSpPr/>
+          <p:nvPr/>
+        </p:nvSpPr>
+        <p:spPr>
+          <a:xfrm>
+            <a:off x="6720840" y="3630168"/>
+            <a:ext cx="1168298" cy="274320"/>
+          </a:xfrm>
+          <a:prstGeom prst="rect">
+            <a:avLst/>
+          </a:prstGeom>
+          <a:noFill/>
+          <a:ln/>
+        </p:spPr>
+        <p:txBody>
+          <a:bodyPr wrap="square" lIns="0" tIns="0" rIns="0" bIns="0" rtlCol="0" anchor="ctr"/>
+          <a:lstStyle/>
+          <a:p>
+            <a:pPr algn="l" indent="0" marL="0">
+              <a:lnSpc>
+                <a:spcPct val="130000"/>
+              </a:lnSpc>
+              <a:buNone/>
+            </a:pPr>
+            <a:r>
+              <a:rPr lang="en-US" sz="1150" dirty="0">
+                <a:solidFill>
+                  <a:srgbClr val="1D1D1F"/>
+                </a:solidFill>
+                <a:latin typeface="Pretendard Medium" pitchFamily="34" charset="0"/>
+                <a:ea typeface="Pretendard Medium" pitchFamily="34" charset="-122"/>
+                <a:cs typeface="Pretendard Medium" pitchFamily="34" charset="-120"/>
+              </a:rPr>
+              <a:t>이미지</a:t>
+            </a:r>
+            <a:endParaRPr lang="en-US" sz="1150" dirty="0"/>
+          </a:p>
+        </p:txBody>
+      </p:sp>
+      <p:sp>
+        <p:nvSpPr>
+          <p:cNvPr id="36" name="Text 34"/>
+          <p:cNvSpPr/>
+          <p:nvPr/>
+        </p:nvSpPr>
+        <p:spPr>
+          <a:xfrm>
+            <a:off x="7889138" y="3630168"/>
+            <a:ext cx="457200" cy="274320"/>
+          </a:xfrm>
+          <a:prstGeom prst="rect">
+            <a:avLst/>
+          </a:prstGeom>
+          <a:noFill/>
+          <a:ln/>
+        </p:spPr>
+        <p:txBody>
+          <a:bodyPr wrap="square" lIns="0" tIns="0" rIns="0" bIns="0" rtlCol="0" anchor="ctr"/>
+          <a:lstStyle/>
+          <a:p>
+            <a:pPr algn="l" indent="0" marL="0">
+              <a:lnSpc>
+                <a:spcPct val="130000"/>
+              </a:lnSpc>
+              <a:buNone/>
+            </a:pPr>
+            <a:r>
+              <a:rPr lang="en-US" sz="1050" b="1" dirty="0">
+                <a:solidFill>
+                  <a:srgbClr val="6C4CFF"/>
+                </a:solidFill>
+                <a:latin typeface="Pretendard" pitchFamily="34" charset="0"/>
+                <a:ea typeface="Pretendard" pitchFamily="34" charset="-122"/>
+                <a:cs typeface="Pretendard" pitchFamily="34" charset="-120"/>
+              </a:rPr>
+              <a:t>4-7</a:t>
+            </a:r>
+            <a:endParaRPr lang="en-US" sz="1050" dirty="0"/>
+          </a:p>
+        </p:txBody>
+      </p:sp>
+      <p:sp>
+        <p:nvSpPr>
+          <p:cNvPr id="37" name="Text 35"/>
+          <p:cNvSpPr/>
+          <p:nvPr/>
+        </p:nvSpPr>
+        <p:spPr>
+          <a:xfrm>
+            <a:off x="8346338" y="3630168"/>
+            <a:ext cx="1168298" cy="274320"/>
+          </a:xfrm>
+          <a:prstGeom prst="rect">
+            <a:avLst/>
+          </a:prstGeom>
+          <a:noFill/>
+          <a:ln/>
+        </p:spPr>
+        <p:txBody>
+          <a:bodyPr wrap="square" lIns="0" tIns="0" rIns="0" bIns="0" rtlCol="0" anchor="ctr"/>
+          <a:lstStyle/>
+          <a:p>
+            <a:pPr algn="l" indent="0" marL="0">
+              <a:lnSpc>
+                <a:spcPct val="130000"/>
+              </a:lnSpc>
+              <a:buNone/>
+            </a:pPr>
+            <a:r>
+              <a:rPr lang="en-US" sz="1150" dirty="0">
+                <a:solidFill>
+                  <a:srgbClr val="1D1D1F"/>
+                </a:solidFill>
+                <a:latin typeface="Pretendard Medium" pitchFamily="34" charset="0"/>
+                <a:ea typeface="Pretendard Medium" pitchFamily="34" charset="-122"/>
+                <a:cs typeface="Pretendard Medium" pitchFamily="34" charset="-120"/>
+              </a:rPr>
+              <a:t>갤러리</a:t>
+            </a:r>
+            <a:endParaRPr lang="en-US" sz="1150" dirty="0"/>
+          </a:p>
+        </p:txBody>
+      </p:sp>
+      <p:sp>
+        <p:nvSpPr>
+          <p:cNvPr id="38" name="Text 36"/>
+          <p:cNvSpPr/>
+          <p:nvPr/>
+        </p:nvSpPr>
+        <p:spPr>
+          <a:xfrm>
+            <a:off x="9514637" y="3630168"/>
+            <a:ext cx="457200" cy="274320"/>
+          </a:xfrm>
+          <a:prstGeom prst="rect">
+            <a:avLst/>
+          </a:prstGeom>
+          <a:noFill/>
+          <a:ln/>
+        </p:spPr>
+        <p:txBody>
+          <a:bodyPr wrap="square" lIns="0" tIns="0" rIns="0" bIns="0" rtlCol="0" anchor="ctr"/>
+          <a:lstStyle/>
+          <a:p>
+            <a:pPr algn="l" indent="0" marL="0">
+              <a:lnSpc>
+                <a:spcPct val="130000"/>
+              </a:lnSpc>
+              <a:buNone/>
+            </a:pPr>
+            <a:r>
+              <a:rPr lang="en-US" sz="1050" b="1" dirty="0">
+                <a:solidFill>
+                  <a:srgbClr val="6C4CFF"/>
+                </a:solidFill>
+                <a:latin typeface="Pretendard" pitchFamily="34" charset="0"/>
+                <a:ea typeface="Pretendard" pitchFamily="34" charset="-122"/>
+                <a:cs typeface="Pretendard" pitchFamily="34" charset="-120"/>
+              </a:rPr>
+              <a:t>4-8</a:t>
+            </a:r>
+            <a:endParaRPr lang="en-US" sz="1050" dirty="0"/>
+          </a:p>
+        </p:txBody>
+      </p:sp>
+      <p:sp>
+        <p:nvSpPr>
+          <p:cNvPr id="39" name="Text 37"/>
+          <p:cNvSpPr/>
+          <p:nvPr/>
+        </p:nvSpPr>
+        <p:spPr>
+          <a:xfrm>
+            <a:off x="9971837" y="3630168"/>
+            <a:ext cx="1168298" cy="274320"/>
+          </a:xfrm>
+          <a:prstGeom prst="rect">
+            <a:avLst/>
+          </a:prstGeom>
+          <a:noFill/>
+          <a:ln/>
+        </p:spPr>
+        <p:txBody>
+          <a:bodyPr wrap="square" lIns="0" tIns="0" rIns="0" bIns="0" rtlCol="0" anchor="ctr"/>
+          <a:lstStyle/>
+          <a:p>
+            <a:pPr algn="l" indent="0" marL="0">
+              <a:lnSpc>
+                <a:spcPct val="130000"/>
+              </a:lnSpc>
+              <a:buNone/>
+            </a:pPr>
+            <a:r>
+              <a:rPr lang="en-US" sz="1150" dirty="0">
+                <a:solidFill>
+                  <a:srgbClr val="1D1D1F"/>
+                </a:solidFill>
+                <a:latin typeface="Pretendard Medium" pitchFamily="34" charset="0"/>
+                <a:ea typeface="Pretendard Medium" pitchFamily="34" charset="-122"/>
+                <a:cs typeface="Pretendard Medium" pitchFamily="34" charset="-120"/>
+              </a:rPr>
+              <a:t>유튜브</a:t>
+            </a:r>
+            <a:endParaRPr lang="en-US" sz="1150" dirty="0"/>
+          </a:p>
+        </p:txBody>
+      </p:sp>
+      <p:sp>
+        <p:nvSpPr>
+          <p:cNvPr id="40" name="Text 38"/>
+          <p:cNvSpPr/>
+          <p:nvPr/>
+        </p:nvSpPr>
+        <p:spPr>
+          <a:xfrm>
+            <a:off x="6263640" y="4133088"/>
+            <a:ext cx="457200" cy="274320"/>
+          </a:xfrm>
+          <a:prstGeom prst="rect">
+            <a:avLst/>
+          </a:prstGeom>
+          <a:noFill/>
+          <a:ln/>
+        </p:spPr>
+        <p:txBody>
+          <a:bodyPr wrap="square" lIns="0" tIns="0" rIns="0" bIns="0" rtlCol="0" anchor="ctr"/>
+          <a:lstStyle/>
+          <a:p>
+            <a:pPr algn="l" indent="0" marL="0">
+              <a:lnSpc>
+                <a:spcPct val="130000"/>
+              </a:lnSpc>
+              <a:buNone/>
+            </a:pPr>
+            <a:r>
+              <a:rPr lang="en-US" sz="1050" b="1" dirty="0">
+                <a:solidFill>
+                  <a:srgbClr val="6C4CFF"/>
+                </a:solidFill>
+                <a:latin typeface="Pretendard" pitchFamily="34" charset="0"/>
+                <a:ea typeface="Pretendard" pitchFamily="34" charset="-122"/>
+                <a:cs typeface="Pretendard" pitchFamily="34" charset="-120"/>
+              </a:rPr>
+              <a:t>4-9</a:t>
+            </a:r>
+            <a:endParaRPr lang="en-US" sz="1050" dirty="0"/>
+          </a:p>
+        </p:txBody>
+      </p:sp>
+      <p:sp>
+        <p:nvSpPr>
+          <p:cNvPr id="41" name="Text 39"/>
+          <p:cNvSpPr/>
+          <p:nvPr/>
+        </p:nvSpPr>
+        <p:spPr>
+          <a:xfrm>
+            <a:off x="6720840" y="4133088"/>
+            <a:ext cx="1168298" cy="274320"/>
+          </a:xfrm>
+          <a:prstGeom prst="rect">
+            <a:avLst/>
+          </a:prstGeom>
+          <a:noFill/>
+          <a:ln/>
+        </p:spPr>
+        <p:txBody>
+          <a:bodyPr wrap="square" lIns="0" tIns="0" rIns="0" bIns="0" rtlCol="0" anchor="ctr"/>
+          <a:lstStyle/>
+          <a:p>
+            <a:pPr algn="l" indent="0" marL="0">
+              <a:lnSpc>
+                <a:spcPct val="130000"/>
+              </a:lnSpc>
+              <a:buNone/>
+            </a:pPr>
+            <a:r>
+              <a:rPr lang="en-US" sz="1150" dirty="0">
+                <a:solidFill>
+                  <a:srgbClr val="1D1D1F"/>
+                </a:solidFill>
+                <a:latin typeface="Pretendard Medium" pitchFamily="34" charset="0"/>
+                <a:ea typeface="Pretendard Medium" pitchFamily="34" charset="-122"/>
+                <a:cs typeface="Pretendard Medium" pitchFamily="34" charset="-120"/>
+              </a:rPr>
+              <a:t>버튼</a:t>
+            </a:r>
+            <a:endParaRPr lang="en-US" sz="1150" dirty="0"/>
+          </a:p>
+        </p:txBody>
+      </p:sp>
+      <p:sp>
+        <p:nvSpPr>
+          <p:cNvPr id="42" name="Text 40"/>
+          <p:cNvSpPr/>
+          <p:nvPr/>
+        </p:nvSpPr>
+        <p:spPr>
+          <a:xfrm>
+            <a:off x="7889138" y="4133088"/>
+            <a:ext cx="457200" cy="274320"/>
+          </a:xfrm>
+          <a:prstGeom prst="rect">
+            <a:avLst/>
+          </a:prstGeom>
+          <a:noFill/>
+          <a:ln/>
+        </p:spPr>
+        <p:txBody>
+          <a:bodyPr wrap="square" lIns="0" tIns="0" rIns="0" bIns="0" rtlCol="0" anchor="ctr"/>
+          <a:lstStyle/>
+          <a:p>
+            <a:pPr algn="l" indent="0" marL="0">
+              <a:lnSpc>
+                <a:spcPct val="130000"/>
+              </a:lnSpc>
+              <a:buNone/>
+            </a:pPr>
+            <a:r>
+              <a:rPr lang="en-US" sz="1050" b="1" dirty="0">
+                <a:solidFill>
+                  <a:srgbClr val="6C4CFF"/>
+                </a:solidFill>
+                <a:latin typeface="Pretendard" pitchFamily="34" charset="0"/>
+                <a:ea typeface="Pretendard" pitchFamily="34" charset="-122"/>
+                <a:cs typeface="Pretendard" pitchFamily="34" charset="-120"/>
+              </a:rPr>
+              <a:t>4-10</a:t>
+            </a:r>
+            <a:endParaRPr lang="en-US" sz="1050" dirty="0"/>
+          </a:p>
+        </p:txBody>
+      </p:sp>
+      <p:sp>
+        <p:nvSpPr>
+          <p:cNvPr id="43" name="Text 41"/>
+          <p:cNvSpPr/>
+          <p:nvPr/>
+        </p:nvSpPr>
+        <p:spPr>
+          <a:xfrm>
+            <a:off x="8346338" y="4133088"/>
+            <a:ext cx="1168298" cy="274320"/>
+          </a:xfrm>
+          <a:prstGeom prst="rect">
+            <a:avLst/>
+          </a:prstGeom>
+          <a:noFill/>
+          <a:ln/>
+        </p:spPr>
+        <p:txBody>
+          <a:bodyPr wrap="square" lIns="0" tIns="0" rIns="0" bIns="0" rtlCol="0" anchor="ctr"/>
+          <a:lstStyle/>
+          <a:p>
+            <a:pPr algn="l" indent="0" marL="0">
+              <a:lnSpc>
+                <a:spcPct val="130000"/>
+              </a:lnSpc>
+              <a:buNone/>
+            </a:pPr>
+            <a:r>
+              <a:rPr lang="en-US" sz="1150" dirty="0">
+                <a:solidFill>
+                  <a:srgbClr val="1D1D1F"/>
+                </a:solidFill>
+                <a:latin typeface="Pretendard Medium" pitchFamily="34" charset="0"/>
+                <a:ea typeface="Pretendard Medium" pitchFamily="34" charset="-122"/>
+                <a:cs typeface="Pretendard Medium" pitchFamily="34" charset="-120"/>
+              </a:rPr>
+              <a:t>질문·답변</a:t>
+            </a:r>
+            <a:endParaRPr lang="en-US" sz="1150" dirty="0"/>
+          </a:p>
+        </p:txBody>
+      </p:sp>
+      <p:sp>
+        <p:nvSpPr>
+          <p:cNvPr id="44" name="Text 42"/>
+          <p:cNvSpPr/>
+          <p:nvPr/>
+        </p:nvSpPr>
+        <p:spPr>
+          <a:xfrm>
+            <a:off x="9514637" y="4133088"/>
+            <a:ext cx="457200" cy="274320"/>
+          </a:xfrm>
+          <a:prstGeom prst="rect">
+            <a:avLst/>
+          </a:prstGeom>
+          <a:noFill/>
+          <a:ln/>
+        </p:spPr>
+        <p:txBody>
+          <a:bodyPr wrap="square" lIns="0" tIns="0" rIns="0" bIns="0" rtlCol="0" anchor="ctr"/>
+          <a:lstStyle/>
+          <a:p>
+            <a:pPr algn="l" indent="0" marL="0">
+              <a:lnSpc>
+                <a:spcPct val="130000"/>
+              </a:lnSpc>
+              <a:buNone/>
+            </a:pPr>
+            <a:r>
+              <a:rPr lang="en-US" sz="1050" b="1" dirty="0">
+                <a:solidFill>
+                  <a:srgbClr val="6C4CFF"/>
+                </a:solidFill>
+                <a:latin typeface="Pretendard" pitchFamily="34" charset="0"/>
+                <a:ea typeface="Pretendard" pitchFamily="34" charset="-122"/>
+                <a:cs typeface="Pretendard" pitchFamily="34" charset="-120"/>
+              </a:rPr>
+              <a:t>4-11</a:t>
+            </a:r>
+            <a:endParaRPr lang="en-US" sz="1050" dirty="0"/>
+          </a:p>
+        </p:txBody>
+      </p:sp>
+      <p:sp>
+        <p:nvSpPr>
+          <p:cNvPr id="45" name="Text 43"/>
+          <p:cNvSpPr/>
+          <p:nvPr/>
+        </p:nvSpPr>
+        <p:spPr>
+          <a:xfrm>
+            <a:off x="9971837" y="4133088"/>
+            <a:ext cx="1168298" cy="274320"/>
+          </a:xfrm>
+          <a:prstGeom prst="rect">
+            <a:avLst/>
+          </a:prstGeom>
+          <a:noFill/>
+          <a:ln/>
+        </p:spPr>
+        <p:txBody>
+          <a:bodyPr wrap="square" lIns="0" tIns="0" rIns="0" bIns="0" rtlCol="0" anchor="ctr"/>
+          <a:lstStyle/>
+          <a:p>
+            <a:pPr algn="l" indent="0" marL="0">
+              <a:lnSpc>
+                <a:spcPct val="130000"/>
+              </a:lnSpc>
+              <a:buNone/>
+            </a:pPr>
+            <a:r>
+              <a:rPr lang="en-US" sz="1150" dirty="0">
+                <a:solidFill>
+                  <a:srgbClr val="1D1D1F"/>
+                </a:solidFill>
+                <a:latin typeface="Pretendard Medium" pitchFamily="34" charset="0"/>
+                <a:ea typeface="Pretendard Medium" pitchFamily="34" charset="-122"/>
+                <a:cs typeface="Pretendard Medium" pitchFamily="34" charset="-120"/>
+              </a:rPr>
+              <a:t>예약</a:t>
+            </a:r>
+            <a:endParaRPr lang="en-US" sz="1150" dirty="0"/>
+          </a:p>
+        </p:txBody>
+      </p:sp>
+      <p:sp>
+        <p:nvSpPr>
+          <p:cNvPr id="46" name="Text 44"/>
+          <p:cNvSpPr/>
+          <p:nvPr/>
+        </p:nvSpPr>
+        <p:spPr>
+          <a:xfrm>
+            <a:off x="6263640" y="4636008"/>
+            <a:ext cx="457200" cy="274320"/>
+          </a:xfrm>
+          <a:prstGeom prst="rect">
+            <a:avLst/>
+          </a:prstGeom>
+          <a:noFill/>
+          <a:ln/>
+        </p:spPr>
+        <p:txBody>
+          <a:bodyPr wrap="square" lIns="0" tIns="0" rIns="0" bIns="0" rtlCol="0" anchor="ctr"/>
+          <a:lstStyle/>
+          <a:p>
+            <a:pPr algn="l" indent="0" marL="0">
+              <a:lnSpc>
+                <a:spcPct val="130000"/>
+              </a:lnSpc>
+              <a:buNone/>
+            </a:pPr>
+            <a:r>
+              <a:rPr lang="en-US" sz="1050" b="1" dirty="0">
+                <a:solidFill>
+                  <a:srgbClr val="6C4CFF"/>
+                </a:solidFill>
+                <a:latin typeface="Pretendard" pitchFamily="34" charset="0"/>
+                <a:ea typeface="Pretendard" pitchFamily="34" charset="-122"/>
+                <a:cs typeface="Pretendard" pitchFamily="34" charset="-120"/>
+              </a:rPr>
+              <a:t>4-12</a:t>
+            </a:r>
+            <a:endParaRPr lang="en-US" sz="1050" dirty="0"/>
+          </a:p>
+        </p:txBody>
+      </p:sp>
+      <p:sp>
+        <p:nvSpPr>
+          <p:cNvPr id="47" name="Text 45"/>
+          <p:cNvSpPr/>
+          <p:nvPr/>
+        </p:nvSpPr>
+        <p:spPr>
+          <a:xfrm>
+            <a:off x="6720840" y="4636008"/>
+            <a:ext cx="1168298" cy="274320"/>
+          </a:xfrm>
+          <a:prstGeom prst="rect">
+            <a:avLst/>
+          </a:prstGeom>
+          <a:noFill/>
+          <a:ln/>
+        </p:spPr>
+        <p:txBody>
+          <a:bodyPr wrap="square" lIns="0" tIns="0" rIns="0" bIns="0" rtlCol="0" anchor="ctr"/>
+          <a:lstStyle/>
+          <a:p>
+            <a:pPr algn="l" indent="0" marL="0">
+              <a:lnSpc>
+                <a:spcPct val="130000"/>
+              </a:lnSpc>
+              <a:buNone/>
+            </a:pPr>
+            <a:r>
+              <a:rPr lang="en-US" sz="1150" dirty="0">
+                <a:solidFill>
+                  <a:srgbClr val="1D1D1F"/>
+                </a:solidFill>
+                <a:latin typeface="Pretendard Medium" pitchFamily="34" charset="0"/>
+                <a:ea typeface="Pretendard Medium" pitchFamily="34" charset="-122"/>
+                <a:cs typeface="Pretendard Medium" pitchFamily="34" charset="-120"/>
+              </a:rPr>
+              <a:t>상품</a:t>
+            </a:r>
+            <a:endParaRPr lang="en-US" sz="1150" dirty="0"/>
+          </a:p>
+        </p:txBody>
+      </p:sp>
+      <p:sp>
+        <p:nvSpPr>
+          <p:cNvPr id="48" name="Text 46"/>
+          <p:cNvSpPr/>
+          <p:nvPr/>
+        </p:nvSpPr>
+        <p:spPr>
+          <a:xfrm>
+            <a:off x="7889138" y="4636008"/>
+            <a:ext cx="457200" cy="274320"/>
+          </a:xfrm>
+          <a:prstGeom prst="rect">
+            <a:avLst/>
+          </a:prstGeom>
+          <a:noFill/>
+          <a:ln/>
+        </p:spPr>
+        <p:txBody>
+          <a:bodyPr wrap="square" lIns="0" tIns="0" rIns="0" bIns="0" rtlCol="0" anchor="ctr"/>
+          <a:lstStyle/>
+          <a:p>
+            <a:pPr algn="l" indent="0" marL="0">
+              <a:lnSpc>
+                <a:spcPct val="130000"/>
+              </a:lnSpc>
+              <a:buNone/>
+            </a:pPr>
+            <a:r>
+              <a:rPr lang="en-US" sz="1050" b="1" dirty="0">
+                <a:solidFill>
+                  <a:srgbClr val="6C4CFF"/>
+                </a:solidFill>
+                <a:latin typeface="Pretendard" pitchFamily="34" charset="0"/>
+                <a:ea typeface="Pretendard" pitchFamily="34" charset="-122"/>
+                <a:cs typeface="Pretendard" pitchFamily="34" charset="-120"/>
+              </a:rPr>
+              <a:t>4-13</a:t>
+            </a:r>
+            <a:endParaRPr lang="en-US" sz="1050" dirty="0"/>
+          </a:p>
+        </p:txBody>
+      </p:sp>
+      <p:sp>
+        <p:nvSpPr>
+          <p:cNvPr id="49" name="Text 47"/>
+          <p:cNvSpPr/>
+          <p:nvPr/>
+        </p:nvSpPr>
+        <p:spPr>
+          <a:xfrm>
+            <a:off x="8346338" y="4636008"/>
+            <a:ext cx="1168298" cy="274320"/>
+          </a:xfrm>
+          <a:prstGeom prst="rect">
+            <a:avLst/>
+          </a:prstGeom>
+          <a:noFill/>
+          <a:ln/>
+        </p:spPr>
+        <p:txBody>
+          <a:bodyPr wrap="square" lIns="0" tIns="0" rIns="0" bIns="0" rtlCol="0" anchor="ctr"/>
+          <a:lstStyle/>
+          <a:p>
+            <a:pPr algn="l" indent="0" marL="0">
+              <a:lnSpc>
+                <a:spcPct val="130000"/>
+              </a:lnSpc>
+              <a:buNone/>
+            </a:pPr>
+            <a:r>
+              <a:rPr lang="en-US" sz="1150" dirty="0">
+                <a:solidFill>
+                  <a:srgbClr val="1D1D1F"/>
+                </a:solidFill>
+                <a:latin typeface="Pretendard Medium" pitchFamily="34" charset="0"/>
+                <a:ea typeface="Pretendard Medium" pitchFamily="34" charset="-122"/>
+                <a:cs typeface="Pretendard Medium" pitchFamily="34" charset="-120"/>
+              </a:rPr>
+              <a:t>위치 안내</a:t>
+            </a:r>
+            <a:endParaRPr lang="en-US" sz="1150" dirty="0"/>
+          </a:p>
+        </p:txBody>
+      </p:sp>
+      <p:sp>
+        <p:nvSpPr>
+          <p:cNvPr id="50" name="Text 48"/>
+          <p:cNvSpPr/>
+          <p:nvPr/>
+        </p:nvSpPr>
+        <p:spPr>
+          <a:xfrm>
+            <a:off x="9514637" y="4636008"/>
+            <a:ext cx="457200" cy="274320"/>
+          </a:xfrm>
+          <a:prstGeom prst="rect">
+            <a:avLst/>
+          </a:prstGeom>
+          <a:noFill/>
+          <a:ln/>
+        </p:spPr>
+        <p:txBody>
+          <a:bodyPr wrap="square" lIns="0" tIns="0" rIns="0" bIns="0" rtlCol="0" anchor="ctr"/>
+          <a:lstStyle/>
+          <a:p>
+            <a:pPr algn="l" indent="0" marL="0">
+              <a:lnSpc>
+                <a:spcPct val="130000"/>
+              </a:lnSpc>
+              <a:buNone/>
+            </a:pPr>
+            <a:r>
+              <a:rPr lang="en-US" sz="1050" b="1" dirty="0">
+                <a:solidFill>
+                  <a:srgbClr val="6C4CFF"/>
+                </a:solidFill>
+                <a:latin typeface="Pretendard" pitchFamily="34" charset="0"/>
+                <a:ea typeface="Pretendard" pitchFamily="34" charset="-122"/>
+                <a:cs typeface="Pretendard" pitchFamily="34" charset="-120"/>
+              </a:rPr>
+              <a:t>4-14</a:t>
+            </a:r>
+            <a:endParaRPr lang="en-US" sz="1050" dirty="0"/>
+          </a:p>
+        </p:txBody>
+      </p:sp>
+      <p:sp>
+        <p:nvSpPr>
+          <p:cNvPr id="51" name="Text 49"/>
+          <p:cNvSpPr/>
+          <p:nvPr/>
+        </p:nvSpPr>
+        <p:spPr>
+          <a:xfrm>
+            <a:off x="9971837" y="4636008"/>
+            <a:ext cx="1168298" cy="274320"/>
+          </a:xfrm>
+          <a:prstGeom prst="rect">
+            <a:avLst/>
+          </a:prstGeom>
+          <a:noFill/>
+          <a:ln/>
+        </p:spPr>
+        <p:txBody>
+          <a:bodyPr wrap="square" lIns="0" tIns="0" rIns="0" bIns="0" rtlCol="0" anchor="ctr"/>
+          <a:lstStyle/>
+          <a:p>
+            <a:pPr algn="l" indent="0" marL="0">
+              <a:lnSpc>
+                <a:spcPct val="130000"/>
+              </a:lnSpc>
+              <a:buNone/>
+            </a:pPr>
+            <a:r>
+              <a:rPr lang="en-US" sz="1150" dirty="0">
+                <a:solidFill>
+                  <a:srgbClr val="1D1D1F"/>
+                </a:solidFill>
+                <a:latin typeface="Pretendard Medium" pitchFamily="34" charset="0"/>
+                <a:ea typeface="Pretendard Medium" pitchFamily="34" charset="-122"/>
+                <a:cs typeface="Pretendard Medium" pitchFamily="34" charset="-120"/>
+              </a:rPr>
+              <a:t>SNS</a:t>
+            </a:r>
+            <a:endParaRPr lang="en-US" sz="1150" dirty="0"/>
+          </a:p>
+        </p:txBody>
+      </p:sp>
+      <p:sp>
+        <p:nvSpPr>
+          <p:cNvPr id="52" name="Text 50"/>
+          <p:cNvSpPr/>
+          <p:nvPr/>
+        </p:nvSpPr>
+        <p:spPr>
+          <a:xfrm>
+            <a:off x="6263640" y="5138928"/>
+            <a:ext cx="457200" cy="274320"/>
+          </a:xfrm>
+          <a:prstGeom prst="rect">
+            <a:avLst/>
+          </a:prstGeom>
+          <a:noFill/>
+          <a:ln/>
+        </p:spPr>
+        <p:txBody>
+          <a:bodyPr wrap="square" lIns="0" tIns="0" rIns="0" bIns="0" rtlCol="0" anchor="ctr"/>
+          <a:lstStyle/>
+          <a:p>
+            <a:pPr algn="l" indent="0" marL="0">
+              <a:lnSpc>
+                <a:spcPct val="130000"/>
+              </a:lnSpc>
+              <a:buNone/>
+            </a:pPr>
+            <a:r>
+              <a:rPr lang="en-US" sz="1050" b="1" dirty="0">
+                <a:solidFill>
+                  <a:srgbClr val="6C4CFF"/>
+                </a:solidFill>
+                <a:latin typeface="Pretendard" pitchFamily="34" charset="0"/>
+                <a:ea typeface="Pretendard" pitchFamily="34" charset="-122"/>
+                <a:cs typeface="Pretendard" pitchFamily="34" charset="-120"/>
+              </a:rPr>
+              <a:t>4-15</a:t>
+            </a:r>
+            <a:endParaRPr lang="en-US" sz="1050" dirty="0"/>
+          </a:p>
+        </p:txBody>
+      </p:sp>
+      <p:sp>
+        <p:nvSpPr>
+          <p:cNvPr id="53" name="Text 51"/>
+          <p:cNvSpPr/>
+          <p:nvPr/>
+        </p:nvSpPr>
+        <p:spPr>
+          <a:xfrm>
+            <a:off x="6720840" y="5138928"/>
+            <a:ext cx="1168298" cy="274320"/>
+          </a:xfrm>
+          <a:prstGeom prst="rect">
+            <a:avLst/>
+          </a:prstGeom>
+          <a:noFill/>
+          <a:ln/>
+        </p:spPr>
+        <p:txBody>
+          <a:bodyPr wrap="square" lIns="0" tIns="0" rIns="0" bIns="0" rtlCol="0" anchor="ctr"/>
+          <a:lstStyle/>
+          <a:p>
+            <a:pPr algn="l" indent="0" marL="0">
+              <a:lnSpc>
+                <a:spcPct val="130000"/>
+              </a:lnSpc>
+              <a:buNone/>
+            </a:pPr>
+            <a:r>
+              <a:rPr lang="en-US" sz="1150" dirty="0">
+                <a:solidFill>
+                  <a:srgbClr val="1D1D1F"/>
+                </a:solidFill>
+                <a:latin typeface="Pretendard Medium" pitchFamily="34" charset="0"/>
+                <a:ea typeface="Pretendard Medium" pitchFamily="34" charset="-122"/>
+                <a:cs typeface="Pretendard Medium" pitchFamily="34" charset="-120"/>
+              </a:rPr>
+              <a:t>구분선</a:t>
+            </a:r>
+            <a:endParaRPr lang="en-US" sz="1150" dirty="0"/>
+          </a:p>
+        </p:txBody>
+      </p:sp>
+      <p:sp>
+        <p:nvSpPr>
+          <p:cNvPr id="54" name="Text 52"/>
+          <p:cNvSpPr/>
+          <p:nvPr/>
+        </p:nvSpPr>
+        <p:spPr>
+          <a:xfrm>
+            <a:off x="7889138" y="5138928"/>
+            <a:ext cx="457200" cy="274320"/>
+          </a:xfrm>
+          <a:prstGeom prst="rect">
+            <a:avLst/>
+          </a:prstGeom>
+          <a:noFill/>
+          <a:ln/>
+        </p:spPr>
+        <p:txBody>
+          <a:bodyPr wrap="square" lIns="0" tIns="0" rIns="0" bIns="0" rtlCol="0" anchor="ctr"/>
+          <a:lstStyle/>
+          <a:p>
+            <a:pPr algn="l" indent="0" marL="0">
+              <a:lnSpc>
+                <a:spcPct val="130000"/>
+              </a:lnSpc>
+              <a:buNone/>
+            </a:pPr>
+            <a:r>
+              <a:rPr lang="en-US" sz="1050" b="1" dirty="0">
+                <a:solidFill>
+                  <a:srgbClr val="6C4CFF"/>
+                </a:solidFill>
+                <a:latin typeface="Pretendard" pitchFamily="34" charset="0"/>
+                <a:ea typeface="Pretendard" pitchFamily="34" charset="-122"/>
+                <a:cs typeface="Pretendard" pitchFamily="34" charset="-120"/>
+              </a:rPr>
+              <a:t>4-16</a:t>
+            </a:r>
+            <a:endParaRPr lang="en-US" sz="1050" dirty="0"/>
+          </a:p>
+        </p:txBody>
+      </p:sp>
+      <p:sp>
+        <p:nvSpPr>
+          <p:cNvPr id="55" name="Text 53"/>
+          <p:cNvSpPr/>
+          <p:nvPr/>
+        </p:nvSpPr>
+        <p:spPr>
+          <a:xfrm>
+            <a:off x="8346338" y="5138928"/>
+            <a:ext cx="1168298" cy="274320"/>
+          </a:xfrm>
+          <a:prstGeom prst="rect">
+            <a:avLst/>
+          </a:prstGeom>
+          <a:noFill/>
+          <a:ln/>
+        </p:spPr>
+        <p:txBody>
+          <a:bodyPr wrap="square" lIns="0" tIns="0" rIns="0" bIns="0" rtlCol="0" anchor="ctr"/>
+          <a:lstStyle/>
+          <a:p>
+            <a:pPr algn="l" indent="0" marL="0">
+              <a:lnSpc>
+                <a:spcPct val="130000"/>
+              </a:lnSpc>
+              <a:buNone/>
+            </a:pPr>
+            <a:r>
+              <a:rPr lang="en-US" sz="1150" dirty="0">
+                <a:solidFill>
+                  <a:srgbClr val="1D1D1F"/>
+                </a:solidFill>
+                <a:latin typeface="Pretendard Medium" pitchFamily="34" charset="0"/>
+                <a:ea typeface="Pretendard Medium" pitchFamily="34" charset="-122"/>
+                <a:cs typeface="Pretendard Medium" pitchFamily="34" charset="-120"/>
+              </a:rPr>
+              <a:t>코드</a:t>
+            </a:r>
+            <a:endParaRPr lang="en-US" sz="1150" dirty="0"/>
+          </a:p>
+        </p:txBody>
+      </p:sp>
+      <p:sp>
+        <p:nvSpPr>
+          <p:cNvPr id="56" name="Text 54"/>
+          <p:cNvSpPr/>
+          <p:nvPr/>
+        </p:nvSpPr>
+        <p:spPr>
+          <a:xfrm>
+            <a:off x="9514637" y="5138928"/>
+            <a:ext cx="457200" cy="274320"/>
+          </a:xfrm>
+          <a:prstGeom prst="rect">
+            <a:avLst/>
+          </a:prstGeom>
+          <a:noFill/>
+          <a:ln/>
+        </p:spPr>
+        <p:txBody>
+          <a:bodyPr wrap="square" lIns="0" tIns="0" rIns="0" bIns="0" rtlCol="0" anchor="ctr"/>
+          <a:lstStyle/>
+          <a:p>
+            <a:pPr algn="l" indent="0" marL="0">
+              <a:lnSpc>
+                <a:spcPct val="130000"/>
+              </a:lnSpc>
+              <a:buNone/>
+            </a:pPr>
+            <a:r>
+              <a:rPr lang="en-US" sz="1050" b="1" dirty="0">
+                <a:solidFill>
+                  <a:srgbClr val="6C4CFF"/>
+                </a:solidFill>
+                <a:latin typeface="Pretendard" pitchFamily="34" charset="0"/>
+                <a:ea typeface="Pretendard" pitchFamily="34" charset="-122"/>
+                <a:cs typeface="Pretendard" pitchFamily="34" charset="-120"/>
+              </a:rPr>
+              <a:t>4-17</a:t>
+            </a:r>
+            <a:endParaRPr lang="en-US" sz="1050" dirty="0"/>
+          </a:p>
+        </p:txBody>
+      </p:sp>
+      <p:sp>
+        <p:nvSpPr>
+          <p:cNvPr id="57" name="Text 55"/>
+          <p:cNvSpPr/>
+          <p:nvPr/>
+        </p:nvSpPr>
+        <p:spPr>
+          <a:xfrm>
+            <a:off x="9971837" y="5138928"/>
+            <a:ext cx="1168298" cy="274320"/>
+          </a:xfrm>
+          <a:prstGeom prst="rect">
+            <a:avLst/>
+          </a:prstGeom>
+          <a:noFill/>
+          <a:ln/>
+        </p:spPr>
+        <p:txBody>
+          <a:bodyPr wrap="square" lIns="0" tIns="0" rIns="0" bIns="0" rtlCol="0" anchor="ctr"/>
+          <a:lstStyle/>
+          <a:p>
+            <a:pPr algn="l" indent="0" marL="0">
+              <a:lnSpc>
+                <a:spcPct val="130000"/>
+              </a:lnSpc>
+              <a:buNone/>
+            </a:pPr>
+            <a:r>
+              <a:rPr lang="en-US" sz="1150" dirty="0">
+                <a:solidFill>
+                  <a:srgbClr val="1D1D1F"/>
+                </a:solidFill>
+                <a:latin typeface="Pretendard Medium" pitchFamily="34" charset="0"/>
+                <a:ea typeface="Pretendard Medium" pitchFamily="34" charset="-122"/>
+                <a:cs typeface="Pretendard Medium" pitchFamily="34" charset="-120"/>
+              </a:rPr>
+              <a:t>2단</a:t>
+            </a:r>
+            <a:endParaRPr lang="en-US" sz="1150" dirty="0"/>
+          </a:p>
+        </p:txBody>
+      </p:sp>
+      <p:sp>
+        <p:nvSpPr>
+          <p:cNvPr id="58" name="Text 56"/>
+          <p:cNvSpPr/>
+          <p:nvPr/>
+        </p:nvSpPr>
+        <p:spPr>
+          <a:xfrm>
+            <a:off x="6263640" y="5650992"/>
+            <a:ext cx="4876495" cy="274320"/>
+          </a:xfrm>
+          <a:prstGeom prst="rect">
+            <a:avLst/>
+          </a:prstGeom>
+          <a:noFill/>
+          <a:ln/>
+        </p:spPr>
+        <p:txBody>
+          <a:bodyPr wrap="square" lIns="0" tIns="0" rIns="0" bIns="0" rtlCol="0" anchor="t"/>
+          <a:lstStyle/>
+          <a:p>
+            <a:pPr algn="l" indent="0" marL="0">
+              <a:lnSpc>
+                <a:spcPct val="130000"/>
+              </a:lnSpc>
+              <a:buNone/>
+            </a:pPr>
+            <a:r>
+              <a:rPr lang="en-US" sz="1000" dirty="0">
+                <a:solidFill>
+                  <a:srgbClr val="6E6E73"/>
+                </a:solidFill>
+                <a:latin typeface="Pretendard" pitchFamily="34" charset="0"/>
+                <a:ea typeface="Pretendard" pitchFamily="34" charset="-122"/>
+                <a:cs typeface="Pretendard" pitchFamily="34" charset="-120"/>
+              </a:rPr>
+              <a:t>예: “상품 카드 만들어줘” → 4-12. 상품 카드.md   ·   “메뉴 카드” → 4-3. 메뉴 카드.md</a:t>
+            </a:r>
+            <a:endParaRPr lang="en-US" sz="1000" dirty="0"/>
           </a:p>
         </p:txBody>
       </p:sp>
@@ -20354,7 +21350,7 @@
               <a:buNone/>
             </a:pPr>
             <a:r>
-              <a:rPr lang="en-US" sz="1400" b="1" dirty="0">
+              <a:rPr lang="en-US" sz="1350" b="1" dirty="0">
                 <a:solidFill>
                   <a:srgbClr val="6C4CFF"/>
                 </a:solidFill>
@@ -20362,9 +21358,9 @@
                 <a:ea typeface="Pretendard" pitchFamily="34" charset="-122"/>
                 <a:cs typeface="Pretendard" pitchFamily="34" charset="-120"/>
               </a:rPr>
-              <a:t>① 허브 목록</a:t>
-            </a:r>
-            <a:endParaRPr lang="en-US" sz="1400" dirty="0"/>
+              <a:t>① 허브 목록 — 왜 design에?</a:t>
+            </a:r>
+            <a:endParaRPr lang="en-US" sz="1350" dirty="0"/>
           </a:p>
         </p:txBody>
       </p:sp>
@@ -20376,8 +21372,8 @@
         </p:nvSpPr>
         <p:spPr>
           <a:xfrm>
-            <a:off x="7616952" y="2907792"/>
-            <a:ext cx="3541471" cy="1005840"/>
+            <a:off x="7616952" y="2889504"/>
+            <a:ext cx="3541471" cy="1097280"/>
           </a:xfrm>
           <a:prstGeom prst="rect">
             <a:avLst/>
@@ -20404,7 +21400,7 @@
                 <a:ea typeface="Pretendard" pitchFamily="34" charset="-122"/>
                 <a:cs typeface="Pretendard" pitchFamily="34" charset="-120"/>
               </a:rPr>
-              <a:t>맨 위 1장에 전 볼트 기능을 ‘가리키기만’. 사람이 어디서든 전체를 한눈에 봅니다.</a:t>
+              <a:t>design은 모든 볼트의 상위 폴더 — 볼트를 가로지르는 목록은 여기에만 둘 수 있습니다. 한 볼트에 넣으면 다른 볼트에선 안 보입니다.</a:t>
             </a:r>
             <a:endParaRPr lang="en-US" sz="1200" dirty="0"/>
           </a:p>

</xml_diff>

<commit_message>
vault backup: 2026-08-11 21:05:19
</commit_message>
<xml_diff>
--- a/CdBd 기능 문서 구조 설계.pptx
+++ b/CdBd 기능 문서 구조 설계.pptx
@@ -6151,7 +6151,7 @@
                 <a:ea typeface="Pretendard" pitchFamily="34" charset="-122"/>
                 <a:cs typeface="Pretendard" pitchFamily="34" charset="-120"/>
               </a:rPr>
-              <a:t>고객이 쓰는 에디터 기능이 있는 볼트 — 경로 가이드는 고객 기능으로 이렇게 채웁니다.</a:t>
+              <a:t>이 볼트에 어떤 CdBd 기능이 있고, 각각 어느 파일에 있는지 이렇게 적습니다.</a:t>
             </a:r>
             <a:endParaRPr lang="en-US" sz="1500" dirty="0"/>
           </a:p>
@@ -6997,7 +6997,7 @@
                 <a:ea typeface="Pretendard" pitchFamily="34" charset="-122"/>
                 <a:cs typeface="Pretendard" pitchFamily="34" charset="-120"/>
               </a:rPr>
-              <a:t>[CdBd 기능 — 고객이 쓰는] 이렇게 말하면 → 이 파일</a:t>
+              <a:t>이 볼트에 있는 CdBd 기능 → 어느 파일에 있나</a:t>
             </a:r>
             <a:endParaRPr lang="en-US" sz="1000" dirty="0"/>
           </a:p>
@@ -7011,7 +7011,7 @@
         </p:nvSpPr>
         <p:spPr>
           <a:xfrm>
-            <a:off x="6263640" y="3291840"/>
+            <a:off x="6263640" y="3246120"/>
             <a:ext cx="4876495" cy="256032"/>
           </a:xfrm>
           <a:prstGeom prst="rect">
@@ -7039,7 +7039,7 @@
                 <a:ea typeface="Pretendard SemiBold" pitchFamily="34" charset="-122"/>
                 <a:cs typeface="Pretendard SemiBold" pitchFamily="34" charset="-120"/>
               </a:rPr>
-              <a:t>“상품 카드 넣어줘”</a:t>
+              <a:t>카드 기능 15종  (상품·예약·유튜브·SNS…)</a:t>
             </a:r>
             <a:endParaRPr lang="en-US" sz="1150" dirty="0"/>
           </a:p>
@@ -7053,7 +7053,7 @@
         </p:nvSpPr>
         <p:spPr>
           <a:xfrm>
-            <a:off x="6391656" y="3511296"/>
+            <a:off x="6391656" y="3474720"/>
             <a:ext cx="4748479" cy="256032"/>
           </a:xfrm>
           <a:prstGeom prst="rect">
@@ -7075,7 +7075,7 @@
             <a:r>
               <a:rPr lang="en-US" sz="1050" dirty="0">
                 <a:solidFill>
-                  <a:srgbClr val="55555A"/>
+                  <a:srgbClr val="6C4CFF"/>
                 </a:solidFill>
                 <a:latin typeface="Pretendard" pitchFamily="34" charset="0"/>
                 <a:ea typeface="Pretendard" pitchFamily="34" charset="-122"/>
@@ -7095,7 +7095,7 @@
         </p:nvSpPr>
         <p:spPr>
           <a:xfrm>
-            <a:off x="6263640" y="3803904"/>
+            <a:off x="6263640" y="3794760"/>
             <a:ext cx="4876495" cy="256032"/>
           </a:xfrm>
           <a:prstGeom prst="rect">
@@ -7123,7 +7123,7 @@
                 <a:ea typeface="Pretendard SemiBold" pitchFamily="34" charset="-122"/>
                 <a:cs typeface="Pretendard SemiBold" pitchFamily="34" charset="-120"/>
               </a:rPr>
-              <a:t>“예약 받는 카드 만들어줘”</a:t>
+              <a:t>새 페이지 추가  (템플릿에서 생성)</a:t>
             </a:r>
             <a:endParaRPr lang="en-US" sz="1150" dirty="0"/>
           </a:p>
@@ -7159,13 +7159,13 @@
             <a:r>
               <a:rPr lang="en-US" sz="1050" dirty="0">
                 <a:solidFill>
-                  <a:srgbClr val="55555A"/>
+                  <a:srgbClr val="6C4CFF"/>
                 </a:solidFill>
                 <a:latin typeface="Pretendard" pitchFamily="34" charset="0"/>
                 <a:ea typeface="Pretendard" pitchFamily="34" charset="-122"/>
                 <a:cs typeface="Pretendard" pitchFamily="34" charset="-120"/>
               </a:rPr>
-              <a:t>→ 1-6-2. CdBd 카드 기능.md</a:t>
+              <a:t>→ 1-1. 워크플로우.md</a:t>
             </a:r>
             <a:endParaRPr lang="en-US" sz="1050" dirty="0"/>
           </a:p>
@@ -7179,7 +7179,7 @@
         </p:nvSpPr>
         <p:spPr>
           <a:xfrm>
-            <a:off x="6263640" y="4315968"/>
+            <a:off x="6263640" y="4343400"/>
             <a:ext cx="4876495" cy="256032"/>
           </a:xfrm>
           <a:prstGeom prst="rect">
@@ -7207,7 +7207,7 @@
                 <a:ea typeface="Pretendard SemiBold" pitchFamily="34" charset="-122"/>
                 <a:cs typeface="Pretendard SemiBold" pitchFamily="34" charset="-120"/>
               </a:rPr>
-              <a:t>“유튜브 영상 카드 추가해줘”</a:t>
+              <a:t>페이지 구성·꾸미기  (테마·배경·여백)</a:t>
             </a:r>
             <a:endParaRPr lang="en-US" sz="1150" dirty="0"/>
           </a:p>
@@ -7221,7 +7221,7 @@
         </p:nvSpPr>
         <p:spPr>
           <a:xfrm>
-            <a:off x="6391656" y="4535424"/>
+            <a:off x="6391656" y="4572000"/>
             <a:ext cx="4748479" cy="256032"/>
           </a:xfrm>
           <a:prstGeom prst="rect">
@@ -7243,13 +7243,13 @@
             <a:r>
               <a:rPr lang="en-US" sz="1050" dirty="0">
                 <a:solidFill>
-                  <a:srgbClr val="55555A"/>
+                  <a:srgbClr val="6C4CFF"/>
                 </a:solidFill>
                 <a:latin typeface="Pretendard" pitchFamily="34" charset="0"/>
                 <a:ea typeface="Pretendard" pitchFamily="34" charset="-122"/>
                 <a:cs typeface="Pretendard" pitchFamily="34" charset="-120"/>
               </a:rPr>
-              <a:t>→ 1-6-2. CdBd 카드 기능.md</a:t>
+              <a:t>→ 1-6-1. CdBd 에디터.md</a:t>
             </a:r>
             <a:endParaRPr lang="en-US" sz="1050" dirty="0"/>
           </a:p>
@@ -7263,7 +7263,7 @@
         </p:nvSpPr>
         <p:spPr>
           <a:xfrm>
-            <a:off x="6263640" y="4828032"/>
+            <a:off x="6263640" y="4892040"/>
             <a:ext cx="4876495" cy="256032"/>
           </a:xfrm>
           <a:prstGeom prst="rect">
@@ -7291,7 +7291,7 @@
                 <a:ea typeface="Pretendard SemiBold" pitchFamily="34" charset="-122"/>
                 <a:cs typeface="Pretendard SemiBold" pitchFamily="34" charset="-120"/>
               </a:rPr>
-              <a:t>“페이지 테마·배경 바꿔줘”</a:t>
+              <a:t>카드 자동화  (순서·핀·복제·삭제)</a:t>
             </a:r>
             <a:endParaRPr lang="en-US" sz="1150" dirty="0"/>
           </a:p>
@@ -7305,7 +7305,7 @@
         </p:nvSpPr>
         <p:spPr>
           <a:xfrm>
-            <a:off x="6391656" y="5047488"/>
+            <a:off x="6391656" y="5120640"/>
             <a:ext cx="4748479" cy="256032"/>
           </a:xfrm>
           <a:prstGeom prst="rect">
@@ -7327,13 +7327,13 @@
             <a:r>
               <a:rPr lang="en-US" sz="1050" dirty="0">
                 <a:solidFill>
-                  <a:srgbClr val="55555A"/>
+                  <a:srgbClr val="6C4CFF"/>
                 </a:solidFill>
                 <a:latin typeface="Pretendard" pitchFamily="34" charset="0"/>
                 <a:ea typeface="Pretendard" pitchFamily="34" charset="-122"/>
                 <a:cs typeface="Pretendard" pitchFamily="34" charset="-120"/>
               </a:rPr>
-              <a:t>→ 1-6-1. CdBd 에디터.md</a:t>
+              <a:t>→ .claude/skills/cdbd-card-automation/</a:t>
             </a:r>
             <a:endParaRPr lang="en-US" sz="1050" dirty="0"/>
           </a:p>
@@ -7347,7 +7347,7 @@
         </p:nvSpPr>
         <p:spPr>
           <a:xfrm>
-            <a:off x="6263640" y="5596128"/>
+            <a:off x="6263640" y="5623560"/>
             <a:ext cx="4876495" cy="320040"/>
           </a:xfrm>
           <a:prstGeom prst="rect">
@@ -9946,7 +9946,7 @@
                 <a:ea typeface="Pretendard SemiBold" pitchFamily="34" charset="-122"/>
                 <a:cs typeface="Pretendard SemiBold" pitchFamily="34" charset="-120"/>
               </a:rPr>
-              <a:t>git에 못 넣는 것도 배포</a:t>
+              <a:t>볼트를 넘는 라우팅</a:t>
             </a:r>
             <a:endParaRPr lang="en-US" sz="1250" dirty="0"/>
           </a:p>
@@ -9988,7 +9988,7 @@
                 <a:ea typeface="Pretendard" pitchFamily="34" charset="-122"/>
                 <a:cs typeface="Pretendard" pitchFamily="34" charset="-120"/>
               </a:rPr>
-              <a:t>gstack · 로그인 · Figma MCP</a:t>
+              <a:t>다른 볼트 기능의 위치까지 안내</a:t>
             </a:r>
             <a:endParaRPr lang="en-US" sz="1050" dirty="0"/>
           </a:p>
@@ -10030,7 +10030,7 @@
                 <a:ea typeface="Pretendard SemiBold" pitchFamily="34" charset="-122"/>
                 <a:cs typeface="Pretendard SemiBold" pitchFamily="34" charset="-120"/>
               </a:rPr>
-              <a:t>파일 구조 = 볼트 내부용 · 플러그인 = 볼트 경계를 넘는 배포용 — 대체재가 아니라 보완재.</a:t>
+              <a:t>파일 구조 = 볼트 내부용 · 플러그인 = 볼트 경계를 넘는 발견용 — 대체재가 아니라 보완재.</a:t>
             </a:r>
             <a:endParaRPr lang="en-US" sz="1250" dirty="0"/>
           </a:p>
@@ -10251,7 +10251,7 @@
                 <a:ea typeface="Pretendard" pitchFamily="34" charset="-122"/>
                 <a:cs typeface="Pretendard" pitchFamily="34" charset="-120"/>
               </a:rPr>
-              <a:t>목적에 필요한 것만 담는다</a:t>
+              <a:t>플러그인이 담는 건 ‘통합 기능 경로 가이드’ 하나</a:t>
             </a:r>
             <a:endParaRPr lang="en-US" sz="2600" dirty="0"/>
           </a:p>
@@ -10290,7 +10290,7 @@
                 <a:ea typeface="Pretendard" pitchFamily="34" charset="-122"/>
                 <a:cs typeface="Pretendard" pitchFamily="34" charset="-120"/>
               </a:rPr>
-              <a:t>목적은 하나 — CdBd 기능을 어느 볼트에서도 수행. 그에 필요한 것만 넣습니다.</a:t>
+              <a:t>5개 볼트의 경로 가이드를 하나로 합친 파일 — 이게 하는 역할은 셋입니다.</a:t>
             </a:r>
             <a:endParaRPr lang="en-US" sz="1500" dirty="0"/>
           </a:p>
@@ -10451,16 +10451,23 @@
         </p:nvSpPr>
         <p:spPr>
           <a:xfrm>
-            <a:off x="1088136" y="3127248"/>
-            <a:ext cx="109728" cy="109728"/>
-          </a:xfrm>
-          <a:prstGeom prst="ellipse">
-            <a:avLst/>
+            <a:off x="1051560" y="2999232"/>
+            <a:ext cx="4389120" cy="530352"/>
+          </a:xfrm>
+          <a:prstGeom prst="roundRect">
+            <a:avLst>
+              <a:gd name="adj" fmla="val 17241"/>
+            </a:avLst>
           </a:prstGeom>
           <a:solidFill>
-            <a:srgbClr val="6C4CFF"/>
+            <a:srgbClr val="EEEAFB"/>
           </a:solidFill>
-          <a:ln/>
+          <a:ln w="15875">
+            <a:solidFill>
+              <a:srgbClr val="6C4CFF"/>
+            </a:solidFill>
+            <a:prstDash val="solid"/>
+          </a:ln>
         </p:spPr>
       </p:sp>
       <p:sp>
@@ -10471,8 +10478,50 @@
         </p:nvSpPr>
         <p:spPr>
           <a:xfrm>
-            <a:off x="1325880" y="3063240"/>
-            <a:ext cx="4206240" cy="274320"/>
+            <a:off x="1051560" y="2999232"/>
+            <a:ext cx="4389120" cy="530352"/>
+          </a:xfrm>
+          <a:prstGeom prst="rect">
+            <a:avLst/>
+          </a:prstGeom>
+          <a:noFill/>
+          <a:ln/>
+        </p:spPr>
+        <p:txBody>
+          <a:bodyPr wrap="square" lIns="0" tIns="0" rIns="0" bIns="0" rtlCol="0" anchor="ctr"/>
+          <a:lstStyle/>
+          <a:p>
+            <a:pPr algn="ctr" indent="0" marL="0">
+              <a:lnSpc>
+                <a:spcPct val="130000"/>
+              </a:lnSpc>
+              <a:buNone/>
+            </a:pPr>
+            <a:r>
+              <a:rPr lang="en-US" sz="1300" b="1" dirty="0">
+                <a:solidFill>
+                  <a:srgbClr val="6C4CFF"/>
+                </a:solidFill>
+                <a:latin typeface="Pretendard" pitchFamily="34" charset="0"/>
+                <a:ea typeface="Pretendard" pitchFamily="34" charset="-122"/>
+                <a:cs typeface="Pretendard" pitchFamily="34" charset="-120"/>
+              </a:rPr>
+              <a:t>통합 기능 경로 가이드 (.md 한 장)</a:t>
+            </a:r>
+            <a:endParaRPr lang="en-US" sz="1300" dirty="0"/>
+          </a:p>
+        </p:txBody>
+      </p:sp>
+      <p:sp>
+        <p:nvSpPr>
+          <p:cNvPr id="12" name="Text 10"/>
+          <p:cNvSpPr/>
+          <p:nvPr/>
+        </p:nvSpPr>
+        <p:spPr>
+          <a:xfrm>
+            <a:off x="1051560" y="3675888"/>
+            <a:ext cx="4389120" cy="274320"/>
           </a:xfrm>
           <a:prstGeom prst="rect">
             <a:avLst/>
@@ -10491,30 +10540,417 @@
               <a:buNone/>
             </a:pPr>
             <a:r>
-              <a:rPr lang="en-US" sz="1250" dirty="0">
-                <a:solidFill>
-                  <a:srgbClr val="6C4CFF"/>
+              <a:rPr lang="en-US" sz="1100" dirty="0">
+                <a:solidFill>
+                  <a:srgbClr val="55555A"/>
+                </a:solidFill>
+                <a:latin typeface="Pretendard" pitchFamily="34" charset="0"/>
+                <a:ea typeface="Pretendard" pitchFamily="34" charset="-122"/>
+                <a:cs typeface="Pretendard" pitchFamily="34" charset="-120"/>
+              </a:rPr>
+              <a:t>= 5개 볼트의 _기능별 경로 가이드를 하나로 합침</a:t>
+            </a:r>
+            <a:endParaRPr lang="en-US" sz="1100" dirty="0"/>
+          </a:p>
+        </p:txBody>
+      </p:sp>
+      <p:sp>
+        <p:nvSpPr>
+          <p:cNvPr id="13" name="Shape 11"/>
+          <p:cNvSpPr/>
+          <p:nvPr/>
+        </p:nvSpPr>
+        <p:spPr>
+          <a:xfrm>
+            <a:off x="1051560" y="4041648"/>
+            <a:ext cx="822960" cy="292608"/>
+          </a:xfrm>
+          <a:prstGeom prst="roundRect">
+            <a:avLst>
+              <a:gd name="adj" fmla="val 18750"/>
+            </a:avLst>
+          </a:prstGeom>
+          <a:solidFill>
+            <a:srgbClr val="FFFFFF"/>
+          </a:solidFill>
+          <a:ln w="12700">
+            <a:solidFill>
+              <a:srgbClr val="E5E7EB"/>
+            </a:solidFill>
+            <a:prstDash val="solid"/>
+          </a:ln>
+        </p:spPr>
+      </p:sp>
+      <p:sp>
+        <p:nvSpPr>
+          <p:cNvPr id="14" name="Text 12"/>
+          <p:cNvSpPr/>
+          <p:nvPr/>
+        </p:nvSpPr>
+        <p:spPr>
+          <a:xfrm>
+            <a:off x="1051560" y="4041648"/>
+            <a:ext cx="822960" cy="292608"/>
+          </a:xfrm>
+          <a:prstGeom prst="rect">
+            <a:avLst/>
+          </a:prstGeom>
+          <a:noFill/>
+          <a:ln/>
+        </p:spPr>
+        <p:txBody>
+          <a:bodyPr wrap="square" lIns="0" tIns="0" rIns="0" bIns="0" rtlCol="0" anchor="ctr"/>
+          <a:lstStyle/>
+          <a:p>
+            <a:pPr algn="ctr" indent="0" marL="0">
+              <a:lnSpc>
+                <a:spcPct val="130000"/>
+              </a:lnSpc>
+              <a:buNone/>
+            </a:pPr>
+            <a:r>
+              <a:rPr lang="en-US" sz="850" dirty="0">
+                <a:solidFill>
+                  <a:srgbClr val="55555A"/>
+                </a:solidFill>
+                <a:latin typeface="Pretendard Medium" pitchFamily="34" charset="0"/>
+                <a:ea typeface="Pretendard Medium" pitchFamily="34" charset="-122"/>
+                <a:cs typeface="Pretendard Medium" pitchFamily="34" charset="-120"/>
+              </a:rPr>
+              <a:t>templates</a:t>
+            </a:r>
+            <a:endParaRPr lang="en-US" sz="850" dirty="0"/>
+          </a:p>
+        </p:txBody>
+      </p:sp>
+      <p:sp>
+        <p:nvSpPr>
+          <p:cNvPr id="15" name="Shape 13"/>
+          <p:cNvSpPr/>
+          <p:nvPr/>
+        </p:nvSpPr>
+        <p:spPr>
+          <a:xfrm>
+            <a:off x="1920240" y="4041648"/>
+            <a:ext cx="822960" cy="292608"/>
+          </a:xfrm>
+          <a:prstGeom prst="roundRect">
+            <a:avLst>
+              <a:gd name="adj" fmla="val 18750"/>
+            </a:avLst>
+          </a:prstGeom>
+          <a:solidFill>
+            <a:srgbClr val="FFFFFF"/>
+          </a:solidFill>
+          <a:ln w="12700">
+            <a:solidFill>
+              <a:srgbClr val="E5E7EB"/>
+            </a:solidFill>
+            <a:prstDash val="solid"/>
+          </a:ln>
+        </p:spPr>
+      </p:sp>
+      <p:sp>
+        <p:nvSpPr>
+          <p:cNvPr id="16" name="Text 14"/>
+          <p:cNvSpPr/>
+          <p:nvPr/>
+        </p:nvSpPr>
+        <p:spPr>
+          <a:xfrm>
+            <a:off x="1920240" y="4041648"/>
+            <a:ext cx="822960" cy="292608"/>
+          </a:xfrm>
+          <a:prstGeom prst="rect">
+            <a:avLst/>
+          </a:prstGeom>
+          <a:noFill/>
+          <a:ln/>
+        </p:spPr>
+        <p:txBody>
+          <a:bodyPr wrap="square" lIns="0" tIns="0" rIns="0" bIns="0" rtlCol="0" anchor="ctr"/>
+          <a:lstStyle/>
+          <a:p>
+            <a:pPr algn="ctr" indent="0" marL="0">
+              <a:lnSpc>
+                <a:spcPct val="130000"/>
+              </a:lnSpc>
+              <a:buNone/>
+            </a:pPr>
+            <a:r>
+              <a:rPr lang="en-US" sz="850" dirty="0">
+                <a:solidFill>
+                  <a:srgbClr val="55555A"/>
+                </a:solidFill>
+                <a:latin typeface="Pretendard Medium" pitchFamily="34" charset="0"/>
+                <a:ea typeface="Pretendard Medium" pitchFamily="34" charset="-122"/>
+                <a:cs typeface="Pretendard Medium" pitchFamily="34" charset="-120"/>
+              </a:rPr>
+              <a:t>service</a:t>
+            </a:r>
+            <a:endParaRPr lang="en-US" sz="850" dirty="0"/>
+          </a:p>
+        </p:txBody>
+      </p:sp>
+      <p:sp>
+        <p:nvSpPr>
+          <p:cNvPr id="17" name="Shape 15"/>
+          <p:cNvSpPr/>
+          <p:nvPr/>
+        </p:nvSpPr>
+        <p:spPr>
+          <a:xfrm>
+            <a:off x="2788920" y="4041648"/>
+            <a:ext cx="822960" cy="292608"/>
+          </a:xfrm>
+          <a:prstGeom prst="roundRect">
+            <a:avLst>
+              <a:gd name="adj" fmla="val 18750"/>
+            </a:avLst>
+          </a:prstGeom>
+          <a:solidFill>
+            <a:srgbClr val="FFFFFF"/>
+          </a:solidFill>
+          <a:ln w="12700">
+            <a:solidFill>
+              <a:srgbClr val="E5E7EB"/>
+            </a:solidFill>
+            <a:prstDash val="solid"/>
+          </a:ln>
+        </p:spPr>
+      </p:sp>
+      <p:sp>
+        <p:nvSpPr>
+          <p:cNvPr id="18" name="Text 16"/>
+          <p:cNvSpPr/>
+          <p:nvPr/>
+        </p:nvSpPr>
+        <p:spPr>
+          <a:xfrm>
+            <a:off x="2788920" y="4041648"/>
+            <a:ext cx="822960" cy="292608"/>
+          </a:xfrm>
+          <a:prstGeom prst="rect">
+            <a:avLst/>
+          </a:prstGeom>
+          <a:noFill/>
+          <a:ln/>
+        </p:spPr>
+        <p:txBody>
+          <a:bodyPr wrap="square" lIns="0" tIns="0" rIns="0" bIns="0" rtlCol="0" anchor="ctr"/>
+          <a:lstStyle/>
+          <a:p>
+            <a:pPr algn="ctr" indent="0" marL="0">
+              <a:lnSpc>
+                <a:spcPct val="130000"/>
+              </a:lnSpc>
+              <a:buNone/>
+            </a:pPr>
+            <a:r>
+              <a:rPr lang="en-US" sz="850" dirty="0">
+                <a:solidFill>
+                  <a:srgbClr val="55555A"/>
+                </a:solidFill>
+                <a:latin typeface="Pretendard Medium" pitchFamily="34" charset="0"/>
+                <a:ea typeface="Pretendard Medium" pitchFamily="34" charset="-122"/>
+                <a:cs typeface="Pretendard Medium" pitchFamily="34" charset="-120"/>
+              </a:rPr>
+              <a:t>system</a:t>
+            </a:r>
+            <a:endParaRPr lang="en-US" sz="850" dirty="0"/>
+          </a:p>
+        </p:txBody>
+      </p:sp>
+      <p:sp>
+        <p:nvSpPr>
+          <p:cNvPr id="19" name="Shape 17"/>
+          <p:cNvSpPr/>
+          <p:nvPr/>
+        </p:nvSpPr>
+        <p:spPr>
+          <a:xfrm>
+            <a:off x="3657600" y="4041648"/>
+            <a:ext cx="822960" cy="292608"/>
+          </a:xfrm>
+          <a:prstGeom prst="roundRect">
+            <a:avLst>
+              <a:gd name="adj" fmla="val 18750"/>
+            </a:avLst>
+          </a:prstGeom>
+          <a:solidFill>
+            <a:srgbClr val="FFFFFF"/>
+          </a:solidFill>
+          <a:ln w="12700">
+            <a:solidFill>
+              <a:srgbClr val="E5E7EB"/>
+            </a:solidFill>
+            <a:prstDash val="solid"/>
+          </a:ln>
+        </p:spPr>
+      </p:sp>
+      <p:sp>
+        <p:nvSpPr>
+          <p:cNvPr id="20" name="Text 18"/>
+          <p:cNvSpPr/>
+          <p:nvPr/>
+        </p:nvSpPr>
+        <p:spPr>
+          <a:xfrm>
+            <a:off x="3657600" y="4041648"/>
+            <a:ext cx="822960" cy="292608"/>
+          </a:xfrm>
+          <a:prstGeom prst="rect">
+            <a:avLst/>
+          </a:prstGeom>
+          <a:noFill/>
+          <a:ln/>
+        </p:spPr>
+        <p:txBody>
+          <a:bodyPr wrap="square" lIns="0" tIns="0" rIns="0" bIns="0" rtlCol="0" anchor="ctr"/>
+          <a:lstStyle/>
+          <a:p>
+            <a:pPr algn="ctr" indent="0" marL="0">
+              <a:lnSpc>
+                <a:spcPct val="130000"/>
+              </a:lnSpc>
+              <a:buNone/>
+            </a:pPr>
+            <a:r>
+              <a:rPr lang="en-US" sz="850" dirty="0">
+                <a:solidFill>
+                  <a:srgbClr val="55555A"/>
+                </a:solidFill>
+                <a:latin typeface="Pretendard Medium" pitchFamily="34" charset="0"/>
+                <a:ea typeface="Pretendard Medium" pitchFamily="34" charset="-122"/>
+                <a:cs typeface="Pretendard Medium" pitchFamily="34" charset="-120"/>
+              </a:rPr>
+              <a:t>marketing</a:t>
+            </a:r>
+            <a:endParaRPr lang="en-US" sz="850" dirty="0"/>
+          </a:p>
+        </p:txBody>
+      </p:sp>
+      <p:sp>
+        <p:nvSpPr>
+          <p:cNvPr id="21" name="Shape 19"/>
+          <p:cNvSpPr/>
+          <p:nvPr/>
+        </p:nvSpPr>
+        <p:spPr>
+          <a:xfrm>
+            <a:off x="4526280" y="4041648"/>
+            <a:ext cx="822960" cy="292608"/>
+          </a:xfrm>
+          <a:prstGeom prst="roundRect">
+            <a:avLst>
+              <a:gd name="adj" fmla="val 18750"/>
+            </a:avLst>
+          </a:prstGeom>
+          <a:solidFill>
+            <a:srgbClr val="FFFFFF"/>
+          </a:solidFill>
+          <a:ln w="12700">
+            <a:solidFill>
+              <a:srgbClr val="E5E7EB"/>
+            </a:solidFill>
+            <a:prstDash val="solid"/>
+          </a:ln>
+        </p:spPr>
+      </p:sp>
+      <p:sp>
+        <p:nvSpPr>
+          <p:cNvPr id="22" name="Text 20"/>
+          <p:cNvSpPr/>
+          <p:nvPr/>
+        </p:nvSpPr>
+        <p:spPr>
+          <a:xfrm>
+            <a:off x="4526280" y="4041648"/>
+            <a:ext cx="822960" cy="292608"/>
+          </a:xfrm>
+          <a:prstGeom prst="rect">
+            <a:avLst/>
+          </a:prstGeom>
+          <a:noFill/>
+          <a:ln/>
+        </p:spPr>
+        <p:txBody>
+          <a:bodyPr wrap="square" lIns="0" tIns="0" rIns="0" bIns="0" rtlCol="0" anchor="ctr"/>
+          <a:lstStyle/>
+          <a:p>
+            <a:pPr algn="ctr" indent="0" marL="0">
+              <a:lnSpc>
+                <a:spcPct val="130000"/>
+              </a:lnSpc>
+              <a:buNone/>
+            </a:pPr>
+            <a:r>
+              <a:rPr lang="en-US" sz="850" dirty="0">
+                <a:solidFill>
+                  <a:srgbClr val="55555A"/>
+                </a:solidFill>
+                <a:latin typeface="Pretendard Medium" pitchFamily="34" charset="0"/>
+                <a:ea typeface="Pretendard Medium" pitchFamily="34" charset="-122"/>
+                <a:cs typeface="Pretendard Medium" pitchFamily="34" charset="-120"/>
+              </a:rPr>
+              <a:t>qrstp</a:t>
+            </a:r>
+            <a:endParaRPr lang="en-US" sz="850" dirty="0"/>
+          </a:p>
+        </p:txBody>
+      </p:sp>
+      <p:sp>
+        <p:nvSpPr>
+          <p:cNvPr id="23" name="Text 21"/>
+          <p:cNvSpPr/>
+          <p:nvPr/>
+        </p:nvSpPr>
+        <p:spPr>
+          <a:xfrm>
+            <a:off x="1051560" y="4681728"/>
+            <a:ext cx="4389120" cy="256032"/>
+          </a:xfrm>
+          <a:prstGeom prst="rect">
+            <a:avLst/>
+          </a:prstGeom>
+          <a:noFill/>
+          <a:ln/>
+        </p:spPr>
+        <p:txBody>
+          <a:bodyPr wrap="square" lIns="0" tIns="0" rIns="0" bIns="0" rtlCol="0" anchor="t"/>
+          <a:lstStyle/>
+          <a:p>
+            <a:pPr algn="l" indent="0" marL="0">
+              <a:lnSpc>
+                <a:spcPct val="130000"/>
+              </a:lnSpc>
+              <a:buNone/>
+            </a:pPr>
+            <a:r>
+              <a:rPr lang="en-US" sz="1100" dirty="0">
+                <a:solidFill>
+                  <a:srgbClr val="6E6E73"/>
                 </a:solidFill>
                 <a:latin typeface="Pretendard SemiBold" pitchFamily="34" charset="0"/>
                 <a:ea typeface="Pretendard SemiBold" pitchFamily="34" charset="-122"/>
                 <a:cs typeface="Pretendard SemiBold" pitchFamily="34" charset="-120"/>
               </a:rPr>
-              <a:t>통합 기능 경로 가이드</a:t>
-            </a:r>
-            <a:endParaRPr lang="en-US" sz="1250" dirty="0"/>
-          </a:p>
-        </p:txBody>
-      </p:sp>
-      <p:sp>
-        <p:nvSpPr>
-          <p:cNvPr id="12" name="Text 10"/>
-          <p:cNvSpPr/>
-          <p:nvPr/>
-        </p:nvSpPr>
-        <p:spPr>
-          <a:xfrm>
-            <a:off x="1325880" y="3337560"/>
-            <a:ext cx="4206240" cy="274320"/>
+              <a:t>이건 플러그인이 아님</a:t>
+            </a:r>
+            <a:endParaRPr lang="en-US" sz="1100" dirty="0"/>
+          </a:p>
+        </p:txBody>
+      </p:sp>
+      <p:sp>
+        <p:nvSpPr>
+          <p:cNvPr id="24" name="Text 22"/>
+          <p:cNvSpPr/>
+          <p:nvPr/>
+        </p:nvSpPr>
+        <p:spPr>
+          <a:xfrm>
+            <a:off x="1051560" y="4956048"/>
+            <a:ext cx="4389120" cy="822960"/>
           </a:xfrm>
           <a:prstGeom prst="rect">
             <a:avLst/>
@@ -10528,124 +10964,40 @@
           <a:p>
             <a:pPr algn="l" indent="0" marL="0">
               <a:lnSpc>
-                <a:spcPct val="130000"/>
+                <a:spcPct val="140000"/>
               </a:lnSpc>
               <a:buNone/>
             </a:pPr>
             <a:r>
               <a:rPr lang="en-US" sz="1050" dirty="0">
                 <a:solidFill>
-                  <a:srgbClr val="55555A"/>
+                  <a:srgbClr val="6E6E73"/>
                 </a:solidFill>
                 <a:latin typeface="Pretendard" pitchFamily="34" charset="0"/>
                 <a:ea typeface="Pretendard" pitchFamily="34" charset="-122"/>
                 <a:cs typeface="Pretendard" pitchFamily="34" charset="-120"/>
               </a:rPr>
-              <a:t>전 볼트 CdBd 기능 → 파일  ·  어디서 켜도 자동 로드</a:t>
+              <a:t>· 브랜드 토큰 · Figma MCP → Figma 작업용 도구</a:t>
             </a:r>
             <a:endParaRPr lang="en-US" sz="1050" dirty="0"/>
           </a:p>
-        </p:txBody>
-      </p:sp>
-      <p:sp>
-        <p:nvSpPr>
-          <p:cNvPr id="13" name="Shape 11"/>
-          <p:cNvSpPr/>
-          <p:nvPr/>
-        </p:nvSpPr>
-        <p:spPr>
-          <a:xfrm>
-            <a:off x="1088136" y="3785616"/>
-            <a:ext cx="109728" cy="109728"/>
-          </a:xfrm>
-          <a:prstGeom prst="ellipse">
-            <a:avLst/>
-          </a:prstGeom>
-          <a:solidFill>
-            <a:srgbClr val="6C4CFF"/>
-          </a:solidFill>
-          <a:ln/>
-        </p:spPr>
-      </p:sp>
-      <p:sp>
-        <p:nvSpPr>
-          <p:cNvPr id="14" name="Text 12"/>
-          <p:cNvSpPr/>
-          <p:nvPr/>
-        </p:nvSpPr>
-        <p:spPr>
-          <a:xfrm>
-            <a:off x="1325880" y="3721608"/>
-            <a:ext cx="4206240" cy="274320"/>
-          </a:xfrm>
-          <a:prstGeom prst="rect">
-            <a:avLst/>
-          </a:prstGeom>
-          <a:noFill/>
-          <a:ln/>
-        </p:spPr>
-        <p:txBody>
-          <a:bodyPr wrap="square" lIns="0" tIns="0" rIns="0" bIns="0" rtlCol="0" anchor="t"/>
-          <a:lstStyle/>
-          <a:p>
-            <a:pPr algn="l" indent="0" marL="0">
-              <a:lnSpc>
-                <a:spcPct val="130000"/>
-              </a:lnSpc>
-              <a:buNone/>
-            </a:pPr>
-            <a:r>
-              <a:rPr lang="en-US" sz="1250" dirty="0">
-                <a:solidFill>
-                  <a:srgbClr val="6C4CFF"/>
-                </a:solidFill>
-                <a:latin typeface="Pretendard SemiBold" pitchFamily="34" charset="0"/>
-                <a:ea typeface="Pretendard SemiBold" pitchFamily="34" charset="-122"/>
-                <a:cs typeface="Pretendard SemiBold" pitchFamily="34" charset="-120"/>
-              </a:rPr>
-              <a:t>브랜드 토큰 정본</a:t>
-            </a:r>
-            <a:endParaRPr lang="en-US" sz="1250" dirty="0"/>
-          </a:p>
-        </p:txBody>
-      </p:sp>
-      <p:sp>
-        <p:nvSpPr>
-          <p:cNvPr id="15" name="Text 13"/>
-          <p:cNvSpPr/>
-          <p:nvPr/>
-        </p:nvSpPr>
-        <p:spPr>
-          <a:xfrm>
-            <a:off x="1325880" y="3995928"/>
-            <a:ext cx="4206240" cy="274320"/>
-          </a:xfrm>
-          <a:prstGeom prst="rect">
-            <a:avLst/>
-          </a:prstGeom>
-          <a:noFill/>
-          <a:ln/>
-        </p:spPr>
-        <p:txBody>
-          <a:bodyPr wrap="square" lIns="0" tIns="0" rIns="0" bIns="0" rtlCol="0" anchor="t"/>
-          <a:lstStyle/>
-          <a:p>
-            <a:pPr algn="l" indent="0" marL="0">
-              <a:lnSpc>
-                <a:spcPct val="130000"/>
+          <a:p>
+            <a:pPr algn="l" indent="0" marL="0">
+              <a:lnSpc>
+                <a:spcPct val="140000"/>
               </a:lnSpc>
               <a:buNone/>
             </a:pPr>
             <a:r>
               <a:rPr lang="en-US" sz="1050" dirty="0">
                 <a:solidFill>
-                  <a:srgbClr val="55555A"/>
+                  <a:srgbClr val="6E6E73"/>
                 </a:solidFill>
                 <a:latin typeface="Pretendard" pitchFamily="34" charset="0"/>
                 <a:ea typeface="Pretendard" pitchFamily="34" charset="-122"/>
                 <a:cs typeface="Pretendard" pitchFamily="34" charset="-120"/>
               </a:rPr>
-              <a:t>컬러 · 폰트 정본값  ·  어느 볼트든 같은 값</a:t>
+              <a:t>· 로그인 정보 → 비밀이라 각자 로컬(~/.config)</a:t>
             </a:r>
             <a:endParaRPr lang="en-US" sz="1050" dirty="0"/>
           </a:p>
@@ -10653,215 +11005,7 @@
       </p:sp>
       <p:sp>
         <p:nvSpPr>
-          <p:cNvPr id="16" name="Shape 14"/>
-          <p:cNvSpPr/>
-          <p:nvPr/>
-        </p:nvSpPr>
-        <p:spPr>
-          <a:xfrm>
-            <a:off x="1088136" y="4443984"/>
-            <a:ext cx="109728" cy="109728"/>
-          </a:xfrm>
-          <a:prstGeom prst="ellipse">
-            <a:avLst/>
-          </a:prstGeom>
-          <a:solidFill>
-            <a:srgbClr val="6C4CFF"/>
-          </a:solidFill>
-          <a:ln/>
-        </p:spPr>
-      </p:sp>
-      <p:sp>
-        <p:nvSpPr>
-          <p:cNvPr id="17" name="Text 15"/>
-          <p:cNvSpPr/>
-          <p:nvPr/>
-        </p:nvSpPr>
-        <p:spPr>
-          <a:xfrm>
-            <a:off x="1325880" y="4379976"/>
-            <a:ext cx="4206240" cy="274320"/>
-          </a:xfrm>
-          <a:prstGeom prst="rect">
-            <a:avLst/>
-          </a:prstGeom>
-          <a:noFill/>
-          <a:ln/>
-        </p:spPr>
-        <p:txBody>
-          <a:bodyPr wrap="square" lIns="0" tIns="0" rIns="0" bIns="0" rtlCol="0" anchor="t"/>
-          <a:lstStyle/>
-          <a:p>
-            <a:pPr algn="l" indent="0" marL="0">
-              <a:lnSpc>
-                <a:spcPct val="130000"/>
-              </a:lnSpc>
-              <a:buNone/>
-            </a:pPr>
-            <a:r>
-              <a:rPr lang="en-US" sz="1250" dirty="0">
-                <a:solidFill>
-                  <a:srgbClr val="6C4CFF"/>
-                </a:solidFill>
-                <a:latin typeface="Pretendard SemiBold" pitchFamily="34" charset="0"/>
-                <a:ea typeface="Pretendard SemiBold" pitchFamily="34" charset="-122"/>
-                <a:cs typeface="Pretendard SemiBold" pitchFamily="34" charset="-120"/>
-              </a:rPr>
-              <a:t>.mcp.json</a:t>
-            </a:r>
-            <a:endParaRPr lang="en-US" sz="1250" dirty="0"/>
-          </a:p>
-        </p:txBody>
-      </p:sp>
-      <p:sp>
-        <p:nvSpPr>
-          <p:cNvPr id="18" name="Text 16"/>
-          <p:cNvSpPr/>
-          <p:nvPr/>
-        </p:nvSpPr>
-        <p:spPr>
-          <a:xfrm>
-            <a:off x="1325880" y="4654296"/>
-            <a:ext cx="4206240" cy="274320"/>
-          </a:xfrm>
-          <a:prstGeom prst="rect">
-            <a:avLst/>
-          </a:prstGeom>
-          <a:noFill/>
-          <a:ln/>
-        </p:spPr>
-        <p:txBody>
-          <a:bodyPr wrap="square" lIns="0" tIns="0" rIns="0" bIns="0" rtlCol="0" anchor="t"/>
-          <a:lstStyle/>
-          <a:p>
-            <a:pPr algn="l" indent="0" marL="0">
-              <a:lnSpc>
-                <a:spcPct val="130000"/>
-              </a:lnSpc>
-              <a:buNone/>
-            </a:pPr>
-            <a:r>
-              <a:rPr lang="en-US" sz="1050" dirty="0">
-                <a:solidFill>
-                  <a:srgbClr val="55555A"/>
-                </a:solidFill>
-                <a:latin typeface="Pretendard" pitchFamily="34" charset="0"/>
-                <a:ea typeface="Pretendard" pitchFamily="34" charset="-122"/>
-                <a:cs typeface="Pretendard" pitchFamily="34" charset="-120"/>
-              </a:rPr>
-              <a:t>Figma 연결  ·  실행 도구</a:t>
-            </a:r>
-            <a:endParaRPr lang="en-US" sz="1050" dirty="0"/>
-          </a:p>
-        </p:txBody>
-      </p:sp>
-      <p:sp>
-        <p:nvSpPr>
-          <p:cNvPr id="19" name="Shape 17"/>
-          <p:cNvSpPr/>
-          <p:nvPr/>
-        </p:nvSpPr>
-        <p:spPr>
-          <a:xfrm>
-            <a:off x="1088136" y="5102352"/>
-            <a:ext cx="109728" cy="109728"/>
-          </a:xfrm>
-          <a:prstGeom prst="ellipse">
-            <a:avLst/>
-          </a:prstGeom>
-          <a:solidFill>
-            <a:srgbClr val="6C4CFF"/>
-          </a:solidFill>
-          <a:ln/>
-        </p:spPr>
-      </p:sp>
-      <p:sp>
-        <p:nvSpPr>
-          <p:cNvPr id="20" name="Text 18"/>
-          <p:cNvSpPr/>
-          <p:nvPr/>
-        </p:nvSpPr>
-        <p:spPr>
-          <a:xfrm>
-            <a:off x="1325880" y="5038344"/>
-            <a:ext cx="4206240" cy="274320"/>
-          </a:xfrm>
-          <a:prstGeom prst="rect">
-            <a:avLst/>
-          </a:prstGeom>
-          <a:noFill/>
-          <a:ln/>
-        </p:spPr>
-        <p:txBody>
-          <a:bodyPr wrap="square" lIns="0" tIns="0" rIns="0" bIns="0" rtlCol="0" anchor="t"/>
-          <a:lstStyle/>
-          <a:p>
-            <a:pPr algn="l" indent="0" marL="0">
-              <a:lnSpc>
-                <a:spcPct val="130000"/>
-              </a:lnSpc>
-              <a:buNone/>
-            </a:pPr>
-            <a:r>
-              <a:rPr lang="en-US" sz="1250" dirty="0">
-                <a:solidFill>
-                  <a:srgbClr val="6C4CFF"/>
-                </a:solidFill>
-                <a:latin typeface="Pretendard SemiBold" pitchFamily="34" charset="0"/>
-                <a:ea typeface="Pretendard SemiBold" pitchFamily="34" charset="-122"/>
-                <a:cs typeface="Pretendard SemiBold" pitchFamily="34" charset="-120"/>
-              </a:rPr>
-              <a:t>로그인 · 셋업 안내</a:t>
-            </a:r>
-            <a:endParaRPr lang="en-US" sz="1250" dirty="0"/>
-          </a:p>
-        </p:txBody>
-      </p:sp>
-      <p:sp>
-        <p:nvSpPr>
-          <p:cNvPr id="21" name="Text 19"/>
-          <p:cNvSpPr/>
-          <p:nvPr/>
-        </p:nvSpPr>
-        <p:spPr>
-          <a:xfrm>
-            <a:off x="1325880" y="5312664"/>
-            <a:ext cx="4206240" cy="274320"/>
-          </a:xfrm>
-          <a:prstGeom prst="rect">
-            <a:avLst/>
-          </a:prstGeom>
-          <a:noFill/>
-          <a:ln/>
-        </p:spPr>
-        <p:txBody>
-          <a:bodyPr wrap="square" lIns="0" tIns="0" rIns="0" bIns="0" rtlCol="0" anchor="t"/>
-          <a:lstStyle/>
-          <a:p>
-            <a:pPr algn="l" indent="0" marL="0">
-              <a:lnSpc>
-                <a:spcPct val="130000"/>
-              </a:lnSpc>
-              <a:buNone/>
-            </a:pPr>
-            <a:r>
-              <a:rPr lang="en-US" sz="1050" dirty="0">
-                <a:solidFill>
-                  <a:srgbClr val="55555A"/>
-                </a:solidFill>
-                <a:latin typeface="Pretendard" pitchFamily="34" charset="0"/>
-                <a:ea typeface="Pretendard" pitchFamily="34" charset="-122"/>
-                <a:cs typeface="Pretendard" pitchFamily="34" charset="-120"/>
-              </a:rPr>
-              <a:t>각자 컴퓨터 설정 위치  ·  어느 PC에서도 실행</a:t>
-            </a:r>
-            <a:endParaRPr lang="en-US" sz="1050" dirty="0"/>
-          </a:p>
-        </p:txBody>
-      </p:sp>
-      <p:sp>
-        <p:nvSpPr>
-          <p:cNvPr id="22" name="Shape 20"/>
+          <p:cNvPr id="25" name="Shape 23"/>
           <p:cNvSpPr/>
           <p:nvPr/>
         </p:nvSpPr>
@@ -10888,7 +11032,7 @@
       </p:sp>
       <p:sp>
         <p:nvSpPr>
-          <p:cNvPr id="23" name="Text 21"/>
+          <p:cNvPr id="26" name="Text 24"/>
           <p:cNvSpPr/>
           <p:nvPr/>
         </p:nvSpPr>
@@ -10922,7 +11066,7 @@
                 <a:ea typeface="Pretendard" pitchFamily="34" charset="-122"/>
                 <a:cs typeface="Pretendard" pitchFamily="34" charset="-120"/>
               </a:rPr>
-              <a:t>파일 구조는 이렇게 — 새 저장소 1개</a:t>
+              <a:t>이 가이드가 하는 일 (역할)</a:t>
             </a:r>
             <a:endParaRPr lang="en-US" sz="1300" dirty="0"/>
           </a:p>
@@ -10930,125 +11074,142 @@
       </p:sp>
       <p:sp>
         <p:nvSpPr>
-          <p:cNvPr id="24" name="Text 22"/>
-          <p:cNvSpPr/>
-          <p:nvPr/>
-        </p:nvSpPr>
-        <p:spPr>
-          <a:xfrm>
-            <a:off x="6263640" y="3035808"/>
-            <a:ext cx="3063240" cy="347472"/>
-          </a:xfrm>
-          <a:prstGeom prst="rect">
-            <a:avLst/>
-          </a:prstGeom>
-          <a:noFill/>
-          <a:ln/>
-        </p:spPr>
-        <p:txBody>
-          <a:bodyPr wrap="square" lIns="0" tIns="0" rIns="0" bIns="0" rtlCol="0" anchor="ctr"/>
-          <a:lstStyle/>
-          <a:p>
-            <a:pPr algn="l" indent="0" marL="0">
-              <a:lnSpc>
-                <a:spcPct val="100000"/>
-              </a:lnSpc>
-              <a:buNone/>
-            </a:pPr>
-            <a:r>
-              <a:rPr lang="en-US" sz="1050" dirty="0">
-                <a:solidFill>
-                  <a:srgbClr val="6C4CFF"/>
+          <p:cNvPr id="27" name="Shape 25"/>
+          <p:cNvSpPr/>
+          <p:nvPr/>
+        </p:nvSpPr>
+        <p:spPr>
+          <a:xfrm>
+            <a:off x="6263640" y="3081528"/>
+            <a:ext cx="365760" cy="365760"/>
+          </a:xfrm>
+          <a:prstGeom prst="ellipse">
+            <a:avLst/>
+          </a:prstGeom>
+          <a:solidFill>
+            <a:srgbClr val="6C4CFF"/>
+          </a:solidFill>
+          <a:ln/>
+        </p:spPr>
+      </p:sp>
+      <p:sp>
+        <p:nvSpPr>
+          <p:cNvPr id="28" name="Text 26"/>
+          <p:cNvSpPr/>
+          <p:nvPr/>
+        </p:nvSpPr>
+        <p:spPr>
+          <a:xfrm>
+            <a:off x="6263640" y="3081528"/>
+            <a:ext cx="365760" cy="365760"/>
+          </a:xfrm>
+          <a:prstGeom prst="rect">
+            <a:avLst/>
+          </a:prstGeom>
+          <a:noFill/>
+          <a:ln/>
+        </p:spPr>
+        <p:txBody>
+          <a:bodyPr wrap="square" lIns="0" tIns="0" rIns="0" bIns="0" rtlCol="0" anchor="ctr"/>
+          <a:lstStyle/>
+          <a:p>
+            <a:pPr algn="ctr" indent="0" marL="0">
+              <a:buNone/>
+            </a:pPr>
+            <a:r>
+              <a:rPr lang="en-US" sz="1300" b="1" dirty="0">
+                <a:solidFill>
+                  <a:srgbClr val="FFFFFF"/>
+                </a:solidFill>
+                <a:latin typeface="Pretendard" pitchFamily="34" charset="0"/>
+                <a:ea typeface="Pretendard" pitchFamily="34" charset="-122"/>
+                <a:cs typeface="Pretendard" pitchFamily="34" charset="-120"/>
+              </a:rPr>
+              <a:t>1</a:t>
+            </a:r>
+            <a:endParaRPr lang="en-US" sz="1300" dirty="0"/>
+          </a:p>
+        </p:txBody>
+      </p:sp>
+      <p:sp>
+        <p:nvSpPr>
+          <p:cNvPr id="29" name="Text 27"/>
+          <p:cNvSpPr/>
+          <p:nvPr/>
+        </p:nvSpPr>
+        <p:spPr>
+          <a:xfrm>
+            <a:off x="6766560" y="3063240"/>
+            <a:ext cx="4419295" cy="274320"/>
+          </a:xfrm>
+          <a:prstGeom prst="rect">
+            <a:avLst/>
+          </a:prstGeom>
+          <a:noFill/>
+          <a:ln/>
+        </p:spPr>
+        <p:txBody>
+          <a:bodyPr wrap="square" lIns="0" tIns="0" rIns="0" bIns="0" rtlCol="0" anchor="t"/>
+          <a:lstStyle/>
+          <a:p>
+            <a:pPr algn="l" indent="0" marL="0">
+              <a:lnSpc>
+                <a:spcPct val="130000"/>
+              </a:lnSpc>
+              <a:buNone/>
+            </a:pPr>
+            <a:r>
+              <a:rPr lang="en-US" sz="1300" dirty="0">
+                <a:solidFill>
+                  <a:srgbClr val="1D1D1F"/>
                 </a:solidFill>
                 <a:latin typeface="Pretendard SemiBold" pitchFamily="34" charset="0"/>
                 <a:ea typeface="Pretendard SemiBold" pitchFamily="34" charset="-122"/>
                 <a:cs typeface="Pretendard SemiBold" pitchFamily="34" charset="-120"/>
               </a:rPr>
-              <a:t>cdbd-plugin/</a:t>
-            </a:r>
-            <a:endParaRPr lang="en-US" sz="1050" dirty="0"/>
-          </a:p>
-        </p:txBody>
-      </p:sp>
-      <p:sp>
-        <p:nvSpPr>
-          <p:cNvPr id="25" name="Text 23"/>
-          <p:cNvSpPr/>
-          <p:nvPr/>
-        </p:nvSpPr>
-        <p:spPr>
-          <a:xfrm>
-            <a:off x="9418320" y="3035808"/>
-            <a:ext cx="1721815" cy="347472"/>
-          </a:xfrm>
-          <a:prstGeom prst="rect">
-            <a:avLst/>
-          </a:prstGeom>
-          <a:noFill/>
-          <a:ln/>
-        </p:spPr>
-        <p:txBody>
-          <a:bodyPr wrap="square" lIns="0" tIns="0" rIns="0" bIns="0" rtlCol="0" anchor="ctr"/>
-          <a:lstStyle/>
-          <a:p>
-            <a:pPr algn="l" indent="0" marL="0">
-              <a:lnSpc>
-                <a:spcPct val="100000"/>
-              </a:lnSpc>
-              <a:buNone/>
-            </a:pPr>
-            <a:r>
-              <a:rPr lang="en-US" sz="1000" dirty="0">
-                <a:solidFill>
-                  <a:srgbClr val="6C4CFF"/>
+              <a:t>위치 무관 발견</a:t>
+            </a:r>
+            <a:endParaRPr lang="en-US" sz="1300" dirty="0"/>
+          </a:p>
+        </p:txBody>
+      </p:sp>
+      <p:sp>
+        <p:nvSpPr>
+          <p:cNvPr id="30" name="Text 28"/>
+          <p:cNvSpPr/>
+          <p:nvPr/>
+        </p:nvSpPr>
+        <p:spPr>
+          <a:xfrm>
+            <a:off x="6766560" y="3364992"/>
+            <a:ext cx="4373575" cy="640080"/>
+          </a:xfrm>
+          <a:prstGeom prst="rect">
+            <a:avLst/>
+          </a:prstGeom>
+          <a:noFill/>
+          <a:ln/>
+        </p:spPr>
+        <p:txBody>
+          <a:bodyPr wrap="square" lIns="0" tIns="0" rIns="0" bIns="0" rtlCol="0" anchor="t"/>
+          <a:lstStyle/>
+          <a:p>
+            <a:pPr algn="l" indent="0" marL="0">
+              <a:lnSpc>
+                <a:spcPct val="135000"/>
+              </a:lnSpc>
+              <a:buNone/>
+            </a:pPr>
+            <a:r>
+              <a:rPr lang="en-US" sz="1050" dirty="0">
+                <a:solidFill>
+                  <a:srgbClr val="55555A"/>
                 </a:solidFill>
                 <a:latin typeface="Pretendard" pitchFamily="34" charset="0"/>
                 <a:ea typeface="Pretendard" pitchFamily="34" charset="-122"/>
                 <a:cs typeface="Pretendard" pitchFamily="34" charset="-120"/>
               </a:rPr>
-              <a:t>신규 저장소</a:t>
-            </a:r>
-            <a:endParaRPr lang="en-US" sz="1000" dirty="0"/>
-          </a:p>
-        </p:txBody>
-      </p:sp>
-      <p:sp>
-        <p:nvSpPr>
-          <p:cNvPr id="26" name="Text 24"/>
-          <p:cNvSpPr/>
-          <p:nvPr/>
-        </p:nvSpPr>
-        <p:spPr>
-          <a:xfrm>
-            <a:off x="6263640" y="3383280"/>
-            <a:ext cx="3063240" cy="347472"/>
-          </a:xfrm>
-          <a:prstGeom prst="rect">
-            <a:avLst/>
-          </a:prstGeom>
-          <a:noFill/>
-          <a:ln/>
-        </p:spPr>
-        <p:txBody>
-          <a:bodyPr wrap="square" lIns="0" tIns="0" rIns="0" bIns="0" rtlCol="0" anchor="ctr"/>
-          <a:lstStyle/>
-          <a:p>
-            <a:pPr algn="l" indent="0" marL="0">
-              <a:lnSpc>
-                <a:spcPct val="100000"/>
-              </a:lnSpc>
-              <a:buNone/>
-            </a:pPr>
-            <a:r>
-              <a:rPr lang="en-US" sz="1050" dirty="0">
-                <a:solidFill>
-                  <a:srgbClr val="1D1D1F"/>
-                </a:solidFill>
-                <a:latin typeface="Pretendard Medium" pitchFamily="34" charset="0"/>
-                <a:ea typeface="Pretendard Medium" pitchFamily="34" charset="-122"/>
-                <a:cs typeface="Pretendard Medium" pitchFamily="34" charset="-120"/>
-              </a:rPr>
-              <a:t>├─ .claude-plugin/marketplace.json</a:t>
+              <a:t>볼트별 가이드는 그 볼트를 켰을 때만. 통합 가이드는 어느 볼트·맨 바깥에서 켜도 전 CdBd 기능을 안다.</a:t>
             </a:r>
             <a:endParaRPr lang="en-US" sz="1050" dirty="0"/>
           </a:p>
@@ -11056,75 +11217,92 @@
       </p:sp>
       <p:sp>
         <p:nvSpPr>
-          <p:cNvPr id="27" name="Text 25"/>
-          <p:cNvSpPr/>
-          <p:nvPr/>
-        </p:nvSpPr>
-        <p:spPr>
-          <a:xfrm>
-            <a:off x="9418320" y="3383280"/>
-            <a:ext cx="1721815" cy="347472"/>
-          </a:xfrm>
-          <a:prstGeom prst="rect">
-            <a:avLst/>
-          </a:prstGeom>
-          <a:noFill/>
-          <a:ln/>
-        </p:spPr>
-        <p:txBody>
-          <a:bodyPr wrap="square" lIns="0" tIns="0" rIns="0" bIns="0" rtlCol="0" anchor="ctr"/>
-          <a:lstStyle/>
-          <a:p>
-            <a:pPr algn="l" indent="0" marL="0">
-              <a:lnSpc>
-                <a:spcPct val="100000"/>
-              </a:lnSpc>
-              <a:buNone/>
-            </a:pPr>
-            <a:r>
-              <a:rPr lang="en-US" sz="1000" dirty="0">
-                <a:solidFill>
-                  <a:srgbClr val="6C4CFF"/>
+          <p:cNvPr id="31" name="Shape 29"/>
+          <p:cNvSpPr/>
+          <p:nvPr/>
+        </p:nvSpPr>
+        <p:spPr>
+          <a:xfrm>
+            <a:off x="6263640" y="4041648"/>
+            <a:ext cx="365760" cy="365760"/>
+          </a:xfrm>
+          <a:prstGeom prst="ellipse">
+            <a:avLst/>
+          </a:prstGeom>
+          <a:solidFill>
+            <a:srgbClr val="6C4CFF"/>
+          </a:solidFill>
+          <a:ln/>
+        </p:spPr>
+      </p:sp>
+      <p:sp>
+        <p:nvSpPr>
+          <p:cNvPr id="32" name="Text 30"/>
+          <p:cNvSpPr/>
+          <p:nvPr/>
+        </p:nvSpPr>
+        <p:spPr>
+          <a:xfrm>
+            <a:off x="6263640" y="4041648"/>
+            <a:ext cx="365760" cy="365760"/>
+          </a:xfrm>
+          <a:prstGeom prst="rect">
+            <a:avLst/>
+          </a:prstGeom>
+          <a:noFill/>
+          <a:ln/>
+        </p:spPr>
+        <p:txBody>
+          <a:bodyPr wrap="square" lIns="0" tIns="0" rIns="0" bIns="0" rtlCol="0" anchor="ctr"/>
+          <a:lstStyle/>
+          <a:p>
+            <a:pPr algn="ctr" indent="0" marL="0">
+              <a:buNone/>
+            </a:pPr>
+            <a:r>
+              <a:rPr lang="en-US" sz="1300" b="1" dirty="0">
+                <a:solidFill>
+                  <a:srgbClr val="FFFFFF"/>
                 </a:solidFill>
                 <a:latin typeface="Pretendard" pitchFamily="34" charset="0"/>
                 <a:ea typeface="Pretendard" pitchFamily="34" charset="-122"/>
                 <a:cs typeface="Pretendard" pitchFamily="34" charset="-120"/>
               </a:rPr>
-              <a:t>마켓 정의</a:t>
-            </a:r>
-            <a:endParaRPr lang="en-US" sz="1000" dirty="0"/>
-          </a:p>
-        </p:txBody>
-      </p:sp>
-      <p:sp>
-        <p:nvSpPr>
-          <p:cNvPr id="28" name="Text 26"/>
-          <p:cNvSpPr/>
-          <p:nvPr/>
-        </p:nvSpPr>
-        <p:spPr>
-          <a:xfrm>
-            <a:off x="6263640" y="3730752"/>
-            <a:ext cx="3063240" cy="347472"/>
-          </a:xfrm>
-          <a:prstGeom prst="rect">
-            <a:avLst/>
-          </a:prstGeom>
-          <a:noFill/>
-          <a:ln/>
-        </p:spPr>
-        <p:txBody>
-          <a:bodyPr wrap="square" lIns="0" tIns="0" rIns="0" bIns="0" rtlCol="0" anchor="ctr"/>
-          <a:lstStyle/>
-          <a:p>
-            <a:pPr algn="l" indent="0" marL="0">
-              <a:lnSpc>
-                <a:spcPct val="100000"/>
-              </a:lnSpc>
-              <a:buNone/>
-            </a:pPr>
-            <a:r>
-              <a:rPr lang="en-US" sz="1050" dirty="0">
+              <a:t>2</a:t>
+            </a:r>
+            <a:endParaRPr lang="en-US" sz="1300" dirty="0"/>
+          </a:p>
+        </p:txBody>
+      </p:sp>
+      <p:sp>
+        <p:nvSpPr>
+          <p:cNvPr id="33" name="Text 31"/>
+          <p:cNvSpPr/>
+          <p:nvPr/>
+        </p:nvSpPr>
+        <p:spPr>
+          <a:xfrm>
+            <a:off x="6766560" y="4023360"/>
+            <a:ext cx="4419295" cy="274320"/>
+          </a:xfrm>
+          <a:prstGeom prst="rect">
+            <a:avLst/>
+          </a:prstGeom>
+          <a:noFill/>
+          <a:ln/>
+        </p:spPr>
+        <p:txBody>
+          <a:bodyPr wrap="square" lIns="0" tIns="0" rIns="0" bIns="0" rtlCol="0" anchor="t"/>
+          <a:lstStyle/>
+          <a:p>
+            <a:pPr algn="l" indent="0" marL="0">
+              <a:lnSpc>
+                <a:spcPct val="130000"/>
+              </a:lnSpc>
+              <a:buNone/>
+            </a:pPr>
+            <a:r>
+              <a:rPr lang="en-US" sz="1300" dirty="0">
                 <a:solidFill>
                   <a:srgbClr val="1D1D1F"/>
                 </a:solidFill>
@@ -11132,133 +11310,49 @@
                 <a:ea typeface="Pretendard SemiBold" pitchFamily="34" charset="-122"/>
                 <a:cs typeface="Pretendard SemiBold" pitchFamily="34" charset="-120"/>
               </a:rPr>
-              <a:t>└─ plugins/cdbd/</a:t>
-            </a:r>
-            <a:endParaRPr lang="en-US" sz="1050" dirty="0"/>
-          </a:p>
-        </p:txBody>
-      </p:sp>
-      <p:sp>
-        <p:nvSpPr>
-          <p:cNvPr id="29" name="Text 27"/>
-          <p:cNvSpPr/>
-          <p:nvPr/>
-        </p:nvSpPr>
-        <p:spPr>
-          <a:xfrm>
-            <a:off x="6263640" y="4078224"/>
-            <a:ext cx="3063240" cy="347472"/>
-          </a:xfrm>
-          <a:prstGeom prst="rect">
-            <a:avLst/>
-          </a:prstGeom>
-          <a:noFill/>
-          <a:ln/>
-        </p:spPr>
-        <p:txBody>
-          <a:bodyPr wrap="square" lIns="0" tIns="0" rIns="0" bIns="0" rtlCol="0" anchor="ctr"/>
-          <a:lstStyle/>
-          <a:p>
-            <a:pPr algn="l" indent="0" marL="0">
-              <a:lnSpc>
-                <a:spcPct val="100000"/>
+              <a:t>볼트를 넘는 라우팅</a:t>
+            </a:r>
+            <a:endParaRPr lang="en-US" sz="1300" dirty="0"/>
+          </a:p>
+        </p:txBody>
+      </p:sp>
+      <p:sp>
+        <p:nvSpPr>
+          <p:cNvPr id="34" name="Text 32"/>
+          <p:cNvSpPr/>
+          <p:nvPr/>
+        </p:nvSpPr>
+        <p:spPr>
+          <a:xfrm>
+            <a:off x="6766560" y="4325112"/>
+            <a:ext cx="4373575" cy="640080"/>
+          </a:xfrm>
+          <a:prstGeom prst="rect">
+            <a:avLst/>
+          </a:prstGeom>
+          <a:noFill/>
+          <a:ln/>
+        </p:spPr>
+        <p:txBody>
+          <a:bodyPr wrap="square" lIns="0" tIns="0" rIns="0" bIns="0" rtlCol="0" anchor="t"/>
+          <a:lstStyle/>
+          <a:p>
+            <a:pPr algn="l" indent="0" marL="0">
+              <a:lnSpc>
+                <a:spcPct val="135000"/>
               </a:lnSpc>
               <a:buNone/>
             </a:pPr>
             <a:r>
               <a:rPr lang="en-US" sz="1050" dirty="0">
                 <a:solidFill>
-                  <a:srgbClr val="1D1D1F"/>
-                </a:solidFill>
-                <a:latin typeface="Pretendard Medium" pitchFamily="34" charset="0"/>
-                <a:ea typeface="Pretendard Medium" pitchFamily="34" charset="-122"/>
-                <a:cs typeface="Pretendard Medium" pitchFamily="34" charset="-120"/>
-              </a:rPr>
-              <a:t>     ├─ 통합 기능 경로 가이드.md</a:t>
-            </a:r>
-            <a:endParaRPr lang="en-US" sz="1050" dirty="0"/>
-          </a:p>
-        </p:txBody>
-      </p:sp>
-      <p:sp>
-        <p:nvSpPr>
-          <p:cNvPr id="30" name="Text 28"/>
-          <p:cNvSpPr/>
-          <p:nvPr/>
-        </p:nvSpPr>
-        <p:spPr>
-          <a:xfrm>
-            <a:off x="9418320" y="4078224"/>
-            <a:ext cx="1721815" cy="347472"/>
-          </a:xfrm>
-          <a:prstGeom prst="rect">
-            <a:avLst/>
-          </a:prstGeom>
-          <a:noFill/>
-          <a:ln/>
-        </p:spPr>
-        <p:txBody>
-          <a:bodyPr wrap="square" lIns="0" tIns="0" rIns="0" bIns="0" rtlCol="0" anchor="ctr"/>
-          <a:lstStyle/>
-          <a:p>
-            <a:pPr algn="l" indent="0" marL="0">
-              <a:lnSpc>
-                <a:spcPct val="100000"/>
-              </a:lnSpc>
-              <a:buNone/>
-            </a:pPr>
-            <a:r>
-              <a:rPr lang="en-US" sz="1000" dirty="0">
-                <a:solidFill>
-                  <a:srgbClr val="6C4CFF"/>
+                  <a:srgbClr val="55555A"/>
                 </a:solidFill>
                 <a:latin typeface="Pretendard" pitchFamily="34" charset="0"/>
                 <a:ea typeface="Pretendard" pitchFamily="34" charset="-122"/>
                 <a:cs typeface="Pretendard" pitchFamily="34" charset="-120"/>
               </a:rPr>
-              <a:t>전 볼트 기능→파일</a:t>
-            </a:r>
-            <a:endParaRPr lang="en-US" sz="1000" dirty="0"/>
-          </a:p>
-        </p:txBody>
-      </p:sp>
-      <p:sp>
-        <p:nvSpPr>
-          <p:cNvPr id="31" name="Text 29"/>
-          <p:cNvSpPr/>
-          <p:nvPr/>
-        </p:nvSpPr>
-        <p:spPr>
-          <a:xfrm>
-            <a:off x="6263640" y="4425696"/>
-            <a:ext cx="3063240" cy="347472"/>
-          </a:xfrm>
-          <a:prstGeom prst="rect">
-            <a:avLst/>
-          </a:prstGeom>
-          <a:noFill/>
-          <a:ln/>
-        </p:spPr>
-        <p:txBody>
-          <a:bodyPr wrap="square" lIns="0" tIns="0" rIns="0" bIns="0" rtlCol="0" anchor="ctr"/>
-          <a:lstStyle/>
-          <a:p>
-            <a:pPr algn="l" indent="0" marL="0">
-              <a:lnSpc>
-                <a:spcPct val="100000"/>
-              </a:lnSpc>
-              <a:buNone/>
-            </a:pPr>
-            <a:r>
-              <a:rPr lang="en-US" sz="1050" dirty="0">
-                <a:solidFill>
-                  <a:srgbClr val="1D1D1F"/>
-                </a:solidFill>
-                <a:latin typeface="Pretendard Medium" pitchFamily="34" charset="0"/>
-                <a:ea typeface="Pretendard Medium" pitchFamily="34" charset="-122"/>
-                <a:cs typeface="Pretendard Medium" pitchFamily="34" charset="-120"/>
-              </a:rPr>
-              <a:t>     ├─ 브랜드 토큰.md</a:t>
+              <a:t>templates에서 “URL 게시해줘” → “그건 design-service 1-4에 있다”고 안내. 볼트 경계를 알아서 넘는다.</a:t>
             </a:r>
             <a:endParaRPr lang="en-US" sz="1050" dirty="0"/>
           </a:p>
@@ -11266,253 +11360,144 @@
       </p:sp>
       <p:sp>
         <p:nvSpPr>
-          <p:cNvPr id="32" name="Text 30"/>
-          <p:cNvSpPr/>
-          <p:nvPr/>
-        </p:nvSpPr>
-        <p:spPr>
-          <a:xfrm>
-            <a:off x="9418320" y="4425696"/>
-            <a:ext cx="1721815" cy="347472"/>
-          </a:xfrm>
-          <a:prstGeom prst="rect">
-            <a:avLst/>
-          </a:prstGeom>
-          <a:noFill/>
-          <a:ln/>
-        </p:spPr>
-        <p:txBody>
-          <a:bodyPr wrap="square" lIns="0" tIns="0" rIns="0" bIns="0" rtlCol="0" anchor="ctr"/>
-          <a:lstStyle/>
-          <a:p>
-            <a:pPr algn="l" indent="0" marL="0">
-              <a:lnSpc>
-                <a:spcPct val="100000"/>
-              </a:lnSpc>
-              <a:buNone/>
-            </a:pPr>
-            <a:r>
-              <a:rPr lang="en-US" sz="1000" dirty="0">
-                <a:solidFill>
-                  <a:srgbClr val="6C4CFF"/>
+          <p:cNvPr id="35" name="Shape 33"/>
+          <p:cNvSpPr/>
+          <p:nvPr/>
+        </p:nvSpPr>
+        <p:spPr>
+          <a:xfrm>
+            <a:off x="6263640" y="5001768"/>
+            <a:ext cx="365760" cy="365760"/>
+          </a:xfrm>
+          <a:prstGeom prst="ellipse">
+            <a:avLst/>
+          </a:prstGeom>
+          <a:solidFill>
+            <a:srgbClr val="6C4CFF"/>
+          </a:solidFill>
+          <a:ln/>
+        </p:spPr>
+      </p:sp>
+      <p:sp>
+        <p:nvSpPr>
+          <p:cNvPr id="36" name="Text 34"/>
+          <p:cNvSpPr/>
+          <p:nvPr/>
+        </p:nvSpPr>
+        <p:spPr>
+          <a:xfrm>
+            <a:off x="6263640" y="5001768"/>
+            <a:ext cx="365760" cy="365760"/>
+          </a:xfrm>
+          <a:prstGeom prst="rect">
+            <a:avLst/>
+          </a:prstGeom>
+          <a:noFill/>
+          <a:ln/>
+        </p:spPr>
+        <p:txBody>
+          <a:bodyPr wrap="square" lIns="0" tIns="0" rIns="0" bIns="0" rtlCol="0" anchor="ctr"/>
+          <a:lstStyle/>
+          <a:p>
+            <a:pPr algn="ctr" indent="0" marL="0">
+              <a:buNone/>
+            </a:pPr>
+            <a:r>
+              <a:rPr lang="en-US" sz="1300" b="1" dirty="0">
+                <a:solidFill>
+                  <a:srgbClr val="FFFFFF"/>
                 </a:solidFill>
                 <a:latin typeface="Pretendard" pitchFamily="34" charset="0"/>
                 <a:ea typeface="Pretendard" pitchFamily="34" charset="-122"/>
                 <a:cs typeface="Pretendard" pitchFamily="34" charset="-120"/>
               </a:rPr>
-              <a:t>컬러·폰트</a:t>
-            </a:r>
-            <a:endParaRPr lang="en-US" sz="1000" dirty="0"/>
-          </a:p>
-        </p:txBody>
-      </p:sp>
-      <p:sp>
-        <p:nvSpPr>
-          <p:cNvPr id="33" name="Text 31"/>
-          <p:cNvSpPr/>
-          <p:nvPr/>
-        </p:nvSpPr>
-        <p:spPr>
-          <a:xfrm>
-            <a:off x="6263640" y="4773168"/>
-            <a:ext cx="3063240" cy="347472"/>
-          </a:xfrm>
-          <a:prstGeom prst="rect">
-            <a:avLst/>
-          </a:prstGeom>
-          <a:noFill/>
-          <a:ln/>
-        </p:spPr>
-        <p:txBody>
-          <a:bodyPr wrap="square" lIns="0" tIns="0" rIns="0" bIns="0" rtlCol="0" anchor="ctr"/>
-          <a:lstStyle/>
-          <a:p>
-            <a:pPr algn="l" indent="0" marL="0">
-              <a:lnSpc>
-                <a:spcPct val="100000"/>
+              <a:t>3</a:t>
+            </a:r>
+            <a:endParaRPr lang="en-US" sz="1300" dirty="0"/>
+          </a:p>
+        </p:txBody>
+      </p:sp>
+      <p:sp>
+        <p:nvSpPr>
+          <p:cNvPr id="37" name="Text 35"/>
+          <p:cNvSpPr/>
+          <p:nvPr/>
+        </p:nvSpPr>
+        <p:spPr>
+          <a:xfrm>
+            <a:off x="6766560" y="4983480"/>
+            <a:ext cx="4419295" cy="274320"/>
+          </a:xfrm>
+          <a:prstGeom prst="rect">
+            <a:avLst/>
+          </a:prstGeom>
+          <a:noFill/>
+          <a:ln/>
+        </p:spPr>
+        <p:txBody>
+          <a:bodyPr wrap="square" lIns="0" tIns="0" rIns="0" bIns="0" rtlCol="0" anchor="t"/>
+          <a:lstStyle/>
+          <a:p>
+            <a:pPr algn="l" indent="0" marL="0">
+              <a:lnSpc>
+                <a:spcPct val="130000"/>
+              </a:lnSpc>
+              <a:buNone/>
+            </a:pPr>
+            <a:r>
+              <a:rPr lang="en-US" sz="1300" dirty="0">
+                <a:solidFill>
+                  <a:srgbClr val="1D1D1F"/>
+                </a:solidFill>
+                <a:latin typeface="Pretendard SemiBold" pitchFamily="34" charset="0"/>
+                <a:ea typeface="Pretendard SemiBold" pitchFamily="34" charset="-122"/>
+                <a:cs typeface="Pretendard SemiBold" pitchFamily="34" charset="-120"/>
+              </a:rPr>
+              <a:t>한 번 고치면 전원 최신</a:t>
+            </a:r>
+            <a:endParaRPr lang="en-US" sz="1300" dirty="0"/>
+          </a:p>
+        </p:txBody>
+      </p:sp>
+      <p:sp>
+        <p:nvSpPr>
+          <p:cNvPr id="38" name="Text 36"/>
+          <p:cNvSpPr/>
+          <p:nvPr/>
+        </p:nvSpPr>
+        <p:spPr>
+          <a:xfrm>
+            <a:off x="6766560" y="5285232"/>
+            <a:ext cx="4373575" cy="640080"/>
+          </a:xfrm>
+          <a:prstGeom prst="rect">
+            <a:avLst/>
+          </a:prstGeom>
+          <a:noFill/>
+          <a:ln/>
+        </p:spPr>
+        <p:txBody>
+          <a:bodyPr wrap="square" lIns="0" tIns="0" rIns="0" bIns="0" rtlCol="0" anchor="t"/>
+          <a:lstStyle/>
+          <a:p>
+            <a:pPr algn="l" indent="0" marL="0">
+              <a:lnSpc>
+                <a:spcPct val="135000"/>
               </a:lnSpc>
               <a:buNone/>
             </a:pPr>
             <a:r>
               <a:rPr lang="en-US" sz="1050" dirty="0">
                 <a:solidFill>
-                  <a:srgbClr val="1D1D1F"/>
-                </a:solidFill>
-                <a:latin typeface="Pretendard Medium" pitchFamily="34" charset="0"/>
-                <a:ea typeface="Pretendard Medium" pitchFamily="34" charset="-122"/>
-                <a:cs typeface="Pretendard Medium" pitchFamily="34" charset="-120"/>
-              </a:rPr>
-              <a:t>     ├─ .mcp.json</a:t>
-            </a:r>
-            <a:endParaRPr lang="en-US" sz="1050" dirty="0"/>
-          </a:p>
-        </p:txBody>
-      </p:sp>
-      <p:sp>
-        <p:nvSpPr>
-          <p:cNvPr id="34" name="Text 32"/>
-          <p:cNvSpPr/>
-          <p:nvPr/>
-        </p:nvSpPr>
-        <p:spPr>
-          <a:xfrm>
-            <a:off x="9418320" y="4773168"/>
-            <a:ext cx="1721815" cy="347472"/>
-          </a:xfrm>
-          <a:prstGeom prst="rect">
-            <a:avLst/>
-          </a:prstGeom>
-          <a:noFill/>
-          <a:ln/>
-        </p:spPr>
-        <p:txBody>
-          <a:bodyPr wrap="square" lIns="0" tIns="0" rIns="0" bIns="0" rtlCol="0" anchor="ctr"/>
-          <a:lstStyle/>
-          <a:p>
-            <a:pPr algn="l" indent="0" marL="0">
-              <a:lnSpc>
-                <a:spcPct val="100000"/>
-              </a:lnSpc>
-              <a:buNone/>
-            </a:pPr>
-            <a:r>
-              <a:rPr lang="en-US" sz="1000" dirty="0">
-                <a:solidFill>
-                  <a:srgbClr val="6C4CFF"/>
+                  <a:srgbClr val="55555A"/>
                 </a:solidFill>
                 <a:latin typeface="Pretendard" pitchFamily="34" charset="0"/>
                 <a:ea typeface="Pretendard" pitchFamily="34" charset="-122"/>
                 <a:cs typeface="Pretendard" pitchFamily="34" charset="-120"/>
               </a:rPr>
-              <a:t>Figma</a:t>
-            </a:r>
-            <a:endParaRPr lang="en-US" sz="1000" dirty="0"/>
-          </a:p>
-        </p:txBody>
-      </p:sp>
-      <p:sp>
-        <p:nvSpPr>
-          <p:cNvPr id="35" name="Text 33"/>
-          <p:cNvSpPr/>
-          <p:nvPr/>
-        </p:nvSpPr>
-        <p:spPr>
-          <a:xfrm>
-            <a:off x="6263640" y="5120640"/>
-            <a:ext cx="3063240" cy="347472"/>
-          </a:xfrm>
-          <a:prstGeom prst="rect">
-            <a:avLst/>
-          </a:prstGeom>
-          <a:noFill/>
-          <a:ln/>
-        </p:spPr>
-        <p:txBody>
-          <a:bodyPr wrap="square" lIns="0" tIns="0" rIns="0" bIns="0" rtlCol="0" anchor="ctr"/>
-          <a:lstStyle/>
-          <a:p>
-            <a:pPr algn="l" indent="0" marL="0">
-              <a:lnSpc>
-                <a:spcPct val="100000"/>
-              </a:lnSpc>
-              <a:buNone/>
-            </a:pPr>
-            <a:r>
-              <a:rPr lang="en-US" sz="1050" dirty="0">
-                <a:solidFill>
-                  <a:srgbClr val="1D1D1F"/>
-                </a:solidFill>
-                <a:latin typeface="Pretendard Medium" pitchFamily="34" charset="0"/>
-                <a:ea typeface="Pretendard Medium" pitchFamily="34" charset="-122"/>
-                <a:cs typeface="Pretendard Medium" pitchFamily="34" charset="-120"/>
-              </a:rPr>
-              <a:t>     └─ ONBOARDING.md</a:t>
+              <a:t>push하면 마켓플레이스로 팀 전원에 자동 반영. 볼트마다 손댈 필요 없다.</a:t>
             </a:r>
             <a:endParaRPr lang="en-US" sz="1050" dirty="0"/>
-          </a:p>
-        </p:txBody>
-      </p:sp>
-      <p:sp>
-        <p:nvSpPr>
-          <p:cNvPr id="36" name="Text 34"/>
-          <p:cNvSpPr/>
-          <p:nvPr/>
-        </p:nvSpPr>
-        <p:spPr>
-          <a:xfrm>
-            <a:off x="9418320" y="5120640"/>
-            <a:ext cx="1721815" cy="347472"/>
-          </a:xfrm>
-          <a:prstGeom prst="rect">
-            <a:avLst/>
-          </a:prstGeom>
-          <a:noFill/>
-          <a:ln/>
-        </p:spPr>
-        <p:txBody>
-          <a:bodyPr wrap="square" lIns="0" tIns="0" rIns="0" bIns="0" rtlCol="0" anchor="ctr"/>
-          <a:lstStyle/>
-          <a:p>
-            <a:pPr algn="l" indent="0" marL="0">
-              <a:lnSpc>
-                <a:spcPct val="100000"/>
-              </a:lnSpc>
-              <a:buNone/>
-            </a:pPr>
-            <a:r>
-              <a:rPr lang="en-US" sz="1000" dirty="0">
-                <a:solidFill>
-                  <a:srgbClr val="6C4CFF"/>
-                </a:solidFill>
-                <a:latin typeface="Pretendard" pitchFamily="34" charset="0"/>
-                <a:ea typeface="Pretendard" pitchFamily="34" charset="-122"/>
-                <a:cs typeface="Pretendard" pitchFamily="34" charset="-120"/>
-              </a:rPr>
-              <a:t>로그인·셋업</a:t>
-            </a:r>
-            <a:endParaRPr lang="en-US" sz="1000" dirty="0"/>
-          </a:p>
-        </p:txBody>
-      </p:sp>
-      <p:sp>
-        <p:nvSpPr>
-          <p:cNvPr id="37" name="Text 35"/>
-          <p:cNvSpPr/>
-          <p:nvPr/>
-        </p:nvSpPr>
-        <p:spPr>
-          <a:xfrm>
-            <a:off x="6263640" y="5623560"/>
-            <a:ext cx="4876495" cy="274320"/>
-          </a:xfrm>
-          <a:prstGeom prst="rect">
-            <a:avLst/>
-          </a:prstGeom>
-          <a:noFill/>
-          <a:ln/>
-        </p:spPr>
-        <p:txBody>
-          <a:bodyPr wrap="square" lIns="0" tIns="0" rIns="0" bIns="0" rtlCol="0" anchor="t"/>
-          <a:lstStyle/>
-          <a:p>
-            <a:pPr algn="l" indent="0" marL="0">
-              <a:lnSpc>
-                <a:spcPct val="130000"/>
-              </a:lnSpc>
-              <a:buNone/>
-            </a:pPr>
-            <a:r>
-              <a:rPr lang="en-US" sz="1100" dirty="0">
-                <a:solidFill>
-                  <a:srgbClr val="1D1D1F"/>
-                </a:solidFill>
-                <a:latin typeface="Pretendard SemiBold" pitchFamily="34" charset="0"/>
-                <a:ea typeface="Pretendard SemiBold" pitchFamily="34" charset="-122"/>
-                <a:cs typeface="Pretendard SemiBold" pitchFamily="34" charset="-120"/>
-              </a:rPr>
-              <a:t>design/ 및 5개 볼트 → 구조 그대로 (안 바뀜)</a:t>
-            </a:r>
-            <a:endParaRPr lang="en-US" sz="1100" dirty="0"/>
           </a:p>
         </p:txBody>
       </p:sp>

</xml_diff>

<commit_message>
vault backup: 2026-08-11 21:29:43
</commit_message>
<xml_diff>
--- a/CdBd 기능 문서 구조 설계.pptx
+++ b/CdBd 기능 문서 구조 설계.pptx
@@ -11775,7 +11775,7 @@
                 <a:ea typeface="Pretendard" pitchFamily="34" charset="-122"/>
                 <a:cs typeface="Pretendard" pitchFamily="34" charset="-120"/>
               </a:rPr>
-              <a:t>5개 볼트 것을 합쳐 ‘이렇게 말하면 → 어느 볼트의 어느 파일’을 한 곳에.</a:t>
+              <a:t>10p 분류(에디터·대시보드) 그대로 + 다른 볼트 작업까지 합쳐, ‘어느 기능이 어느 파일에’.</a:t>
             </a:r>
             <a:endParaRPr lang="en-US" sz="1500" dirty="0"/>
           </a:p>
@@ -11861,30 +11861,45 @@
       </p:sp>
       <p:sp>
         <p:nvSpPr>
-          <p:cNvPr id="8" name="Shape 6"/>
-          <p:cNvSpPr/>
-          <p:nvPr/>
-        </p:nvSpPr>
-        <p:spPr>
-          <a:xfrm>
-            <a:off x="777240" y="2331720"/>
-            <a:ext cx="10637215" cy="3456432"/>
-          </a:xfrm>
-          <a:prstGeom prst="roundRect">
-            <a:avLst>
-              <a:gd name="adj" fmla="val 3175"/>
-            </a:avLst>
-          </a:prstGeom>
-          <a:solidFill>
-            <a:srgbClr val="FFFFFF"/>
-          </a:solidFill>
-          <a:ln w="12700">
-            <a:solidFill>
-              <a:srgbClr val="E5E7EB"/>
-            </a:solidFill>
-            <a:prstDash val="solid"/>
-          </a:ln>
-        </p:spPr>
+          <p:cNvPr id="8" name="Text 6"/>
+          <p:cNvSpPr/>
+          <p:nvPr/>
+        </p:nvSpPr>
+        <p:spPr>
+          <a:xfrm>
+            <a:off x="5470855" y="1847088"/>
+            <a:ext cx="5943600" cy="256032"/>
+          </a:xfrm>
+          <a:prstGeom prst="rect">
+            <a:avLst/>
+          </a:prstGeom>
+          <a:noFill/>
+          <a:ln/>
+        </p:spPr>
+        <p:txBody>
+          <a:bodyPr wrap="square" lIns="0" tIns="0" rIns="0" bIns="0" rtlCol="0" anchor="ctr"/>
+          <a:lstStyle/>
+          <a:p>
+            <a:pPr algn="r" indent="0" marL="0">
+              <a:lnSpc>
+                <a:spcPct val="130000"/>
+              </a:lnSpc>
+              <a:buNone/>
+            </a:pPr>
+            <a:r>
+              <a:rPr lang="en-US" sz="1000" dirty="0">
+                <a:solidFill>
+                  <a:srgbClr val="6E6E73"/>
+                </a:solidFill>
+                <a:latin typeface="Pretendard Medium" pitchFamily="34" charset="0"/>
+                <a:ea typeface="Pretendard Medium" pitchFamily="34" charset="-122"/>
+                <a:cs typeface="Pretendard Medium" pitchFamily="34" charset="-120"/>
+              </a:rPr>
+              <a:t>[T] templates  [SV] design-service  [DS] design-system</a:t>
+            </a:r>
+            <a:endParaRPr lang="en-US" sz="1000" dirty="0"/>
+          </a:p>
+        </p:txBody>
       </p:sp>
       <p:sp>
         <p:nvSpPr>
@@ -11894,8 +11909,8 @@
         </p:nvSpPr>
         <p:spPr>
           <a:xfrm>
-            <a:off x="1069848" y="2478024"/>
-            <a:ext cx="3840480" cy="274320"/>
+            <a:off x="777240" y="2286000"/>
+            <a:ext cx="5074920" cy="274320"/>
           </a:xfrm>
           <a:prstGeom prst="rect">
             <a:avLst/>
@@ -11914,7 +11929,7 @@
               <a:buNone/>
             </a:pPr>
             <a:r>
-              <a:rPr lang="en-US" sz="1200" dirty="0">
+              <a:rPr lang="en-US" sz="1250" dirty="0">
                 <a:solidFill>
                   <a:srgbClr val="6C4CFF"/>
                 </a:solidFill>
@@ -11922,106 +11937,22 @@
                 <a:ea typeface="Pretendard SemiBold" pitchFamily="34" charset="-122"/>
                 <a:cs typeface="Pretendard SemiBold" pitchFamily="34" charset="-120"/>
               </a:rPr>
-              <a:t>이렇게 말하면</a:t>
-            </a:r>
-            <a:endParaRPr lang="en-US" sz="1200" dirty="0"/>
-          </a:p>
-        </p:txBody>
-      </p:sp>
-      <p:sp>
-        <p:nvSpPr>
-          <p:cNvPr id="10" name="Text 8"/>
-          <p:cNvSpPr/>
-          <p:nvPr/>
-        </p:nvSpPr>
-        <p:spPr>
-          <a:xfrm>
-            <a:off x="4983480" y="2478024"/>
-            <a:ext cx="2468880" cy="274320"/>
-          </a:xfrm>
-          <a:prstGeom prst="rect">
-            <a:avLst/>
-          </a:prstGeom>
-          <a:noFill/>
-          <a:ln/>
-        </p:spPr>
-        <p:txBody>
-          <a:bodyPr wrap="square" lIns="0" tIns="0" rIns="0" bIns="0" rtlCol="0" anchor="t"/>
-          <a:lstStyle/>
-          <a:p>
-            <a:pPr algn="l" indent="0" marL="0">
-              <a:lnSpc>
-                <a:spcPct val="130000"/>
-              </a:lnSpc>
-              <a:buNone/>
-            </a:pPr>
-            <a:r>
-              <a:rPr lang="en-US" sz="1200" dirty="0">
-                <a:solidFill>
-                  <a:srgbClr val="6C4CFF"/>
-                </a:solidFill>
-                <a:latin typeface="Pretendard SemiBold" pitchFamily="34" charset="0"/>
-                <a:ea typeface="Pretendard SemiBold" pitchFamily="34" charset="-122"/>
-                <a:cs typeface="Pretendard SemiBold" pitchFamily="34" charset="-120"/>
-              </a:rPr>
-              <a:t>볼트</a:t>
-            </a:r>
-            <a:endParaRPr lang="en-US" sz="1200" dirty="0"/>
-          </a:p>
-        </p:txBody>
-      </p:sp>
-      <p:sp>
-        <p:nvSpPr>
-          <p:cNvPr id="11" name="Text 9"/>
-          <p:cNvSpPr/>
-          <p:nvPr/>
-        </p:nvSpPr>
-        <p:spPr>
-          <a:xfrm>
-            <a:off x="7543800" y="2478024"/>
-            <a:ext cx="3578047" cy="274320"/>
-          </a:xfrm>
-          <a:prstGeom prst="rect">
-            <a:avLst/>
-          </a:prstGeom>
-          <a:noFill/>
-          <a:ln/>
-        </p:spPr>
-        <p:txBody>
-          <a:bodyPr wrap="square" lIns="0" tIns="0" rIns="0" bIns="0" rtlCol="0" anchor="t"/>
-          <a:lstStyle/>
-          <a:p>
-            <a:pPr algn="l" indent="0" marL="0">
-              <a:lnSpc>
-                <a:spcPct val="130000"/>
-              </a:lnSpc>
-              <a:buNone/>
-            </a:pPr>
-            <a:r>
-              <a:rPr lang="en-US" sz="1200" dirty="0">
-                <a:solidFill>
-                  <a:srgbClr val="6C4CFF"/>
-                </a:solidFill>
-                <a:latin typeface="Pretendard SemiBold" pitchFamily="34" charset="0"/>
-                <a:ea typeface="Pretendard SemiBold" pitchFamily="34" charset="-122"/>
-                <a:cs typeface="Pretendard SemiBold" pitchFamily="34" charset="-120"/>
-              </a:rPr>
-              <a:t>파일</a:t>
-            </a:r>
-            <a:endParaRPr lang="en-US" sz="1200" dirty="0"/>
-          </a:p>
-        </p:txBody>
-      </p:sp>
-      <p:sp>
-        <p:nvSpPr>
-          <p:cNvPr id="12" name="Shape 10"/>
-          <p:cNvSpPr/>
-          <p:nvPr/>
-        </p:nvSpPr>
-        <p:spPr>
-          <a:xfrm>
-            <a:off x="1069848" y="2788920"/>
-            <a:ext cx="10051999" cy="0"/>
+              <a:t>CdBd 기능 (에디터 · 대시보드)</a:t>
+            </a:r>
+            <a:endParaRPr lang="en-US" sz="1250" dirty="0"/>
+          </a:p>
+        </p:txBody>
+      </p:sp>
+      <p:sp>
+        <p:nvSpPr>
+          <p:cNvPr id="10" name="Shape 8"/>
+          <p:cNvSpPr/>
+          <p:nvPr/>
+        </p:nvSpPr>
+        <p:spPr>
+          <a:xfrm>
+            <a:off x="777240" y="2615184"/>
+            <a:ext cx="5074920" cy="0"/>
           </a:xfrm>
           <a:prstGeom prst="line">
             <a:avLst/>
@@ -12037,14 +11968,14 @@
       </p:sp>
       <p:sp>
         <p:nvSpPr>
-          <p:cNvPr id="13" name="Text 11"/>
-          <p:cNvSpPr/>
-          <p:nvPr/>
-        </p:nvSpPr>
-        <p:spPr>
-          <a:xfrm>
-            <a:off x="1069848" y="2862072"/>
-            <a:ext cx="3840480" cy="320040"/>
+          <p:cNvPr id="11" name="Text 9"/>
+          <p:cNvSpPr/>
+          <p:nvPr/>
+        </p:nvSpPr>
+        <p:spPr>
+          <a:xfrm>
+            <a:off x="777240" y="2724912"/>
+            <a:ext cx="1874520" cy="365760"/>
           </a:xfrm>
           <a:prstGeom prst="rect">
             <a:avLst/>
@@ -12066,69 +11997,27 @@
               <a:rPr lang="en-US" sz="1150" dirty="0">
                 <a:solidFill>
                   <a:srgbClr val="1D1D1F"/>
-                </a:solidFill>
-                <a:latin typeface="Pretendard Medium" pitchFamily="34" charset="0"/>
-                <a:ea typeface="Pretendard Medium" pitchFamily="34" charset="-122"/>
-                <a:cs typeface="Pretendard Medium" pitchFamily="34" charset="-120"/>
-              </a:rPr>
-              <a:t>“상품 카드 넣어줘”</a:t>
-            </a:r>
-            <a:endParaRPr lang="en-US" sz="1150" dirty="0"/>
-          </a:p>
-        </p:txBody>
-      </p:sp>
-      <p:sp>
-        <p:nvSpPr>
-          <p:cNvPr id="14" name="Text 12"/>
-          <p:cNvSpPr/>
-          <p:nvPr/>
-        </p:nvSpPr>
-        <p:spPr>
-          <a:xfrm>
-            <a:off x="4983480" y="2862072"/>
-            <a:ext cx="2468880" cy="320040"/>
-          </a:xfrm>
-          <a:prstGeom prst="rect">
-            <a:avLst/>
-          </a:prstGeom>
-          <a:noFill/>
-          <a:ln/>
-        </p:spPr>
-        <p:txBody>
-          <a:bodyPr wrap="square" lIns="0" tIns="0" rIns="0" bIns="0" rtlCol="0" anchor="ctr"/>
-          <a:lstStyle/>
-          <a:p>
-            <a:pPr algn="l" indent="0" marL="0">
-              <a:lnSpc>
-                <a:spcPct val="130000"/>
-              </a:lnSpc>
-              <a:buNone/>
-            </a:pPr>
-            <a:r>
-              <a:rPr lang="en-US" sz="1100" dirty="0">
-                <a:solidFill>
-                  <a:srgbClr val="6C4CFF"/>
                 </a:solidFill>
                 <a:latin typeface="Pretendard SemiBold" pitchFamily="34" charset="0"/>
                 <a:ea typeface="Pretendard SemiBold" pitchFamily="34" charset="-122"/>
                 <a:cs typeface="Pretendard SemiBold" pitchFamily="34" charset="-120"/>
               </a:rPr>
-              <a:t>templates</a:t>
-            </a:r>
-            <a:endParaRPr lang="en-US" sz="1100" dirty="0"/>
-          </a:p>
-        </p:txBody>
-      </p:sp>
-      <p:sp>
-        <p:nvSpPr>
-          <p:cNvPr id="15" name="Text 13"/>
-          <p:cNvSpPr/>
-          <p:nvPr/>
-        </p:nvSpPr>
-        <p:spPr>
-          <a:xfrm>
-            <a:off x="7543800" y="2862072"/>
-            <a:ext cx="3578047" cy="320040"/>
+              <a:t>카드 15종</a:t>
+            </a:r>
+            <a:endParaRPr lang="en-US" sz="1150" dirty="0"/>
+          </a:p>
+        </p:txBody>
+      </p:sp>
+      <p:sp>
+        <p:nvSpPr>
+          <p:cNvPr id="12" name="Text 10"/>
+          <p:cNvSpPr/>
+          <p:nvPr/>
+        </p:nvSpPr>
+        <p:spPr>
+          <a:xfrm>
+            <a:off x="2697480" y="2724912"/>
+            <a:ext cx="3154680" cy="365760"/>
           </a:xfrm>
           <a:prstGeom prst="rect">
             <a:avLst/>
@@ -12147,7 +12036,7 @@
               <a:buNone/>
             </a:pPr>
             <a:r>
-              <a:rPr lang="en-US" sz="1100" dirty="0">
+              <a:rPr lang="en-US" sz="1050" dirty="0">
                 <a:solidFill>
                   <a:srgbClr val="55555A"/>
                 </a:solidFill>
@@ -12155,22 +12044,22 @@
                 <a:ea typeface="Pretendard" pitchFamily="34" charset="-122"/>
                 <a:cs typeface="Pretendard" pitchFamily="34" charset="-120"/>
               </a:rPr>
-              <a:t>1-6-2. CdBd 카드 기능</a:t>
-            </a:r>
-            <a:endParaRPr lang="en-US" sz="1100" dirty="0"/>
-          </a:p>
-        </p:txBody>
-      </p:sp>
-      <p:sp>
-        <p:nvSpPr>
-          <p:cNvPr id="16" name="Shape 14"/>
-          <p:cNvSpPr/>
-          <p:nvPr/>
-        </p:nvSpPr>
-        <p:spPr>
-          <a:xfrm>
-            <a:off x="1069848" y="3209544"/>
-            <a:ext cx="10051999" cy="0"/>
+              <a:t>→ [T] 1-6-2 · [DS] 4-x</a:t>
+            </a:r>
+            <a:endParaRPr lang="en-US" sz="1050" dirty="0"/>
+          </a:p>
+        </p:txBody>
+      </p:sp>
+      <p:sp>
+        <p:nvSpPr>
+          <p:cNvPr id="13" name="Shape 11"/>
+          <p:cNvSpPr/>
+          <p:nvPr/>
+        </p:nvSpPr>
+        <p:spPr>
+          <a:xfrm>
+            <a:off x="777240" y="3127248"/>
+            <a:ext cx="5074920" cy="0"/>
           </a:xfrm>
           <a:prstGeom prst="line">
             <a:avLst/>
@@ -12186,14 +12075,14 @@
       </p:sp>
       <p:sp>
         <p:nvSpPr>
-          <p:cNvPr id="17" name="Text 15"/>
-          <p:cNvSpPr/>
-          <p:nvPr/>
-        </p:nvSpPr>
-        <p:spPr>
-          <a:xfrm>
-            <a:off x="1069848" y="3227832"/>
-            <a:ext cx="3840480" cy="320040"/>
+          <p:cNvPr id="14" name="Text 12"/>
+          <p:cNvSpPr/>
+          <p:nvPr/>
+        </p:nvSpPr>
+        <p:spPr>
+          <a:xfrm>
+            <a:off x="777240" y="3182112"/>
+            <a:ext cx="1874520" cy="365760"/>
           </a:xfrm>
           <a:prstGeom prst="rect">
             <a:avLst/>
@@ -12215,69 +12104,27 @@
               <a:rPr lang="en-US" sz="1150" dirty="0">
                 <a:solidFill>
                   <a:srgbClr val="1D1D1F"/>
-                </a:solidFill>
-                <a:latin typeface="Pretendard Medium" pitchFamily="34" charset="0"/>
-                <a:ea typeface="Pretendard Medium" pitchFamily="34" charset="-122"/>
-                <a:cs typeface="Pretendard Medium" pitchFamily="34" charset="-120"/>
-              </a:rPr>
-              <a:t>“통계 화면 만들어줘”</a:t>
-            </a:r>
-            <a:endParaRPr lang="en-US" sz="1150" dirty="0"/>
-          </a:p>
-        </p:txBody>
-      </p:sp>
-      <p:sp>
-        <p:nvSpPr>
-          <p:cNvPr id="18" name="Text 16"/>
-          <p:cNvSpPr/>
-          <p:nvPr/>
-        </p:nvSpPr>
-        <p:spPr>
-          <a:xfrm>
-            <a:off x="4983480" y="3227832"/>
-            <a:ext cx="2468880" cy="320040"/>
-          </a:xfrm>
-          <a:prstGeom prst="rect">
-            <a:avLst/>
-          </a:prstGeom>
-          <a:noFill/>
-          <a:ln/>
-        </p:spPr>
-        <p:txBody>
-          <a:bodyPr wrap="square" lIns="0" tIns="0" rIns="0" bIns="0" rtlCol="0" anchor="ctr"/>
-          <a:lstStyle/>
-          <a:p>
-            <a:pPr algn="l" indent="0" marL="0">
-              <a:lnSpc>
-                <a:spcPct val="130000"/>
-              </a:lnSpc>
-              <a:buNone/>
-            </a:pPr>
-            <a:r>
-              <a:rPr lang="en-US" sz="1100" dirty="0">
-                <a:solidFill>
-                  <a:srgbClr val="6C4CFF"/>
                 </a:solidFill>
                 <a:latin typeface="Pretendard SemiBold" pitchFamily="34" charset="0"/>
                 <a:ea typeface="Pretendard SemiBold" pitchFamily="34" charset="-122"/>
                 <a:cs typeface="Pretendard SemiBold" pitchFamily="34" charset="-120"/>
               </a:rPr>
-              <a:t>design-system</a:t>
-            </a:r>
-            <a:endParaRPr lang="en-US" sz="1100" dirty="0"/>
-          </a:p>
-        </p:txBody>
-      </p:sp>
-      <p:sp>
-        <p:nvSpPr>
-          <p:cNvPr id="19" name="Text 17"/>
-          <p:cNvSpPr/>
-          <p:nvPr/>
-        </p:nvSpPr>
-        <p:spPr>
-          <a:xfrm>
-            <a:off x="7543800" y="3227832"/>
-            <a:ext cx="3578047" cy="320040"/>
+              <a:t>페이지 구성·꾸미기</a:t>
+            </a:r>
+            <a:endParaRPr lang="en-US" sz="1150" dirty="0"/>
+          </a:p>
+        </p:txBody>
+      </p:sp>
+      <p:sp>
+        <p:nvSpPr>
+          <p:cNvPr id="15" name="Text 13"/>
+          <p:cNvSpPr/>
+          <p:nvPr/>
+        </p:nvSpPr>
+        <p:spPr>
+          <a:xfrm>
+            <a:off x="2697480" y="3182112"/>
+            <a:ext cx="3154680" cy="365760"/>
           </a:xfrm>
           <a:prstGeom prst="rect">
             <a:avLst/>
@@ -12296,7 +12143,7 @@
               <a:buNone/>
             </a:pPr>
             <a:r>
-              <a:rPr lang="en-US" sz="1100" dirty="0">
+              <a:rPr lang="en-US" sz="1050" dirty="0">
                 <a:solidFill>
                   <a:srgbClr val="55555A"/>
                 </a:solidFill>
@@ -12304,22 +12151,22 @@
                 <a:ea typeface="Pretendard" pitchFamily="34" charset="-122"/>
                 <a:cs typeface="Pretendard" pitchFamily="34" charset="-120"/>
               </a:rPr>
-              <a:t>3-11. 통계</a:t>
-            </a:r>
-            <a:endParaRPr lang="en-US" sz="1100" dirty="0"/>
-          </a:p>
-        </p:txBody>
-      </p:sp>
-      <p:sp>
-        <p:nvSpPr>
-          <p:cNvPr id="20" name="Shape 18"/>
-          <p:cNvSpPr/>
-          <p:nvPr/>
-        </p:nvSpPr>
-        <p:spPr>
-          <a:xfrm>
-            <a:off x="1069848" y="3575304"/>
-            <a:ext cx="10051999" cy="0"/>
+              <a:t>→ [DS] 3-2-x · [T] 1-6-1</a:t>
+            </a:r>
+            <a:endParaRPr lang="en-US" sz="1050" dirty="0"/>
+          </a:p>
+        </p:txBody>
+      </p:sp>
+      <p:sp>
+        <p:nvSpPr>
+          <p:cNvPr id="16" name="Shape 14"/>
+          <p:cNvSpPr/>
+          <p:nvPr/>
+        </p:nvSpPr>
+        <p:spPr>
+          <a:xfrm>
+            <a:off x="777240" y="3584448"/>
+            <a:ext cx="5074920" cy="0"/>
           </a:xfrm>
           <a:prstGeom prst="line">
             <a:avLst/>
@@ -12335,14 +12182,14 @@
       </p:sp>
       <p:sp>
         <p:nvSpPr>
-          <p:cNvPr id="21" name="Text 19"/>
-          <p:cNvSpPr/>
-          <p:nvPr/>
-        </p:nvSpPr>
-        <p:spPr>
-          <a:xfrm>
-            <a:off x="1069848" y="3593592"/>
-            <a:ext cx="3840480" cy="320040"/>
+          <p:cNvPr id="17" name="Text 15"/>
+          <p:cNvSpPr/>
+          <p:nvPr/>
+        </p:nvSpPr>
+        <p:spPr>
+          <a:xfrm>
+            <a:off x="777240" y="3639312"/>
+            <a:ext cx="1874520" cy="365760"/>
           </a:xfrm>
           <a:prstGeom prst="rect">
             <a:avLst/>
@@ -12364,69 +12211,27 @@
               <a:rPr lang="en-US" sz="1150" dirty="0">
                 <a:solidFill>
                   <a:srgbClr val="1D1D1F"/>
-                </a:solidFill>
-                <a:latin typeface="Pretendard Medium" pitchFamily="34" charset="0"/>
-                <a:ea typeface="Pretendard Medium" pitchFamily="34" charset="-122"/>
-                <a:cs typeface="Pretendard Medium" pitchFamily="34" charset="-120"/>
-              </a:rPr>
-              <a:t>“에디터 카드보드 수정”</a:t>
-            </a:r>
-            <a:endParaRPr lang="en-US" sz="1150" dirty="0"/>
-          </a:p>
-        </p:txBody>
-      </p:sp>
-      <p:sp>
-        <p:nvSpPr>
-          <p:cNvPr id="22" name="Text 20"/>
-          <p:cNvSpPr/>
-          <p:nvPr/>
-        </p:nvSpPr>
-        <p:spPr>
-          <a:xfrm>
-            <a:off x="4983480" y="3593592"/>
-            <a:ext cx="2468880" cy="320040"/>
-          </a:xfrm>
-          <a:prstGeom prst="rect">
-            <a:avLst/>
-          </a:prstGeom>
-          <a:noFill/>
-          <a:ln/>
-        </p:spPr>
-        <p:txBody>
-          <a:bodyPr wrap="square" lIns="0" tIns="0" rIns="0" bIns="0" rtlCol="0" anchor="ctr"/>
-          <a:lstStyle/>
-          <a:p>
-            <a:pPr algn="l" indent="0" marL="0">
-              <a:lnSpc>
-                <a:spcPct val="130000"/>
-              </a:lnSpc>
-              <a:buNone/>
-            </a:pPr>
-            <a:r>
-              <a:rPr lang="en-US" sz="1100" dirty="0">
-                <a:solidFill>
-                  <a:srgbClr val="6C4CFF"/>
                 </a:solidFill>
                 <a:latin typeface="Pretendard SemiBold" pitchFamily="34" charset="0"/>
                 <a:ea typeface="Pretendard SemiBold" pitchFamily="34" charset="-122"/>
                 <a:cs typeface="Pretendard SemiBold" pitchFamily="34" charset="-120"/>
               </a:rPr>
-              <a:t>design-system</a:t>
-            </a:r>
-            <a:endParaRPr lang="en-US" sz="1100" dirty="0"/>
-          </a:p>
-        </p:txBody>
-      </p:sp>
-      <p:sp>
-        <p:nvSpPr>
-          <p:cNvPr id="23" name="Text 21"/>
-          <p:cNvSpPr/>
-          <p:nvPr/>
-        </p:nvSpPr>
-        <p:spPr>
-          <a:xfrm>
-            <a:off x="7543800" y="3593592"/>
-            <a:ext cx="3578047" cy="320040"/>
+              <a:t>게시 (URL · OG)</a:t>
+            </a:r>
+            <a:endParaRPr lang="en-US" sz="1150" dirty="0"/>
+          </a:p>
+        </p:txBody>
+      </p:sp>
+      <p:sp>
+        <p:nvSpPr>
+          <p:cNvPr id="18" name="Text 16"/>
+          <p:cNvSpPr/>
+          <p:nvPr/>
+        </p:nvSpPr>
+        <p:spPr>
+          <a:xfrm>
+            <a:off x="2697480" y="3639312"/>
+            <a:ext cx="3154680" cy="365760"/>
           </a:xfrm>
           <a:prstGeom prst="rect">
             <a:avLst/>
@@ -12445,7 +12250,7 @@
               <a:buNone/>
             </a:pPr>
             <a:r>
-              <a:rPr lang="en-US" sz="1100" dirty="0">
+              <a:rPr lang="en-US" sz="1050" dirty="0">
                 <a:solidFill>
                   <a:srgbClr val="55555A"/>
                 </a:solidFill>
@@ -12453,22 +12258,22 @@
                 <a:ea typeface="Pretendard" pitchFamily="34" charset="-122"/>
                 <a:cs typeface="Pretendard" pitchFamily="34" charset="-120"/>
               </a:rPr>
-              <a:t>3-2-3. 카드 보드</a:t>
-            </a:r>
-            <a:endParaRPr lang="en-US" sz="1100" dirty="0"/>
-          </a:p>
-        </p:txBody>
-      </p:sp>
-      <p:sp>
-        <p:nvSpPr>
-          <p:cNvPr id="24" name="Shape 22"/>
-          <p:cNvSpPr/>
-          <p:nvPr/>
-        </p:nvSpPr>
-        <p:spPr>
-          <a:xfrm>
-            <a:off x="1069848" y="3941064"/>
-            <a:ext cx="10051999" cy="0"/>
+              <a:t>→ [SV] 1-4 §게시</a:t>
+            </a:r>
+            <a:endParaRPr lang="en-US" sz="1050" dirty="0"/>
+          </a:p>
+        </p:txBody>
+      </p:sp>
+      <p:sp>
+        <p:nvSpPr>
+          <p:cNvPr id="19" name="Shape 17"/>
+          <p:cNvSpPr/>
+          <p:nvPr/>
+        </p:nvSpPr>
+        <p:spPr>
+          <a:xfrm>
+            <a:off x="777240" y="4041648"/>
+            <a:ext cx="5074920" cy="0"/>
           </a:xfrm>
           <a:prstGeom prst="line">
             <a:avLst/>
@@ -12484,14 +12289,14 @@
       </p:sp>
       <p:sp>
         <p:nvSpPr>
-          <p:cNvPr id="25" name="Text 23"/>
-          <p:cNvSpPr/>
-          <p:nvPr/>
-        </p:nvSpPr>
-        <p:spPr>
-          <a:xfrm>
-            <a:off x="1069848" y="3959352"/>
-            <a:ext cx="3840480" cy="320040"/>
+          <p:cNvPr id="20" name="Text 18"/>
+          <p:cNvSpPr/>
+          <p:nvPr/>
+        </p:nvSpPr>
+        <p:spPr>
+          <a:xfrm>
+            <a:off x="777240" y="4096512"/>
+            <a:ext cx="1874520" cy="365760"/>
           </a:xfrm>
           <a:prstGeom prst="rect">
             <a:avLst/>
@@ -12513,69 +12318,27 @@
               <a:rPr lang="en-US" sz="1150" dirty="0">
                 <a:solidFill>
                   <a:srgbClr val="1D1D1F"/>
-                </a:solidFill>
-                <a:latin typeface="Pretendard Medium" pitchFamily="34" charset="0"/>
-                <a:ea typeface="Pretendard Medium" pitchFamily="34" charset="-122"/>
-                <a:cs typeface="Pretendard Medium" pitchFamily="34" charset="-120"/>
-              </a:rPr>
-              <a:t>“URL 게시해줘”</a:t>
-            </a:r>
-            <a:endParaRPr lang="en-US" sz="1150" dirty="0"/>
-          </a:p>
-        </p:txBody>
-      </p:sp>
-      <p:sp>
-        <p:nvSpPr>
-          <p:cNvPr id="26" name="Text 24"/>
-          <p:cNvSpPr/>
-          <p:nvPr/>
-        </p:nvSpPr>
-        <p:spPr>
-          <a:xfrm>
-            <a:off x="4983480" y="3959352"/>
-            <a:ext cx="2468880" cy="320040"/>
-          </a:xfrm>
-          <a:prstGeom prst="rect">
-            <a:avLst/>
-          </a:prstGeom>
-          <a:noFill/>
-          <a:ln/>
-        </p:spPr>
-        <p:txBody>
-          <a:bodyPr wrap="square" lIns="0" tIns="0" rIns="0" bIns="0" rtlCol="0" anchor="ctr"/>
-          <a:lstStyle/>
-          <a:p>
-            <a:pPr algn="l" indent="0" marL="0">
-              <a:lnSpc>
-                <a:spcPct val="130000"/>
-              </a:lnSpc>
-              <a:buNone/>
-            </a:pPr>
-            <a:r>
-              <a:rPr lang="en-US" sz="1100" dirty="0">
-                <a:solidFill>
-                  <a:srgbClr val="6C4CFF"/>
                 </a:solidFill>
                 <a:latin typeface="Pretendard SemiBold" pitchFamily="34" charset="0"/>
                 <a:ea typeface="Pretendard SemiBold" pitchFamily="34" charset="-122"/>
                 <a:cs typeface="Pretendard SemiBold" pitchFamily="34" charset="-120"/>
               </a:rPr>
-              <a:t>design-service</a:t>
-            </a:r>
-            <a:endParaRPr lang="en-US" sz="1100" dirty="0"/>
-          </a:p>
-        </p:txBody>
-      </p:sp>
-      <p:sp>
-        <p:nvSpPr>
-          <p:cNvPr id="27" name="Text 25"/>
-          <p:cNvSpPr/>
-          <p:nvPr/>
-        </p:nvSpPr>
-        <p:spPr>
-          <a:xfrm>
-            <a:off x="7543800" y="3959352"/>
-            <a:ext cx="3578047" cy="320040"/>
+              <a:t>페이지 · URL 통계</a:t>
+            </a:r>
+            <a:endParaRPr lang="en-US" sz="1150" dirty="0"/>
+          </a:p>
+        </p:txBody>
+      </p:sp>
+      <p:sp>
+        <p:nvSpPr>
+          <p:cNvPr id="21" name="Text 19"/>
+          <p:cNvSpPr/>
+          <p:nvPr/>
+        </p:nvSpPr>
+        <p:spPr>
+          <a:xfrm>
+            <a:off x="2697480" y="4096512"/>
+            <a:ext cx="3154680" cy="365760"/>
           </a:xfrm>
           <a:prstGeom prst="rect">
             <a:avLst/>
@@ -12594,7 +12357,7 @@
               <a:buNone/>
             </a:pPr>
             <a:r>
-              <a:rPr lang="en-US" sz="1100" dirty="0">
+              <a:rPr lang="en-US" sz="1050" dirty="0">
                 <a:solidFill>
                   <a:srgbClr val="55555A"/>
                 </a:solidFill>
@@ -12602,22 +12365,22 @@
                 <a:ea typeface="Pretendard" pitchFamily="34" charset="-122"/>
                 <a:cs typeface="Pretendard" pitchFamily="34" charset="-120"/>
               </a:rPr>
-              <a:t>1-4. CdBd 콘텐츠 §게시</a:t>
-            </a:r>
-            <a:endParaRPr lang="en-US" sz="1100" dirty="0"/>
-          </a:p>
-        </p:txBody>
-      </p:sp>
-      <p:sp>
-        <p:nvSpPr>
-          <p:cNvPr id="28" name="Shape 26"/>
-          <p:cNvSpPr/>
-          <p:nvPr/>
-        </p:nvSpPr>
-        <p:spPr>
-          <a:xfrm>
-            <a:off x="1069848" y="4306824"/>
-            <a:ext cx="10051999" cy="0"/>
+              <a:t>→ [DS] 3-11 통계</a:t>
+            </a:r>
+            <a:endParaRPr lang="en-US" sz="1050" dirty="0"/>
+          </a:p>
+        </p:txBody>
+      </p:sp>
+      <p:sp>
+        <p:nvSpPr>
+          <p:cNvPr id="22" name="Shape 20"/>
+          <p:cNvSpPr/>
+          <p:nvPr/>
+        </p:nvSpPr>
+        <p:spPr>
+          <a:xfrm>
+            <a:off x="777240" y="4498848"/>
+            <a:ext cx="5074920" cy="0"/>
           </a:xfrm>
           <a:prstGeom prst="line">
             <a:avLst/>
@@ -12633,14 +12396,14 @@
       </p:sp>
       <p:sp>
         <p:nvSpPr>
-          <p:cNvPr id="29" name="Text 27"/>
-          <p:cNvSpPr/>
-          <p:nvPr/>
-        </p:nvSpPr>
-        <p:spPr>
-          <a:xfrm>
-            <a:off x="1069848" y="4325112"/>
-            <a:ext cx="3840480" cy="320040"/>
+          <p:cNvPr id="23" name="Text 21"/>
+          <p:cNvSpPr/>
+          <p:nvPr/>
+        </p:nvSpPr>
+        <p:spPr>
+          <a:xfrm>
+            <a:off x="777240" y="4553712"/>
+            <a:ext cx="1874520" cy="365760"/>
           </a:xfrm>
           <a:prstGeom prst="rect">
             <a:avLst/>
@@ -12662,69 +12425,27 @@
               <a:rPr lang="en-US" sz="1150" dirty="0">
                 <a:solidFill>
                   <a:srgbClr val="1D1D1F"/>
-                </a:solidFill>
-                <a:latin typeface="Pretendard Medium" pitchFamily="34" charset="0"/>
-                <a:ea typeface="Pretendard Medium" pitchFamily="34" charset="-122"/>
-                <a:cs typeface="Pretendard Medium" pitchFamily="34" charset="-120"/>
-              </a:rPr>
-              <a:t>“룩북 시안 만들어줘”</a:t>
-            </a:r>
-            <a:endParaRPr lang="en-US" sz="1150" dirty="0"/>
-          </a:p>
-        </p:txBody>
-      </p:sp>
-      <p:sp>
-        <p:nvSpPr>
-          <p:cNvPr id="30" name="Text 28"/>
-          <p:cNvSpPr/>
-          <p:nvPr/>
-        </p:nvSpPr>
-        <p:spPr>
-          <a:xfrm>
-            <a:off x="4983480" y="4325112"/>
-            <a:ext cx="2468880" cy="320040"/>
-          </a:xfrm>
-          <a:prstGeom prst="rect">
-            <a:avLst/>
-          </a:prstGeom>
-          <a:noFill/>
-          <a:ln/>
-        </p:spPr>
-        <p:txBody>
-          <a:bodyPr wrap="square" lIns="0" tIns="0" rIns="0" bIns="0" rtlCol="0" anchor="ctr"/>
-          <a:lstStyle/>
-          <a:p>
-            <a:pPr algn="l" indent="0" marL="0">
-              <a:lnSpc>
-                <a:spcPct val="130000"/>
-              </a:lnSpc>
-              <a:buNone/>
-            </a:pPr>
-            <a:r>
-              <a:rPr lang="en-US" sz="1100" dirty="0">
-                <a:solidFill>
-                  <a:srgbClr val="6C4CFF"/>
                 </a:solidFill>
                 <a:latin typeface="Pretendard SemiBold" pitchFamily="34" charset="0"/>
                 <a:ea typeface="Pretendard SemiBold" pitchFamily="34" charset="-122"/>
                 <a:cs typeface="Pretendard SemiBold" pitchFamily="34" charset="-120"/>
               </a:rPr>
-              <a:t>design-service</a:t>
-            </a:r>
-            <a:endParaRPr lang="en-US" sz="1100" dirty="0"/>
-          </a:p>
-        </p:txBody>
-      </p:sp>
-      <p:sp>
-        <p:nvSpPr>
-          <p:cNvPr id="31" name="Text 29"/>
-          <p:cNvSpPr/>
-          <p:nvPr/>
-        </p:nvSpPr>
-        <p:spPr>
-          <a:xfrm>
-            <a:off x="7543800" y="4325112"/>
-            <a:ext cx="3578047" cy="320040"/>
+              <a:t>계정 · 주소 · 요금</a:t>
+            </a:r>
+            <a:endParaRPr lang="en-US" sz="1150" dirty="0"/>
+          </a:p>
+        </p:txBody>
+      </p:sp>
+      <p:sp>
+        <p:nvSpPr>
+          <p:cNvPr id="24" name="Text 22"/>
+          <p:cNvSpPr/>
+          <p:nvPr/>
+        </p:nvSpPr>
+        <p:spPr>
+          <a:xfrm>
+            <a:off x="2697480" y="4553712"/>
+            <a:ext cx="3154680" cy="365760"/>
           </a:xfrm>
           <a:prstGeom prst="rect">
             <a:avLst/>
@@ -12743,7 +12464,7 @@
               <a:buNone/>
             </a:pPr>
             <a:r>
-              <a:rPr lang="en-US" sz="1100" dirty="0">
+              <a:rPr lang="en-US" sz="1050" dirty="0">
                 <a:solidFill>
                   <a:srgbClr val="55555A"/>
                 </a:solidFill>
@@ -12751,22 +12472,22 @@
                 <a:ea typeface="Pretendard" pitchFamily="34" charset="-122"/>
                 <a:cs typeface="Pretendard" pitchFamily="34" charset="-120"/>
               </a:rPr>
-              <a:t>룩북/1-2. 시안</a:t>
-            </a:r>
-            <a:endParaRPr lang="en-US" sz="1100" dirty="0"/>
-          </a:p>
-        </p:txBody>
-      </p:sp>
-      <p:sp>
-        <p:nvSpPr>
-          <p:cNvPr id="32" name="Shape 30"/>
-          <p:cNvSpPr/>
-          <p:nvPr/>
-        </p:nvSpPr>
-        <p:spPr>
-          <a:xfrm>
-            <a:off x="1069848" y="4672584"/>
-            <a:ext cx="10051999" cy="0"/>
+              <a:t>→ [DS] 3-8 · 3-5</a:t>
+            </a:r>
+            <a:endParaRPr lang="en-US" sz="1050" dirty="0"/>
+          </a:p>
+        </p:txBody>
+      </p:sp>
+      <p:sp>
+        <p:nvSpPr>
+          <p:cNvPr id="25" name="Shape 23"/>
+          <p:cNvSpPr/>
+          <p:nvPr/>
+        </p:nvSpPr>
+        <p:spPr>
+          <a:xfrm>
+            <a:off x="777240" y="4956048"/>
+            <a:ext cx="5074920" cy="0"/>
           </a:xfrm>
           <a:prstGeom prst="line">
             <a:avLst/>
@@ -12782,14 +12503,14 @@
       </p:sp>
       <p:sp>
         <p:nvSpPr>
-          <p:cNvPr id="33" name="Text 31"/>
-          <p:cNvSpPr/>
-          <p:nvPr/>
-        </p:nvSpPr>
-        <p:spPr>
-          <a:xfrm>
-            <a:off x="1069848" y="4690872"/>
-            <a:ext cx="3840480" cy="320040"/>
+          <p:cNvPr id="26" name="Text 24"/>
+          <p:cNvSpPr/>
+          <p:nvPr/>
+        </p:nvSpPr>
+        <p:spPr>
+          <a:xfrm>
+            <a:off x="777240" y="5010912"/>
+            <a:ext cx="1874520" cy="365760"/>
           </a:xfrm>
           <a:prstGeom prst="rect">
             <a:avLst/>
@@ -12811,69 +12532,27 @@
               <a:rPr lang="en-US" sz="1150" dirty="0">
                 <a:solidFill>
                   <a:srgbClr val="1D1D1F"/>
-                </a:solidFill>
-                <a:latin typeface="Pretendard Medium" pitchFamily="34" charset="0"/>
-                <a:ea typeface="Pretendard Medium" pitchFamily="34" charset="-122"/>
-                <a:cs typeface="Pretendard Medium" pitchFamily="34" charset="-120"/>
-              </a:rPr>
-              <a:t>“QR 이벤트 만들어줘”</a:t>
-            </a:r>
-            <a:endParaRPr lang="en-US" sz="1150" dirty="0"/>
-          </a:p>
-        </p:txBody>
-      </p:sp>
-      <p:sp>
-        <p:nvSpPr>
-          <p:cNvPr id="34" name="Text 32"/>
-          <p:cNvSpPr/>
-          <p:nvPr/>
-        </p:nvSpPr>
-        <p:spPr>
-          <a:xfrm>
-            <a:off x="4983480" y="4690872"/>
-            <a:ext cx="2468880" cy="320040"/>
-          </a:xfrm>
-          <a:prstGeom prst="rect">
-            <a:avLst/>
-          </a:prstGeom>
-          <a:noFill/>
-          <a:ln/>
-        </p:spPr>
-        <p:txBody>
-          <a:bodyPr wrap="square" lIns="0" tIns="0" rIns="0" bIns="0" rtlCol="0" anchor="ctr"/>
-          <a:lstStyle/>
-          <a:p>
-            <a:pPr algn="l" indent="0" marL="0">
-              <a:lnSpc>
-                <a:spcPct val="130000"/>
-              </a:lnSpc>
-              <a:buNone/>
-            </a:pPr>
-            <a:r>
-              <a:rPr lang="en-US" sz="1100" dirty="0">
-                <a:solidFill>
-                  <a:srgbClr val="6C4CFF"/>
                 </a:solidFill>
                 <a:latin typeface="Pretendard SemiBold" pitchFamily="34" charset="0"/>
                 <a:ea typeface="Pretendard SemiBold" pitchFamily="34" charset="-122"/>
                 <a:cs typeface="Pretendard SemiBold" pitchFamily="34" charset="-120"/>
               </a:rPr>
-              <a:t>makevu-qrstp</a:t>
-            </a:r>
-            <a:endParaRPr lang="en-US" sz="1100" dirty="0"/>
-          </a:p>
-        </p:txBody>
-      </p:sp>
-      <p:sp>
-        <p:nvSpPr>
-          <p:cNvPr id="35" name="Text 33"/>
-          <p:cNvSpPr/>
-          <p:nvPr/>
-        </p:nvSpPr>
-        <p:spPr>
-          <a:xfrm>
-            <a:off x="7543800" y="4690872"/>
-            <a:ext cx="3578047" cy="320040"/>
+              <a:t>버전 · 권한</a:t>
+            </a:r>
+            <a:endParaRPr lang="en-US" sz="1150" dirty="0"/>
+          </a:p>
+        </p:txBody>
+      </p:sp>
+      <p:sp>
+        <p:nvSpPr>
+          <p:cNvPr id="27" name="Text 25"/>
+          <p:cNvSpPr/>
+          <p:nvPr/>
+        </p:nvSpPr>
+        <p:spPr>
+          <a:xfrm>
+            <a:off x="2697480" y="5010912"/>
+            <a:ext cx="3154680" cy="365760"/>
           </a:xfrm>
           <a:prstGeom prst="rect">
             <a:avLst/>
@@ -12892,7 +12571,7 @@
               <a:buNone/>
             </a:pPr>
             <a:r>
-              <a:rPr lang="en-US" sz="1100" dirty="0">
+              <a:rPr lang="en-US" sz="1050" dirty="0">
                 <a:solidFill>
                   <a:srgbClr val="55555A"/>
                 </a:solidFill>
@@ -12900,22 +12579,171 @@
                 <a:ea typeface="Pretendard" pitchFamily="34" charset="-122"/>
                 <a:cs typeface="Pretendard" pitchFamily="34" charset="-120"/>
               </a:rPr>
-              <a:t>3. 워크플로우</a:t>
-            </a:r>
-            <a:endParaRPr lang="en-US" sz="1100" dirty="0"/>
-          </a:p>
-        </p:txBody>
-      </p:sp>
-      <p:sp>
-        <p:nvSpPr>
-          <p:cNvPr id="36" name="Shape 34"/>
-          <p:cNvSpPr/>
-          <p:nvPr/>
-        </p:nvSpPr>
-        <p:spPr>
-          <a:xfrm>
-            <a:off x="1069848" y="5038344"/>
-            <a:ext cx="10051999" cy="0"/>
+              <a:t>→ [DS] 3-15 · 3-13</a:t>
+            </a:r>
+            <a:endParaRPr lang="en-US" sz="1050" dirty="0"/>
+          </a:p>
+        </p:txBody>
+      </p:sp>
+      <p:sp>
+        <p:nvSpPr>
+          <p:cNvPr id="28" name="Text 26"/>
+          <p:cNvSpPr/>
+          <p:nvPr/>
+        </p:nvSpPr>
+        <p:spPr>
+          <a:xfrm>
+            <a:off x="6336792" y="2286000"/>
+            <a:ext cx="5074920" cy="274320"/>
+          </a:xfrm>
+          <a:prstGeom prst="rect">
+            <a:avLst/>
+          </a:prstGeom>
+          <a:noFill/>
+          <a:ln/>
+        </p:spPr>
+        <p:txBody>
+          <a:bodyPr wrap="square" lIns="0" tIns="0" rIns="0" bIns="0" rtlCol="0" anchor="t"/>
+          <a:lstStyle/>
+          <a:p>
+            <a:pPr algn="l" indent="0" marL="0">
+              <a:lnSpc>
+                <a:spcPct val="130000"/>
+              </a:lnSpc>
+              <a:buNone/>
+            </a:pPr>
+            <a:r>
+              <a:rPr lang="en-US" sz="1250" dirty="0">
+                <a:solidFill>
+                  <a:srgbClr val="6C4CFF"/>
+                </a:solidFill>
+                <a:latin typeface="Pretendard SemiBold" pitchFamily="34" charset="0"/>
+                <a:ea typeface="Pretendard SemiBold" pitchFamily="34" charset="-122"/>
+                <a:cs typeface="Pretendard SemiBold" pitchFamily="34" charset="-120"/>
+              </a:rPr>
+              <a:t>다른 볼트 — 제작 작업</a:t>
+            </a:r>
+            <a:endParaRPr lang="en-US" sz="1250" dirty="0"/>
+          </a:p>
+        </p:txBody>
+      </p:sp>
+      <p:sp>
+        <p:nvSpPr>
+          <p:cNvPr id="29" name="Shape 27"/>
+          <p:cNvSpPr/>
+          <p:nvPr/>
+        </p:nvSpPr>
+        <p:spPr>
+          <a:xfrm>
+            <a:off x="6336792" y="2615184"/>
+            <a:ext cx="5074920" cy="0"/>
+          </a:xfrm>
+          <a:prstGeom prst="line">
+            <a:avLst/>
+          </a:prstGeom>
+          <a:noFill/>
+          <a:ln w="9525">
+            <a:solidFill>
+              <a:srgbClr val="E5E7EB"/>
+            </a:solidFill>
+            <a:prstDash val="solid"/>
+          </a:ln>
+        </p:spPr>
+      </p:sp>
+      <p:sp>
+        <p:nvSpPr>
+          <p:cNvPr id="30" name="Text 28"/>
+          <p:cNvSpPr/>
+          <p:nvPr/>
+        </p:nvSpPr>
+        <p:spPr>
+          <a:xfrm>
+            <a:off x="6336792" y="2724912"/>
+            <a:ext cx="1874520" cy="365760"/>
+          </a:xfrm>
+          <a:prstGeom prst="rect">
+            <a:avLst/>
+          </a:prstGeom>
+          <a:noFill/>
+          <a:ln/>
+        </p:spPr>
+        <p:txBody>
+          <a:bodyPr wrap="square" lIns="0" tIns="0" rIns="0" bIns="0" rtlCol="0" anchor="ctr"/>
+          <a:lstStyle/>
+          <a:p>
+            <a:pPr algn="l" indent="0" marL="0">
+              <a:lnSpc>
+                <a:spcPct val="130000"/>
+              </a:lnSpc>
+              <a:buNone/>
+            </a:pPr>
+            <a:r>
+              <a:rPr lang="en-US" sz="1150" dirty="0">
+                <a:solidFill>
+                  <a:srgbClr val="1D1D1F"/>
+                </a:solidFill>
+                <a:latin typeface="Pretendard SemiBold" pitchFamily="34" charset="0"/>
+                <a:ea typeface="Pretendard SemiBold" pitchFamily="34" charset="-122"/>
+                <a:cs typeface="Pretendard SemiBold" pitchFamily="34" charset="-120"/>
+              </a:rPr>
+              <a:t>룩북 시안</a:t>
+            </a:r>
+            <a:endParaRPr lang="en-US" sz="1150" dirty="0"/>
+          </a:p>
+        </p:txBody>
+      </p:sp>
+      <p:sp>
+        <p:nvSpPr>
+          <p:cNvPr id="31" name="Text 29"/>
+          <p:cNvSpPr/>
+          <p:nvPr/>
+        </p:nvSpPr>
+        <p:spPr>
+          <a:xfrm>
+            <a:off x="8257032" y="2724912"/>
+            <a:ext cx="3154680" cy="365760"/>
+          </a:xfrm>
+          <a:prstGeom prst="rect">
+            <a:avLst/>
+          </a:prstGeom>
+          <a:noFill/>
+          <a:ln/>
+        </p:spPr>
+        <p:txBody>
+          <a:bodyPr wrap="square" lIns="0" tIns="0" rIns="0" bIns="0" rtlCol="0" anchor="ctr"/>
+          <a:lstStyle/>
+          <a:p>
+            <a:pPr algn="l" indent="0" marL="0">
+              <a:lnSpc>
+                <a:spcPct val="130000"/>
+              </a:lnSpc>
+              <a:buNone/>
+            </a:pPr>
+            <a:r>
+              <a:rPr lang="en-US" sz="1050" dirty="0">
+                <a:solidFill>
+                  <a:srgbClr val="55555A"/>
+                </a:solidFill>
+                <a:latin typeface="Pretendard" pitchFamily="34" charset="0"/>
+                <a:ea typeface="Pretendard" pitchFamily="34" charset="-122"/>
+                <a:cs typeface="Pretendard" pitchFamily="34" charset="-120"/>
+              </a:rPr>
+              <a:t>→ [SV] 룩북/1-2. 시안</a:t>
+            </a:r>
+            <a:endParaRPr lang="en-US" sz="1050" dirty="0"/>
+          </a:p>
+        </p:txBody>
+      </p:sp>
+      <p:sp>
+        <p:nvSpPr>
+          <p:cNvPr id="32" name="Shape 30"/>
+          <p:cNvSpPr/>
+          <p:nvPr/>
+        </p:nvSpPr>
+        <p:spPr>
+          <a:xfrm>
+            <a:off x="6336792" y="3127248"/>
+            <a:ext cx="5074920" cy="0"/>
           </a:xfrm>
           <a:prstGeom prst="line">
             <a:avLst/>
@@ -12931,14 +12759,14 @@
       </p:sp>
       <p:sp>
         <p:nvSpPr>
-          <p:cNvPr id="37" name="Text 35"/>
-          <p:cNvSpPr/>
-          <p:nvPr/>
-        </p:nvSpPr>
-        <p:spPr>
-          <a:xfrm>
-            <a:off x="1069848" y="5056632"/>
-            <a:ext cx="3840480" cy="320040"/>
+          <p:cNvPr id="33" name="Text 31"/>
+          <p:cNvSpPr/>
+          <p:nvPr/>
+        </p:nvSpPr>
+        <p:spPr>
+          <a:xfrm>
+            <a:off x="6336792" y="3182112"/>
+            <a:ext cx="1874520" cy="365760"/>
           </a:xfrm>
           <a:prstGeom prst="rect">
             <a:avLst/>
@@ -12960,69 +12788,27 @@
               <a:rPr lang="en-US" sz="1150" dirty="0">
                 <a:solidFill>
                   <a:srgbClr val="1D1D1F"/>
-                </a:solidFill>
-                <a:latin typeface="Pretendard Medium" pitchFamily="34" charset="0"/>
-                <a:ea typeface="Pretendard Medium" pitchFamily="34" charset="-122"/>
-                <a:cs typeface="Pretendard Medium" pitchFamily="34" charset="-120"/>
-              </a:rPr>
-              <a:t>“블로그 썸네일 만들어줘”</a:t>
-            </a:r>
-            <a:endParaRPr lang="en-US" sz="1150" dirty="0"/>
-          </a:p>
-        </p:txBody>
-      </p:sp>
-      <p:sp>
-        <p:nvSpPr>
-          <p:cNvPr id="38" name="Text 36"/>
-          <p:cNvSpPr/>
-          <p:nvPr/>
-        </p:nvSpPr>
-        <p:spPr>
-          <a:xfrm>
-            <a:off x="4983480" y="5056632"/>
-            <a:ext cx="2468880" cy="320040"/>
-          </a:xfrm>
-          <a:prstGeom prst="rect">
-            <a:avLst/>
-          </a:prstGeom>
-          <a:noFill/>
-          <a:ln/>
-        </p:spPr>
-        <p:txBody>
-          <a:bodyPr wrap="square" lIns="0" tIns="0" rIns="0" bIns="0" rtlCol="0" anchor="ctr"/>
-          <a:lstStyle/>
-          <a:p>
-            <a:pPr algn="l" indent="0" marL="0">
-              <a:lnSpc>
-                <a:spcPct val="130000"/>
-              </a:lnSpc>
-              <a:buNone/>
-            </a:pPr>
-            <a:r>
-              <a:rPr lang="en-US" sz="1100" dirty="0">
-                <a:solidFill>
-                  <a:srgbClr val="6C4CFF"/>
                 </a:solidFill>
                 <a:latin typeface="Pretendard SemiBold" pitchFamily="34" charset="0"/>
                 <a:ea typeface="Pretendard SemiBold" pitchFamily="34" charset="-122"/>
                 <a:cs typeface="Pretendard SemiBold" pitchFamily="34" charset="-120"/>
               </a:rPr>
-              <a:t>marketing</a:t>
-            </a:r>
-            <a:endParaRPr lang="en-US" sz="1100" dirty="0"/>
-          </a:p>
-        </p:txBody>
-      </p:sp>
-      <p:sp>
-        <p:nvSpPr>
-          <p:cNvPr id="39" name="Text 37"/>
-          <p:cNvSpPr/>
-          <p:nvPr/>
-        </p:nvSpPr>
-        <p:spPr>
-          <a:xfrm>
-            <a:off x="7543800" y="5056632"/>
-            <a:ext cx="3578047" cy="320040"/>
+              <a:t>소식지</a:t>
+            </a:r>
+            <a:endParaRPr lang="en-US" sz="1150" dirty="0"/>
+          </a:p>
+        </p:txBody>
+      </p:sp>
+      <p:sp>
+        <p:nvSpPr>
+          <p:cNvPr id="34" name="Text 32"/>
+          <p:cNvSpPr/>
+          <p:nvPr/>
+        </p:nvSpPr>
+        <p:spPr>
+          <a:xfrm>
+            <a:off x="8257032" y="3182112"/>
+            <a:ext cx="3154680" cy="365760"/>
           </a:xfrm>
           <a:prstGeom prst="rect">
             <a:avLst/>
@@ -13041,7 +12827,7 @@
               <a:buNone/>
             </a:pPr>
             <a:r>
-              <a:rPr lang="en-US" sz="1100" dirty="0">
+              <a:rPr lang="en-US" sz="1050" dirty="0">
                 <a:solidFill>
                   <a:srgbClr val="55555A"/>
                 </a:solidFill>
@@ -13049,22 +12835,22 @@
                 <a:ea typeface="Pretendard" pitchFamily="34" charset="-122"/>
                 <a:cs typeface="Pretendard" pitchFamily="34" charset="-120"/>
               </a:rPr>
-              <a:t>1-1. 썸네일</a:t>
-            </a:r>
-            <a:endParaRPr lang="en-US" sz="1100" dirty="0"/>
-          </a:p>
-        </p:txBody>
-      </p:sp>
-      <p:sp>
-        <p:nvSpPr>
-          <p:cNvPr id="40" name="Shape 38"/>
-          <p:cNvSpPr/>
-          <p:nvPr/>
-        </p:nvSpPr>
-        <p:spPr>
-          <a:xfrm>
-            <a:off x="1069848" y="5404104"/>
-            <a:ext cx="10051999" cy="0"/>
+              <a:t>→ [SV] 소식지/1. 제작</a:t>
+            </a:r>
+            <a:endParaRPr lang="en-US" sz="1050" dirty="0"/>
+          </a:p>
+        </p:txBody>
+      </p:sp>
+      <p:sp>
+        <p:nvSpPr>
+          <p:cNvPr id="35" name="Shape 33"/>
+          <p:cNvSpPr/>
+          <p:nvPr/>
+        </p:nvSpPr>
+        <p:spPr>
+          <a:xfrm>
+            <a:off x="6336792" y="3584448"/>
+            <a:ext cx="5074920" cy="0"/>
           </a:xfrm>
           <a:prstGeom prst="line">
             <a:avLst/>
@@ -13080,14 +12866,14 @@
       </p:sp>
       <p:sp>
         <p:nvSpPr>
-          <p:cNvPr id="41" name="Text 39"/>
-          <p:cNvSpPr/>
-          <p:nvPr/>
-        </p:nvSpPr>
-        <p:spPr>
-          <a:xfrm>
-            <a:off x="1069848" y="5422392"/>
-            <a:ext cx="3840480" cy="320040"/>
+          <p:cNvPr id="36" name="Text 34"/>
+          <p:cNvSpPr/>
+          <p:nvPr/>
+        </p:nvSpPr>
+        <p:spPr>
+          <a:xfrm>
+            <a:off x="6336792" y="3639312"/>
+            <a:ext cx="1874520" cy="365760"/>
           </a:xfrm>
           <a:prstGeom prst="rect">
             <a:avLst/>
@@ -13109,138 +12895,310 @@
               <a:rPr lang="en-US" sz="1150" dirty="0">
                 <a:solidFill>
                   <a:srgbClr val="1D1D1F"/>
+                </a:solidFill>
+                <a:latin typeface="Pretendard SemiBold" pitchFamily="34" charset="0"/>
+                <a:ea typeface="Pretendard SemiBold" pitchFamily="34" charset="-122"/>
+                <a:cs typeface="Pretendard SemiBold" pitchFamily="34" charset="-120"/>
+              </a:rPr>
+              <a:t>QR 이벤트</a:t>
+            </a:r>
+            <a:endParaRPr lang="en-US" sz="1150" dirty="0"/>
+          </a:p>
+        </p:txBody>
+      </p:sp>
+      <p:sp>
+        <p:nvSpPr>
+          <p:cNvPr id="37" name="Text 35"/>
+          <p:cNvSpPr/>
+          <p:nvPr/>
+        </p:nvSpPr>
+        <p:spPr>
+          <a:xfrm>
+            <a:off x="8257032" y="3639312"/>
+            <a:ext cx="3154680" cy="365760"/>
+          </a:xfrm>
+          <a:prstGeom prst="rect">
+            <a:avLst/>
+          </a:prstGeom>
+          <a:noFill/>
+          <a:ln/>
+        </p:spPr>
+        <p:txBody>
+          <a:bodyPr wrap="square" lIns="0" tIns="0" rIns="0" bIns="0" rtlCol="0" anchor="ctr"/>
+          <a:lstStyle/>
+          <a:p>
+            <a:pPr algn="l" indent="0" marL="0">
+              <a:lnSpc>
+                <a:spcPct val="130000"/>
+              </a:lnSpc>
+              <a:buNone/>
+            </a:pPr>
+            <a:r>
+              <a:rPr lang="en-US" sz="1050" dirty="0">
+                <a:solidFill>
+                  <a:srgbClr val="55555A"/>
+                </a:solidFill>
+                <a:latin typeface="Pretendard" pitchFamily="34" charset="0"/>
+                <a:ea typeface="Pretendard" pitchFamily="34" charset="-122"/>
+                <a:cs typeface="Pretendard" pitchFamily="34" charset="-120"/>
+              </a:rPr>
+              <a:t>→ makevu 3. 워크플로우</a:t>
+            </a:r>
+            <a:endParaRPr lang="en-US" sz="1050" dirty="0"/>
+          </a:p>
+        </p:txBody>
+      </p:sp>
+      <p:sp>
+        <p:nvSpPr>
+          <p:cNvPr id="38" name="Shape 36"/>
+          <p:cNvSpPr/>
+          <p:nvPr/>
+        </p:nvSpPr>
+        <p:spPr>
+          <a:xfrm>
+            <a:off x="6336792" y="4041648"/>
+            <a:ext cx="5074920" cy="0"/>
+          </a:xfrm>
+          <a:prstGeom prst="line">
+            <a:avLst/>
+          </a:prstGeom>
+          <a:noFill/>
+          <a:ln w="6350">
+            <a:solidFill>
+              <a:srgbClr val="F0F0F0"/>
+            </a:solidFill>
+            <a:prstDash val="solid"/>
+          </a:ln>
+        </p:spPr>
+      </p:sp>
+      <p:sp>
+        <p:nvSpPr>
+          <p:cNvPr id="39" name="Text 37"/>
+          <p:cNvSpPr/>
+          <p:nvPr/>
+        </p:nvSpPr>
+        <p:spPr>
+          <a:xfrm>
+            <a:off x="6336792" y="4096512"/>
+            <a:ext cx="1874520" cy="365760"/>
+          </a:xfrm>
+          <a:prstGeom prst="rect">
+            <a:avLst/>
+          </a:prstGeom>
+          <a:noFill/>
+          <a:ln/>
+        </p:spPr>
+        <p:txBody>
+          <a:bodyPr wrap="square" lIns="0" tIns="0" rIns="0" bIns="0" rtlCol="0" anchor="ctr"/>
+          <a:lstStyle/>
+          <a:p>
+            <a:pPr algn="l" indent="0" marL="0">
+              <a:lnSpc>
+                <a:spcPct val="130000"/>
+              </a:lnSpc>
+              <a:buNone/>
+            </a:pPr>
+            <a:r>
+              <a:rPr lang="en-US" sz="1150" dirty="0">
+                <a:solidFill>
+                  <a:srgbClr val="1D1D1F"/>
+                </a:solidFill>
+                <a:latin typeface="Pretendard SemiBold" pitchFamily="34" charset="0"/>
+                <a:ea typeface="Pretendard SemiBold" pitchFamily="34" charset="-122"/>
+                <a:cs typeface="Pretendard SemiBold" pitchFamily="34" charset="-120"/>
+              </a:rPr>
+              <a:t>블로그 썸네일</a:t>
+            </a:r>
+            <a:endParaRPr lang="en-US" sz="1150" dirty="0"/>
+          </a:p>
+        </p:txBody>
+      </p:sp>
+      <p:sp>
+        <p:nvSpPr>
+          <p:cNvPr id="40" name="Text 38"/>
+          <p:cNvSpPr/>
+          <p:nvPr/>
+        </p:nvSpPr>
+        <p:spPr>
+          <a:xfrm>
+            <a:off x="8257032" y="4096512"/>
+            <a:ext cx="3154680" cy="365760"/>
+          </a:xfrm>
+          <a:prstGeom prst="rect">
+            <a:avLst/>
+          </a:prstGeom>
+          <a:noFill/>
+          <a:ln/>
+        </p:spPr>
+        <p:txBody>
+          <a:bodyPr wrap="square" lIns="0" tIns="0" rIns="0" bIns="0" rtlCol="0" anchor="ctr"/>
+          <a:lstStyle/>
+          <a:p>
+            <a:pPr algn="l" indent="0" marL="0">
+              <a:lnSpc>
+                <a:spcPct val="130000"/>
+              </a:lnSpc>
+              <a:buNone/>
+            </a:pPr>
+            <a:r>
+              <a:rPr lang="en-US" sz="1050" dirty="0">
+                <a:solidFill>
+                  <a:srgbClr val="55555A"/>
+                </a:solidFill>
+                <a:latin typeface="Pretendard" pitchFamily="34" charset="0"/>
+                <a:ea typeface="Pretendard" pitchFamily="34" charset="-122"/>
+                <a:cs typeface="Pretendard" pitchFamily="34" charset="-120"/>
+              </a:rPr>
+              <a:t>→ marketing 1-1. 썸네일</a:t>
+            </a:r>
+            <a:endParaRPr lang="en-US" sz="1050" dirty="0"/>
+          </a:p>
+        </p:txBody>
+      </p:sp>
+      <p:sp>
+        <p:nvSpPr>
+          <p:cNvPr id="41" name="Shape 39"/>
+          <p:cNvSpPr/>
+          <p:nvPr/>
+        </p:nvSpPr>
+        <p:spPr>
+          <a:xfrm>
+            <a:off x="6336792" y="4498848"/>
+            <a:ext cx="5074920" cy="0"/>
+          </a:xfrm>
+          <a:prstGeom prst="line">
+            <a:avLst/>
+          </a:prstGeom>
+          <a:noFill/>
+          <a:ln w="6350">
+            <a:solidFill>
+              <a:srgbClr val="F0F0F0"/>
+            </a:solidFill>
+            <a:prstDash val="solid"/>
+          </a:ln>
+        </p:spPr>
+      </p:sp>
+      <p:sp>
+        <p:nvSpPr>
+          <p:cNvPr id="42" name="Text 40"/>
+          <p:cNvSpPr/>
+          <p:nvPr/>
+        </p:nvSpPr>
+        <p:spPr>
+          <a:xfrm>
+            <a:off x="6336792" y="4553712"/>
+            <a:ext cx="1874520" cy="365760"/>
+          </a:xfrm>
+          <a:prstGeom prst="rect">
+            <a:avLst/>
+          </a:prstGeom>
+          <a:noFill/>
+          <a:ln/>
+        </p:spPr>
+        <p:txBody>
+          <a:bodyPr wrap="square" lIns="0" tIns="0" rIns="0" bIns="0" rtlCol="0" anchor="ctr"/>
+          <a:lstStyle/>
+          <a:p>
+            <a:pPr algn="l" indent="0" marL="0">
+              <a:lnSpc>
+                <a:spcPct val="130000"/>
+              </a:lnSpc>
+              <a:buNone/>
+            </a:pPr>
+            <a:r>
+              <a:rPr lang="en-US" sz="1150" dirty="0">
+                <a:solidFill>
+                  <a:srgbClr val="1D1D1F"/>
+                </a:solidFill>
+                <a:latin typeface="Pretendard SemiBold" pitchFamily="34" charset="0"/>
+                <a:ea typeface="Pretendard SemiBold" pitchFamily="34" charset="-122"/>
+                <a:cs typeface="Pretendard SemiBold" pitchFamily="34" charset="-120"/>
+              </a:rPr>
+              <a:t>아이콘 제작</a:t>
+            </a:r>
+            <a:endParaRPr lang="en-US" sz="1150" dirty="0"/>
+          </a:p>
+        </p:txBody>
+      </p:sp>
+      <p:sp>
+        <p:nvSpPr>
+          <p:cNvPr id="43" name="Text 41"/>
+          <p:cNvSpPr/>
+          <p:nvPr/>
+        </p:nvSpPr>
+        <p:spPr>
+          <a:xfrm>
+            <a:off x="8257032" y="4553712"/>
+            <a:ext cx="3154680" cy="365760"/>
+          </a:xfrm>
+          <a:prstGeom prst="rect">
+            <a:avLst/>
+          </a:prstGeom>
+          <a:noFill/>
+          <a:ln/>
+        </p:spPr>
+        <p:txBody>
+          <a:bodyPr wrap="square" lIns="0" tIns="0" rIns="0" bIns="0" rtlCol="0" anchor="ctr"/>
+          <a:lstStyle/>
+          <a:p>
+            <a:pPr algn="l" indent="0" marL="0">
+              <a:lnSpc>
+                <a:spcPct val="130000"/>
+              </a:lnSpc>
+              <a:buNone/>
+            </a:pPr>
+            <a:r>
+              <a:rPr lang="en-US" sz="1050" dirty="0">
+                <a:solidFill>
+                  <a:srgbClr val="55555A"/>
+                </a:solidFill>
+                <a:latin typeface="Pretendard" pitchFamily="34" charset="0"/>
+                <a:ea typeface="Pretendard" pitchFamily="34" charset="-122"/>
+                <a:cs typeface="Pretendard" pitchFamily="34" charset="-120"/>
+              </a:rPr>
+              <a:t>→ [DS] skills/icon-use</a:t>
+            </a:r>
+            <a:endParaRPr lang="en-US" sz="1050" dirty="0"/>
+          </a:p>
+        </p:txBody>
+      </p:sp>
+      <p:sp>
+        <p:nvSpPr>
+          <p:cNvPr id="44" name="Text 42"/>
+          <p:cNvSpPr/>
+          <p:nvPr/>
+        </p:nvSpPr>
+        <p:spPr>
+          <a:xfrm>
+            <a:off x="777240" y="5806440"/>
+            <a:ext cx="10637215" cy="274320"/>
+          </a:xfrm>
+          <a:prstGeom prst="rect">
+            <a:avLst/>
+          </a:prstGeom>
+          <a:noFill/>
+          <a:ln/>
+        </p:spPr>
+        <p:txBody>
+          <a:bodyPr wrap="square" lIns="0" tIns="0" rIns="0" bIns="0" rtlCol="0" anchor="t"/>
+          <a:lstStyle/>
+          <a:p>
+            <a:pPr algn="l" indent="0" marL="0">
+              <a:lnSpc>
+                <a:spcPct val="130000"/>
+              </a:lnSpc>
+              <a:buNone/>
+            </a:pPr>
+            <a:r>
+              <a:rPr lang="en-US" sz="1100" dirty="0">
+                <a:solidFill>
+                  <a:srgbClr val="6E6E73"/>
                 </a:solidFill>
                 <a:latin typeface="Pretendard Medium" pitchFamily="34" charset="0"/>
                 <a:ea typeface="Pretendard Medium" pitchFamily="34" charset="-122"/>
                 <a:cs typeface="Pretendard Medium" pitchFamily="34" charset="-120"/>
               </a:rPr>
-              <a:t>“아이콘 바꿔줘”</a:t>
-            </a:r>
-            <a:endParaRPr lang="en-US" sz="1150" dirty="0"/>
-          </a:p>
-        </p:txBody>
-      </p:sp>
-      <p:sp>
-        <p:nvSpPr>
-          <p:cNvPr id="42" name="Text 40"/>
-          <p:cNvSpPr/>
-          <p:nvPr/>
-        </p:nvSpPr>
-        <p:spPr>
-          <a:xfrm>
-            <a:off x="4983480" y="5422392"/>
-            <a:ext cx="2468880" cy="320040"/>
-          </a:xfrm>
-          <a:prstGeom prst="rect">
-            <a:avLst/>
-          </a:prstGeom>
-          <a:noFill/>
-          <a:ln/>
-        </p:spPr>
-        <p:txBody>
-          <a:bodyPr wrap="square" lIns="0" tIns="0" rIns="0" bIns="0" rtlCol="0" anchor="ctr"/>
-          <a:lstStyle/>
-          <a:p>
-            <a:pPr algn="l" indent="0" marL="0">
-              <a:lnSpc>
-                <a:spcPct val="130000"/>
-              </a:lnSpc>
-              <a:buNone/>
-            </a:pPr>
-            <a:r>
-              <a:rPr lang="en-US" sz="1100" dirty="0">
-                <a:solidFill>
-                  <a:srgbClr val="6C4CFF"/>
-                </a:solidFill>
-                <a:latin typeface="Pretendard SemiBold" pitchFamily="34" charset="0"/>
-                <a:ea typeface="Pretendard SemiBold" pitchFamily="34" charset="-122"/>
-                <a:cs typeface="Pretendard SemiBold" pitchFamily="34" charset="-120"/>
-              </a:rPr>
-              <a:t>design-system</a:t>
-            </a:r>
-            <a:endParaRPr lang="en-US" sz="1100" dirty="0"/>
-          </a:p>
-        </p:txBody>
-      </p:sp>
-      <p:sp>
-        <p:nvSpPr>
-          <p:cNvPr id="43" name="Text 41"/>
-          <p:cNvSpPr/>
-          <p:nvPr/>
-        </p:nvSpPr>
-        <p:spPr>
-          <a:xfrm>
-            <a:off x="7543800" y="5422392"/>
-            <a:ext cx="3578047" cy="320040"/>
-          </a:xfrm>
-          <a:prstGeom prst="rect">
-            <a:avLst/>
-          </a:prstGeom>
-          <a:noFill/>
-          <a:ln/>
-        </p:spPr>
-        <p:txBody>
-          <a:bodyPr wrap="square" lIns="0" tIns="0" rIns="0" bIns="0" rtlCol="0" anchor="ctr"/>
-          <a:lstStyle/>
-          <a:p>
-            <a:pPr algn="l" indent="0" marL="0">
-              <a:lnSpc>
-                <a:spcPct val="130000"/>
-              </a:lnSpc>
-              <a:buNone/>
-            </a:pPr>
-            <a:r>
-              <a:rPr lang="en-US" sz="1100" dirty="0">
-                <a:solidFill>
-                  <a:srgbClr val="55555A"/>
-                </a:solidFill>
-                <a:latin typeface="Pretendard" pitchFamily="34" charset="0"/>
-                <a:ea typeface="Pretendard" pitchFamily="34" charset="-122"/>
-                <a:cs typeface="Pretendard" pitchFamily="34" charset="-120"/>
-              </a:rPr>
-              <a:t>skills/cdbd-icon-use</a:t>
-            </a:r>
-            <a:endParaRPr lang="en-US" sz="1100" dirty="0"/>
-          </a:p>
-        </p:txBody>
-      </p:sp>
-      <p:sp>
-        <p:nvSpPr>
-          <p:cNvPr id="44" name="Text 42"/>
-          <p:cNvSpPr/>
-          <p:nvPr/>
-        </p:nvSpPr>
-        <p:spPr>
-          <a:xfrm>
-            <a:off x="777240" y="5907024"/>
-            <a:ext cx="10637215" cy="274320"/>
-          </a:xfrm>
-          <a:prstGeom prst="rect">
-            <a:avLst/>
-          </a:prstGeom>
-          <a:noFill/>
-          <a:ln/>
-        </p:spPr>
-        <p:txBody>
-          <a:bodyPr wrap="square" lIns="0" tIns="0" rIns="0" bIns="0" rtlCol="0" anchor="t"/>
-          <a:lstStyle/>
-          <a:p>
-            <a:pPr algn="l" indent="0" marL="0">
-              <a:lnSpc>
-                <a:spcPct val="130000"/>
-              </a:lnSpc>
-              <a:buNone/>
-            </a:pPr>
-            <a:r>
-              <a:rPr lang="en-US" sz="1100" dirty="0">
-                <a:solidFill>
-                  <a:srgbClr val="6E6E73"/>
-                </a:solidFill>
-                <a:latin typeface="Pretendard Medium" pitchFamily="34" charset="0"/>
-                <a:ea typeface="Pretendard Medium" pitchFamily="34" charset="-122"/>
-                <a:cs typeface="Pretendard Medium" pitchFamily="34" charset="-120"/>
-              </a:rPr>
-              <a:t>핵심 — 각 줄이 ‘볼트 + 파일’을 가리켜, 어느 볼트 것이든 이 한 파일에서 라우팅됩니다.</a:t>
+              <a:t>핵심 — CdBd 기능뿐 아니라 룩북·QR·마케팅 작업까지 전부. 어느 볼트에서 켜도 이 한 파일로 다 압니다.</a:t>
             </a:r>
             <a:endParaRPr lang="en-US" sz="1100" dirty="0"/>
           </a:p>

</xml_diff>

<commit_message>
vault backup: 2026-08-11 21:32:59
</commit_message>
<xml_diff>
--- a/CdBd 기능 문서 구조 설계.pptx
+++ b/CdBd 기능 문서 구조 설계.pptx
@@ -11775,7 +11775,7 @@
                 <a:ea typeface="Pretendard" pitchFamily="34" charset="-122"/>
                 <a:cs typeface="Pretendard" pitchFamily="34" charset="-120"/>
               </a:rPr>
-              <a:t>10p 분류(에디터·대시보드) 그대로 + 다른 볼트 작업까지 합쳐, ‘어느 기능이 어느 파일에’.</a:t>
+              <a:t>10p 분류 그대로 · CdBd 기능만. 3개 볼트(T·SV·DS)에 흩어진 걸 한 파일에 모읍니다.</a:t>
             </a:r>
             <a:endParaRPr lang="en-US" sz="1500" dirty="0"/>
           </a:p>
@@ -11937,7 +11937,7 @@
                 <a:ea typeface="Pretendard SemiBold" pitchFamily="34" charset="-122"/>
                 <a:cs typeface="Pretendard SemiBold" pitchFamily="34" charset="-120"/>
               </a:rPr>
-              <a:t>CdBd 기능 (에디터 · 대시보드)</a:t>
+              <a:t>Ⓑ 에디터</a:t>
             </a:r>
             <a:endParaRPr lang="en-US" sz="1250" dirty="0"/>
           </a:p>
@@ -11974,8 +11974,8 @@
         </p:nvSpPr>
         <p:spPr>
           <a:xfrm>
-            <a:off x="777240" y="2724912"/>
-            <a:ext cx="1874520" cy="365760"/>
+            <a:off x="777240" y="2706624"/>
+            <a:ext cx="1965960" cy="347472"/>
           </a:xfrm>
           <a:prstGeom prst="rect">
             <a:avLst/>
@@ -11994,7 +11994,7 @@
               <a:buNone/>
             </a:pPr>
             <a:r>
-              <a:rPr lang="en-US" sz="1150" dirty="0">
+              <a:rPr lang="en-US" sz="1100" dirty="0">
                 <a:solidFill>
                   <a:srgbClr val="1D1D1F"/>
                 </a:solidFill>
@@ -12004,7 +12004,7 @@
               </a:rPr>
               <a:t>카드 15종</a:t>
             </a:r>
-            <a:endParaRPr lang="en-US" sz="1150" dirty="0"/>
+            <a:endParaRPr lang="en-US" sz="1100" dirty="0"/>
           </a:p>
         </p:txBody>
       </p:sp>
@@ -12016,8 +12016,8 @@
         </p:nvSpPr>
         <p:spPr>
           <a:xfrm>
-            <a:off x="2697480" y="2724912"/>
-            <a:ext cx="3154680" cy="365760"/>
+            <a:off x="2788920" y="2706624"/>
+            <a:ext cx="3063240" cy="347472"/>
           </a:xfrm>
           <a:prstGeom prst="rect">
             <a:avLst/>
@@ -12036,7 +12036,7 @@
               <a:buNone/>
             </a:pPr>
             <a:r>
-              <a:rPr lang="en-US" sz="1050" dirty="0">
+              <a:rPr lang="en-US" sz="1000" dirty="0">
                 <a:solidFill>
                   <a:srgbClr val="55555A"/>
                 </a:solidFill>
@@ -12046,7 +12046,7 @@
               </a:rPr>
               <a:t>→ [T] 1-6-2 · [DS] 4-x</a:t>
             </a:r>
-            <a:endParaRPr lang="en-US" sz="1050" dirty="0"/>
+            <a:endParaRPr lang="en-US" sz="1000" dirty="0"/>
           </a:p>
         </p:txBody>
       </p:sp>
@@ -12058,7 +12058,7 @@
         </p:nvSpPr>
         <p:spPr>
           <a:xfrm>
-            <a:off x="777240" y="3127248"/>
+            <a:off x="777240" y="3063240"/>
             <a:ext cx="5074920" cy="0"/>
           </a:xfrm>
           <a:prstGeom prst="line">
@@ -12081,8 +12081,8 @@
         </p:nvSpPr>
         <p:spPr>
           <a:xfrm>
-            <a:off x="777240" y="3182112"/>
-            <a:ext cx="1874520" cy="365760"/>
+            <a:off x="777240" y="3108960"/>
+            <a:ext cx="1965960" cy="347472"/>
           </a:xfrm>
           <a:prstGeom prst="rect">
             <a:avLst/>
@@ -12101,7 +12101,7 @@
               <a:buNone/>
             </a:pPr>
             <a:r>
-              <a:rPr lang="en-US" sz="1150" dirty="0">
+              <a:rPr lang="en-US" sz="1100" dirty="0">
                 <a:solidFill>
                   <a:srgbClr val="1D1D1F"/>
                 </a:solidFill>
@@ -12109,9 +12109,9 @@
                 <a:ea typeface="Pretendard SemiBold" pitchFamily="34" charset="-122"/>
                 <a:cs typeface="Pretendard SemiBold" pitchFamily="34" charset="-120"/>
               </a:rPr>
-              <a:t>페이지 구성·꾸미기</a:t>
-            </a:r>
-            <a:endParaRPr lang="en-US" sz="1150" dirty="0"/>
+              <a:t>카드 자동화</a:t>
+            </a:r>
+            <a:endParaRPr lang="en-US" sz="1100" dirty="0"/>
           </a:p>
         </p:txBody>
       </p:sp>
@@ -12123,8 +12123,8 @@
         </p:nvSpPr>
         <p:spPr>
           <a:xfrm>
-            <a:off x="2697480" y="3182112"/>
-            <a:ext cx="3154680" cy="365760"/>
+            <a:off x="2788920" y="3108960"/>
+            <a:ext cx="3063240" cy="347472"/>
           </a:xfrm>
           <a:prstGeom prst="rect">
             <a:avLst/>
@@ -12143,7 +12143,7 @@
               <a:buNone/>
             </a:pPr>
             <a:r>
-              <a:rPr lang="en-US" sz="1050" dirty="0">
+              <a:rPr lang="en-US" sz="1000" dirty="0">
                 <a:solidFill>
                   <a:srgbClr val="55555A"/>
                 </a:solidFill>
@@ -12151,9 +12151,9 @@
                 <a:ea typeface="Pretendard" pitchFamily="34" charset="-122"/>
                 <a:cs typeface="Pretendard" pitchFamily="34" charset="-120"/>
               </a:rPr>
-              <a:t>→ [DS] 3-2-x · [T] 1-6-1</a:t>
-            </a:r>
-            <a:endParaRPr lang="en-US" sz="1050" dirty="0"/>
+              <a:t>→ [T] skills/card-automation</a:t>
+            </a:r>
+            <a:endParaRPr lang="en-US" sz="1000" dirty="0"/>
           </a:p>
         </p:txBody>
       </p:sp>
@@ -12165,7 +12165,7 @@
         </p:nvSpPr>
         <p:spPr>
           <a:xfrm>
-            <a:off x="777240" y="3584448"/>
+            <a:off x="777240" y="3465576"/>
             <a:ext cx="5074920" cy="0"/>
           </a:xfrm>
           <a:prstGeom prst="line">
@@ -12188,8 +12188,8 @@
         </p:nvSpPr>
         <p:spPr>
           <a:xfrm>
-            <a:off x="777240" y="3639312"/>
-            <a:ext cx="1874520" cy="365760"/>
+            <a:off x="777240" y="3511296"/>
+            <a:ext cx="1965960" cy="347472"/>
           </a:xfrm>
           <a:prstGeom prst="rect">
             <a:avLst/>
@@ -12208,7 +12208,7 @@
               <a:buNone/>
             </a:pPr>
             <a:r>
-              <a:rPr lang="en-US" sz="1150" dirty="0">
+              <a:rPr lang="en-US" sz="1100" dirty="0">
                 <a:solidFill>
                   <a:srgbClr val="1D1D1F"/>
                 </a:solidFill>
@@ -12216,9 +12216,9 @@
                 <a:ea typeface="Pretendard SemiBold" pitchFamily="34" charset="-122"/>
                 <a:cs typeface="Pretendard SemiBold" pitchFamily="34" charset="-120"/>
               </a:rPr>
-              <a:t>게시 (URL · OG)</a:t>
-            </a:r>
-            <a:endParaRPr lang="en-US" sz="1150" dirty="0"/>
+              <a:t>페이지 구성·꾸미기</a:t>
+            </a:r>
+            <a:endParaRPr lang="en-US" sz="1100" dirty="0"/>
           </a:p>
         </p:txBody>
       </p:sp>
@@ -12230,8 +12230,8 @@
         </p:nvSpPr>
         <p:spPr>
           <a:xfrm>
-            <a:off x="2697480" y="3639312"/>
-            <a:ext cx="3154680" cy="365760"/>
+            <a:off x="2788920" y="3511296"/>
+            <a:ext cx="3063240" cy="347472"/>
           </a:xfrm>
           <a:prstGeom prst="rect">
             <a:avLst/>
@@ -12250,7 +12250,7 @@
               <a:buNone/>
             </a:pPr>
             <a:r>
-              <a:rPr lang="en-US" sz="1050" dirty="0">
+              <a:rPr lang="en-US" sz="1000" dirty="0">
                 <a:solidFill>
                   <a:srgbClr val="55555A"/>
                 </a:solidFill>
@@ -12258,9 +12258,9 @@
                 <a:ea typeface="Pretendard" pitchFamily="34" charset="-122"/>
                 <a:cs typeface="Pretendard" pitchFamily="34" charset="-120"/>
               </a:rPr>
-              <a:t>→ [SV] 1-4 §게시</a:t>
-            </a:r>
-            <a:endParaRPr lang="en-US" sz="1050" dirty="0"/>
+              <a:t>→ [DS] 3-2-x · [T] 1-6-1</a:t>
+            </a:r>
+            <a:endParaRPr lang="en-US" sz="1000" dirty="0"/>
           </a:p>
         </p:txBody>
       </p:sp>
@@ -12272,7 +12272,7 @@
         </p:nvSpPr>
         <p:spPr>
           <a:xfrm>
-            <a:off x="777240" y="4041648"/>
+            <a:off x="777240" y="3867912"/>
             <a:ext cx="5074920" cy="0"/>
           </a:xfrm>
           <a:prstGeom prst="line">
@@ -12295,8 +12295,8 @@
         </p:nvSpPr>
         <p:spPr>
           <a:xfrm>
-            <a:off x="777240" y="4096512"/>
-            <a:ext cx="1874520" cy="365760"/>
+            <a:off x="777240" y="3913632"/>
+            <a:ext cx="1965960" cy="347472"/>
           </a:xfrm>
           <a:prstGeom prst="rect">
             <a:avLst/>
@@ -12315,7 +12315,7 @@
               <a:buNone/>
             </a:pPr>
             <a:r>
-              <a:rPr lang="en-US" sz="1150" dirty="0">
+              <a:rPr lang="en-US" sz="1100" dirty="0">
                 <a:solidFill>
                   <a:srgbClr val="1D1D1F"/>
                 </a:solidFill>
@@ -12323,9 +12323,9 @@
                 <a:ea typeface="Pretendard SemiBold" pitchFamily="34" charset="-122"/>
                 <a:cs typeface="Pretendard SemiBold" pitchFamily="34" charset="-120"/>
               </a:rPr>
-              <a:t>페이지 · URL 통계</a:t>
-            </a:r>
-            <a:endParaRPr lang="en-US" sz="1150" dirty="0"/>
+              <a:t>이미지 라이브러리</a:t>
+            </a:r>
+            <a:endParaRPr lang="en-US" sz="1100" dirty="0"/>
           </a:p>
         </p:txBody>
       </p:sp>
@@ -12337,8 +12337,8 @@
         </p:nvSpPr>
         <p:spPr>
           <a:xfrm>
-            <a:off x="2697480" y="4096512"/>
-            <a:ext cx="3154680" cy="365760"/>
+            <a:off x="2788920" y="3913632"/>
+            <a:ext cx="3063240" cy="347472"/>
           </a:xfrm>
           <a:prstGeom prst="rect">
             <a:avLst/>
@@ -12357,7 +12357,7 @@
               <a:buNone/>
             </a:pPr>
             <a:r>
-              <a:rPr lang="en-US" sz="1050" dirty="0">
+              <a:rPr lang="en-US" sz="1000" dirty="0">
                 <a:solidFill>
                   <a:srgbClr val="55555A"/>
                 </a:solidFill>
@@ -12365,9 +12365,9 @@
                 <a:ea typeface="Pretendard" pitchFamily="34" charset="-122"/>
                 <a:cs typeface="Pretendard" pitchFamily="34" charset="-120"/>
               </a:rPr>
-              <a:t>→ [DS] 3-11 통계</a:t>
-            </a:r>
-            <a:endParaRPr lang="en-US" sz="1050" dirty="0"/>
+              <a:t>→ [SV] CLAUDE §이미지</a:t>
+            </a:r>
+            <a:endParaRPr lang="en-US" sz="1000" dirty="0"/>
           </a:p>
         </p:txBody>
       </p:sp>
@@ -12379,7 +12379,7 @@
         </p:nvSpPr>
         <p:spPr>
           <a:xfrm>
-            <a:off x="777240" y="4498848"/>
+            <a:off x="777240" y="4270248"/>
             <a:ext cx="5074920" cy="0"/>
           </a:xfrm>
           <a:prstGeom prst="line">
@@ -12402,8 +12402,8 @@
         </p:nvSpPr>
         <p:spPr>
           <a:xfrm>
-            <a:off x="777240" y="4553712"/>
-            <a:ext cx="1874520" cy="365760"/>
+            <a:off x="777240" y="4315968"/>
+            <a:ext cx="1965960" cy="347472"/>
           </a:xfrm>
           <a:prstGeom prst="rect">
             <a:avLst/>
@@ -12422,7 +12422,7 @@
               <a:buNone/>
             </a:pPr>
             <a:r>
-              <a:rPr lang="en-US" sz="1150" dirty="0">
+              <a:rPr lang="en-US" sz="1100" dirty="0">
                 <a:solidFill>
                   <a:srgbClr val="1D1D1F"/>
                 </a:solidFill>
@@ -12430,9 +12430,9 @@
                 <a:ea typeface="Pretendard SemiBold" pitchFamily="34" charset="-122"/>
                 <a:cs typeface="Pretendard SemiBold" pitchFamily="34" charset="-120"/>
               </a:rPr>
-              <a:t>계정 · 주소 · 요금</a:t>
-            </a:r>
-            <a:endParaRPr lang="en-US" sz="1150" dirty="0"/>
+              <a:t>게시 (URL · OG)</a:t>
+            </a:r>
+            <a:endParaRPr lang="en-US" sz="1100" dirty="0"/>
           </a:p>
         </p:txBody>
       </p:sp>
@@ -12444,8 +12444,8 @@
         </p:nvSpPr>
         <p:spPr>
           <a:xfrm>
-            <a:off x="2697480" y="4553712"/>
-            <a:ext cx="3154680" cy="365760"/>
+            <a:off x="2788920" y="4315968"/>
+            <a:ext cx="3063240" cy="347472"/>
           </a:xfrm>
           <a:prstGeom prst="rect">
             <a:avLst/>
@@ -12464,7 +12464,7 @@
               <a:buNone/>
             </a:pPr>
             <a:r>
-              <a:rPr lang="en-US" sz="1050" dirty="0">
+              <a:rPr lang="en-US" sz="1000" dirty="0">
                 <a:solidFill>
                   <a:srgbClr val="55555A"/>
                 </a:solidFill>
@@ -12472,9 +12472,9 @@
                 <a:ea typeface="Pretendard" pitchFamily="34" charset="-122"/>
                 <a:cs typeface="Pretendard" pitchFamily="34" charset="-120"/>
               </a:rPr>
-              <a:t>→ [DS] 3-8 · 3-5</a:t>
-            </a:r>
-            <a:endParaRPr lang="en-US" sz="1050" dirty="0"/>
+              <a:t>→ [SV] 1-4 §게시</a:t>
+            </a:r>
+            <a:endParaRPr lang="en-US" sz="1000" dirty="0"/>
           </a:p>
         </p:txBody>
       </p:sp>
@@ -12486,7 +12486,7 @@
         </p:nvSpPr>
         <p:spPr>
           <a:xfrm>
-            <a:off x="777240" y="4956048"/>
+            <a:off x="777240" y="4672584"/>
             <a:ext cx="5074920" cy="0"/>
           </a:xfrm>
           <a:prstGeom prst="line">
@@ -12509,8 +12509,8 @@
         </p:nvSpPr>
         <p:spPr>
           <a:xfrm>
-            <a:off x="777240" y="5010912"/>
-            <a:ext cx="1874520" cy="365760"/>
+            <a:off x="777240" y="4718304"/>
+            <a:ext cx="1965960" cy="347472"/>
           </a:xfrm>
           <a:prstGeom prst="rect">
             <a:avLst/>
@@ -12529,7 +12529,7 @@
               <a:buNone/>
             </a:pPr>
             <a:r>
-              <a:rPr lang="en-US" sz="1150" dirty="0">
+              <a:rPr lang="en-US" sz="1100" dirty="0">
                 <a:solidFill>
                   <a:srgbClr val="1D1D1F"/>
                 </a:solidFill>
@@ -12537,9 +12537,9 @@
                 <a:ea typeface="Pretendard SemiBold" pitchFamily="34" charset="-122"/>
                 <a:cs typeface="Pretendard SemiBold" pitchFamily="34" charset="-120"/>
               </a:rPr>
-              <a:t>버전 · 권한</a:t>
-            </a:r>
-            <a:endParaRPr lang="en-US" sz="1150" dirty="0"/>
+              <a:t>페이지 비밀번호</a:t>
+            </a:r>
+            <a:endParaRPr lang="en-US" sz="1100" dirty="0"/>
           </a:p>
         </p:txBody>
       </p:sp>
@@ -12551,8 +12551,8 @@
         </p:nvSpPr>
         <p:spPr>
           <a:xfrm>
-            <a:off x="2697480" y="5010912"/>
-            <a:ext cx="3154680" cy="365760"/>
+            <a:off x="2788920" y="4718304"/>
+            <a:ext cx="3063240" cy="347472"/>
           </a:xfrm>
           <a:prstGeom prst="rect">
             <a:avLst/>
@@ -12571,7 +12571,7 @@
               <a:buNone/>
             </a:pPr>
             <a:r>
-              <a:rPr lang="en-US" sz="1050" dirty="0">
+              <a:rPr lang="en-US" sz="1000" dirty="0">
                 <a:solidFill>
                   <a:srgbClr val="55555A"/>
                 </a:solidFill>
@@ -12579,31 +12579,54 @@
                 <a:ea typeface="Pretendard" pitchFamily="34" charset="-122"/>
                 <a:cs typeface="Pretendard" pitchFamily="34" charset="-120"/>
               </a:rPr>
-              <a:t>→ [DS] 3-15 · 3-13</a:t>
-            </a:r>
-            <a:endParaRPr lang="en-US" sz="1050" dirty="0"/>
-          </a:p>
-        </p:txBody>
-      </p:sp>
-      <p:sp>
-        <p:nvSpPr>
-          <p:cNvPr id="28" name="Text 26"/>
-          <p:cNvSpPr/>
-          <p:nvPr/>
-        </p:nvSpPr>
-        <p:spPr>
-          <a:xfrm>
-            <a:off x="6336792" y="2286000"/>
-            <a:ext cx="5074920" cy="274320"/>
-          </a:xfrm>
-          <a:prstGeom prst="rect">
-            <a:avLst/>
-          </a:prstGeom>
-          <a:noFill/>
-          <a:ln/>
-        </p:spPr>
-        <p:txBody>
-          <a:bodyPr wrap="square" lIns="0" tIns="0" rIns="0" bIns="0" rtlCol="0" anchor="t"/>
+              <a:t>→ [SV] 1-4 모달</a:t>
+            </a:r>
+            <a:endParaRPr lang="en-US" sz="1000" dirty="0"/>
+          </a:p>
+        </p:txBody>
+      </p:sp>
+      <p:sp>
+        <p:nvSpPr>
+          <p:cNvPr id="28" name="Shape 26"/>
+          <p:cNvSpPr/>
+          <p:nvPr/>
+        </p:nvSpPr>
+        <p:spPr>
+          <a:xfrm>
+            <a:off x="777240" y="5074920"/>
+            <a:ext cx="5074920" cy="0"/>
+          </a:xfrm>
+          <a:prstGeom prst="line">
+            <a:avLst/>
+          </a:prstGeom>
+          <a:noFill/>
+          <a:ln w="6350">
+            <a:solidFill>
+              <a:srgbClr val="F0F0F0"/>
+            </a:solidFill>
+            <a:prstDash val="solid"/>
+          </a:ln>
+        </p:spPr>
+      </p:sp>
+      <p:sp>
+        <p:nvSpPr>
+          <p:cNvPr id="29" name="Text 27"/>
+          <p:cNvSpPr/>
+          <p:nvPr/>
+        </p:nvSpPr>
+        <p:spPr>
+          <a:xfrm>
+            <a:off x="777240" y="5120640"/>
+            <a:ext cx="1965960" cy="347472"/>
+          </a:xfrm>
+          <a:prstGeom prst="rect">
+            <a:avLst/>
+          </a:prstGeom>
+          <a:noFill/>
+          <a:ln/>
+        </p:spPr>
+        <p:txBody>
+          <a:bodyPr wrap="square" lIns="0" tIns="0" rIns="0" bIns="0" rtlCol="0" anchor="ctr"/>
           <a:lstStyle/>
           <a:p>
             <a:pPr algn="l" indent="0" marL="0">
@@ -12613,15 +12636,99 @@
               <a:buNone/>
             </a:pPr>
             <a:r>
-              <a:rPr lang="en-US" sz="1250" dirty="0">
-                <a:solidFill>
-                  <a:srgbClr val="6C4CFF"/>
+              <a:rPr lang="en-US" sz="1100" dirty="0">
+                <a:solidFill>
+                  <a:srgbClr val="1D1D1F"/>
                 </a:solidFill>
                 <a:latin typeface="Pretendard SemiBold" pitchFamily="34" charset="0"/>
                 <a:ea typeface="Pretendard SemiBold" pitchFamily="34" charset="-122"/>
                 <a:cs typeface="Pretendard SemiBold" pitchFamily="34" charset="-120"/>
               </a:rPr>
-              <a:t>다른 볼트 — 제작 작업</a:t>
+              <a:t>데이터 연결</a:t>
+            </a:r>
+            <a:endParaRPr lang="en-US" sz="1100" dirty="0"/>
+          </a:p>
+        </p:txBody>
+      </p:sp>
+      <p:sp>
+        <p:nvSpPr>
+          <p:cNvPr id="30" name="Text 28"/>
+          <p:cNvSpPr/>
+          <p:nvPr/>
+        </p:nvSpPr>
+        <p:spPr>
+          <a:xfrm>
+            <a:off x="2788920" y="5120640"/>
+            <a:ext cx="3063240" cy="347472"/>
+          </a:xfrm>
+          <a:prstGeom prst="rect">
+            <a:avLst/>
+          </a:prstGeom>
+          <a:noFill/>
+          <a:ln/>
+        </p:spPr>
+        <p:txBody>
+          <a:bodyPr wrap="square" lIns="0" tIns="0" rIns="0" bIns="0" rtlCol="0" anchor="ctr"/>
+          <a:lstStyle/>
+          <a:p>
+            <a:pPr algn="l" indent="0" marL="0">
+              <a:lnSpc>
+                <a:spcPct val="130000"/>
+              </a:lnSpc>
+              <a:buNone/>
+            </a:pPr>
+            <a:r>
+              <a:rPr lang="en-US" sz="1000" dirty="0">
+                <a:solidFill>
+                  <a:srgbClr val="55555A"/>
+                </a:solidFill>
+                <a:latin typeface="Pretendard" pitchFamily="34" charset="0"/>
+                <a:ea typeface="Pretendard" pitchFamily="34" charset="-122"/>
+                <a:cs typeface="Pretendard" pitchFamily="34" charset="-120"/>
+              </a:rPr>
+              <a:t>→ [DS] 3-10 데이터 관리</a:t>
+            </a:r>
+            <a:endParaRPr lang="en-US" sz="1000" dirty="0"/>
+          </a:p>
+        </p:txBody>
+      </p:sp>
+      <p:sp>
+        <p:nvSpPr>
+          <p:cNvPr id="31" name="Text 29"/>
+          <p:cNvSpPr/>
+          <p:nvPr/>
+        </p:nvSpPr>
+        <p:spPr>
+          <a:xfrm>
+            <a:off x="6336792" y="2286000"/>
+            <a:ext cx="5074920" cy="274320"/>
+          </a:xfrm>
+          <a:prstGeom prst="rect">
+            <a:avLst/>
+          </a:prstGeom>
+          <a:noFill/>
+          <a:ln/>
+        </p:spPr>
+        <p:txBody>
+          <a:bodyPr wrap="square" lIns="0" tIns="0" rIns="0" bIns="0" rtlCol="0" anchor="t"/>
+          <a:lstStyle/>
+          <a:p>
+            <a:pPr algn="l" indent="0" marL="0">
+              <a:lnSpc>
+                <a:spcPct val="130000"/>
+              </a:lnSpc>
+              <a:buNone/>
+            </a:pPr>
+            <a:r>
+              <a:rPr lang="en-US" sz="1250" dirty="0">
+                <a:solidFill>
+                  <a:srgbClr val="6C4CFF"/>
+                </a:solidFill>
+                <a:latin typeface="Pretendard SemiBold" pitchFamily="34" charset="0"/>
+                <a:ea typeface="Pretendard SemiBold" pitchFamily="34" charset="-122"/>
+                <a:cs typeface="Pretendard SemiBold" pitchFamily="34" charset="-120"/>
+              </a:rPr>
+              <a:t>Ⓐ 대시보드 (계정)</a:t>
             </a:r>
             <a:endParaRPr lang="en-US" sz="1250" dirty="0"/>
           </a:p>
@@ -12629,7 +12736,7 @@
       </p:sp>
       <p:sp>
         <p:nvSpPr>
-          <p:cNvPr id="29" name="Shape 27"/>
+          <p:cNvPr id="32" name="Shape 30"/>
           <p:cNvSpPr/>
           <p:nvPr/>
         </p:nvSpPr>
@@ -12652,14 +12759,14 @@
       </p:sp>
       <p:sp>
         <p:nvSpPr>
-          <p:cNvPr id="30" name="Text 28"/>
-          <p:cNvSpPr/>
-          <p:nvPr/>
-        </p:nvSpPr>
-        <p:spPr>
-          <a:xfrm>
-            <a:off x="6336792" y="2724912"/>
-            <a:ext cx="1874520" cy="365760"/>
+          <p:cNvPr id="33" name="Text 31"/>
+          <p:cNvSpPr/>
+          <p:nvPr/>
+        </p:nvSpPr>
+        <p:spPr>
+          <a:xfrm>
+            <a:off x="6336792" y="2706624"/>
+            <a:ext cx="1965960" cy="347472"/>
           </a:xfrm>
           <a:prstGeom prst="rect">
             <a:avLst/>
@@ -12678,7 +12785,7 @@
               <a:buNone/>
             </a:pPr>
             <a:r>
-              <a:rPr lang="en-US" sz="1150" dirty="0">
+              <a:rPr lang="en-US" sz="1100" dirty="0">
                 <a:solidFill>
                   <a:srgbClr val="1D1D1F"/>
                 </a:solidFill>
@@ -12686,22 +12793,22 @@
                 <a:ea typeface="Pretendard SemiBold" pitchFamily="34" charset="-122"/>
                 <a:cs typeface="Pretendard SemiBold" pitchFamily="34" charset="-120"/>
               </a:rPr>
-              <a:t>룩북 시안</a:t>
-            </a:r>
-            <a:endParaRPr lang="en-US" sz="1150" dirty="0"/>
-          </a:p>
-        </p:txBody>
-      </p:sp>
-      <p:sp>
-        <p:nvSpPr>
-          <p:cNvPr id="31" name="Text 29"/>
-          <p:cNvSpPr/>
-          <p:nvPr/>
-        </p:nvSpPr>
-        <p:spPr>
-          <a:xfrm>
-            <a:off x="8257032" y="2724912"/>
-            <a:ext cx="3154680" cy="365760"/>
+              <a:t>회원가입 · 로그인</a:t>
+            </a:r>
+            <a:endParaRPr lang="en-US" sz="1100" dirty="0"/>
+          </a:p>
+        </p:txBody>
+      </p:sp>
+      <p:sp>
+        <p:nvSpPr>
+          <p:cNvPr id="34" name="Text 32"/>
+          <p:cNvSpPr/>
+          <p:nvPr/>
+        </p:nvSpPr>
+        <p:spPr>
+          <a:xfrm>
+            <a:off x="8348472" y="2706624"/>
+            <a:ext cx="3063240" cy="347472"/>
           </a:xfrm>
           <a:prstGeom prst="rect">
             <a:avLst/>
@@ -12720,7 +12827,7 @@
               <a:buNone/>
             </a:pPr>
             <a:r>
-              <a:rPr lang="en-US" sz="1050" dirty="0">
+              <a:rPr lang="en-US" sz="1000" dirty="0">
                 <a:solidFill>
                   <a:srgbClr val="55555A"/>
                 </a:solidFill>
@@ -12728,21 +12835,21 @@
                 <a:ea typeface="Pretendard" pitchFamily="34" charset="-122"/>
                 <a:cs typeface="Pretendard" pitchFamily="34" charset="-120"/>
               </a:rPr>
-              <a:t>→ [SV] 룩북/1-2. 시안</a:t>
-            </a:r>
-            <a:endParaRPr lang="en-US" sz="1050" dirty="0"/>
-          </a:p>
-        </p:txBody>
-      </p:sp>
-      <p:sp>
-        <p:nvSpPr>
-          <p:cNvPr id="32" name="Shape 30"/>
-          <p:cNvSpPr/>
-          <p:nvPr/>
-        </p:nvSpPr>
-        <p:spPr>
-          <a:xfrm>
-            <a:off x="6336792" y="3127248"/>
+              <a:t>→ [DS] 3-6</a:t>
+            </a:r>
+            <a:endParaRPr lang="en-US" sz="1000" dirty="0"/>
+          </a:p>
+        </p:txBody>
+      </p:sp>
+      <p:sp>
+        <p:nvSpPr>
+          <p:cNvPr id="35" name="Shape 33"/>
+          <p:cNvSpPr/>
+          <p:nvPr/>
+        </p:nvSpPr>
+        <p:spPr>
+          <a:xfrm>
+            <a:off x="6336792" y="3063240"/>
             <a:ext cx="5074920" cy="0"/>
           </a:xfrm>
           <a:prstGeom prst="line">
@@ -12759,14 +12866,14 @@
       </p:sp>
       <p:sp>
         <p:nvSpPr>
-          <p:cNvPr id="33" name="Text 31"/>
-          <p:cNvSpPr/>
-          <p:nvPr/>
-        </p:nvSpPr>
-        <p:spPr>
-          <a:xfrm>
-            <a:off x="6336792" y="3182112"/>
-            <a:ext cx="1874520" cy="365760"/>
+          <p:cNvPr id="36" name="Text 34"/>
+          <p:cNvSpPr/>
+          <p:nvPr/>
+        </p:nvSpPr>
+        <p:spPr>
+          <a:xfrm>
+            <a:off x="6336792" y="3108960"/>
+            <a:ext cx="1965960" cy="347472"/>
           </a:xfrm>
           <a:prstGeom prst="rect">
             <a:avLst/>
@@ -12785,7 +12892,7 @@
               <a:buNone/>
             </a:pPr>
             <a:r>
-              <a:rPr lang="en-US" sz="1150" dirty="0">
+              <a:rPr lang="en-US" sz="1100" dirty="0">
                 <a:solidFill>
                   <a:srgbClr val="1D1D1F"/>
                 </a:solidFill>
@@ -12793,22 +12900,22 @@
                 <a:ea typeface="Pretendard SemiBold" pitchFamily="34" charset="-122"/>
                 <a:cs typeface="Pretendard SemiBold" pitchFamily="34" charset="-120"/>
               </a:rPr>
-              <a:t>소식지</a:t>
-            </a:r>
-            <a:endParaRPr lang="en-US" sz="1150" dirty="0"/>
-          </a:p>
-        </p:txBody>
-      </p:sp>
-      <p:sp>
-        <p:nvSpPr>
-          <p:cNvPr id="34" name="Text 32"/>
-          <p:cNvSpPr/>
-          <p:nvPr/>
-        </p:nvSpPr>
-        <p:spPr>
-          <a:xfrm>
-            <a:off x="8257032" y="3182112"/>
-            <a:ext cx="3154680" cy="365760"/>
+              <a:t>홈 · 내 페이지 · 공유</a:t>
+            </a:r>
+            <a:endParaRPr lang="en-US" sz="1100" dirty="0"/>
+          </a:p>
+        </p:txBody>
+      </p:sp>
+      <p:sp>
+        <p:nvSpPr>
+          <p:cNvPr id="37" name="Text 35"/>
+          <p:cNvSpPr/>
+          <p:nvPr/>
+        </p:nvSpPr>
+        <p:spPr>
+          <a:xfrm>
+            <a:off x="8348472" y="3108960"/>
+            <a:ext cx="3063240" cy="347472"/>
           </a:xfrm>
           <a:prstGeom prst="rect">
             <a:avLst/>
@@ -12827,7 +12934,7 @@
               <a:buNone/>
             </a:pPr>
             <a:r>
-              <a:rPr lang="en-US" sz="1050" dirty="0">
+              <a:rPr lang="en-US" sz="1000" dirty="0">
                 <a:solidFill>
                   <a:srgbClr val="55555A"/>
                 </a:solidFill>
@@ -12835,21 +12942,21 @@
                 <a:ea typeface="Pretendard" pitchFamily="34" charset="-122"/>
                 <a:cs typeface="Pretendard" pitchFamily="34" charset="-120"/>
               </a:rPr>
-              <a:t>→ [SV] 소식지/1. 제작</a:t>
-            </a:r>
-            <a:endParaRPr lang="en-US" sz="1050" dirty="0"/>
-          </a:p>
-        </p:txBody>
-      </p:sp>
-      <p:sp>
-        <p:nvSpPr>
-          <p:cNvPr id="35" name="Shape 33"/>
-          <p:cNvSpPr/>
-          <p:nvPr/>
-        </p:nvSpPr>
-        <p:spPr>
-          <a:xfrm>
-            <a:off x="6336792" y="3584448"/>
+              <a:t>→ [DS] 3-7 · 3-9</a:t>
+            </a:r>
+            <a:endParaRPr lang="en-US" sz="1000" dirty="0"/>
+          </a:p>
+        </p:txBody>
+      </p:sp>
+      <p:sp>
+        <p:nvSpPr>
+          <p:cNvPr id="38" name="Shape 36"/>
+          <p:cNvSpPr/>
+          <p:nvPr/>
+        </p:nvSpPr>
+        <p:spPr>
+          <a:xfrm>
+            <a:off x="6336792" y="3465576"/>
             <a:ext cx="5074920" cy="0"/>
           </a:xfrm>
           <a:prstGeom prst="line">
@@ -12866,14 +12973,14 @@
       </p:sp>
       <p:sp>
         <p:nvSpPr>
-          <p:cNvPr id="36" name="Text 34"/>
-          <p:cNvSpPr/>
-          <p:nvPr/>
-        </p:nvSpPr>
-        <p:spPr>
-          <a:xfrm>
-            <a:off x="6336792" y="3639312"/>
-            <a:ext cx="1874520" cy="365760"/>
+          <p:cNvPr id="39" name="Text 37"/>
+          <p:cNvSpPr/>
+          <p:nvPr/>
+        </p:nvSpPr>
+        <p:spPr>
+          <a:xfrm>
+            <a:off x="6336792" y="3511296"/>
+            <a:ext cx="1965960" cy="347472"/>
           </a:xfrm>
           <a:prstGeom prst="rect">
             <a:avLst/>
@@ -12892,7 +12999,7 @@
               <a:buNone/>
             </a:pPr>
             <a:r>
-              <a:rPr lang="en-US" sz="1150" dirty="0">
+              <a:rPr lang="en-US" sz="1100" dirty="0">
                 <a:solidFill>
                   <a:srgbClr val="1D1D1F"/>
                 </a:solidFill>
@@ -12900,22 +13007,22 @@
                 <a:ea typeface="Pretendard SemiBold" pitchFamily="34" charset="-122"/>
                 <a:cs typeface="Pretendard SemiBold" pitchFamily="34" charset="-120"/>
               </a:rPr>
-              <a:t>QR 이벤트</a:t>
-            </a:r>
-            <a:endParaRPr lang="en-US" sz="1150" dirty="0"/>
-          </a:p>
-        </p:txBody>
-      </p:sp>
-      <p:sp>
-        <p:nvSpPr>
-          <p:cNvPr id="37" name="Text 35"/>
-          <p:cNvSpPr/>
-          <p:nvPr/>
-        </p:nvSpPr>
-        <p:spPr>
-          <a:xfrm>
-            <a:off x="8257032" y="3639312"/>
-            <a:ext cx="3154680" cy="365760"/>
+              <a:t>버전 기록</a:t>
+            </a:r>
+            <a:endParaRPr lang="en-US" sz="1100" dirty="0"/>
+          </a:p>
+        </p:txBody>
+      </p:sp>
+      <p:sp>
+        <p:nvSpPr>
+          <p:cNvPr id="40" name="Text 38"/>
+          <p:cNvSpPr/>
+          <p:nvPr/>
+        </p:nvSpPr>
+        <p:spPr>
+          <a:xfrm>
+            <a:off x="8348472" y="3511296"/>
+            <a:ext cx="3063240" cy="347472"/>
           </a:xfrm>
           <a:prstGeom prst="rect">
             <a:avLst/>
@@ -12934,7 +13041,7 @@
               <a:buNone/>
             </a:pPr>
             <a:r>
-              <a:rPr lang="en-US" sz="1050" dirty="0">
+              <a:rPr lang="en-US" sz="1000" dirty="0">
                 <a:solidFill>
                   <a:srgbClr val="55555A"/>
                 </a:solidFill>
@@ -12942,21 +13049,21 @@
                 <a:ea typeface="Pretendard" pitchFamily="34" charset="-122"/>
                 <a:cs typeface="Pretendard" pitchFamily="34" charset="-120"/>
               </a:rPr>
-              <a:t>→ makevu 3. 워크플로우</a:t>
-            </a:r>
-            <a:endParaRPr lang="en-US" sz="1050" dirty="0"/>
-          </a:p>
-        </p:txBody>
-      </p:sp>
-      <p:sp>
-        <p:nvSpPr>
-          <p:cNvPr id="38" name="Shape 36"/>
-          <p:cNvSpPr/>
-          <p:nvPr/>
-        </p:nvSpPr>
-        <p:spPr>
-          <a:xfrm>
-            <a:off x="6336792" y="4041648"/>
+              <a:t>→ [DS] 3-15</a:t>
+            </a:r>
+            <a:endParaRPr lang="en-US" sz="1000" dirty="0"/>
+          </a:p>
+        </p:txBody>
+      </p:sp>
+      <p:sp>
+        <p:nvSpPr>
+          <p:cNvPr id="41" name="Shape 39"/>
+          <p:cNvSpPr/>
+          <p:nvPr/>
+        </p:nvSpPr>
+        <p:spPr>
+          <a:xfrm>
+            <a:off x="6336792" y="3867912"/>
             <a:ext cx="5074920" cy="0"/>
           </a:xfrm>
           <a:prstGeom prst="line">
@@ -12973,14 +13080,14 @@
       </p:sp>
       <p:sp>
         <p:nvSpPr>
-          <p:cNvPr id="39" name="Text 37"/>
-          <p:cNvSpPr/>
-          <p:nvPr/>
-        </p:nvSpPr>
-        <p:spPr>
-          <a:xfrm>
-            <a:off x="6336792" y="4096512"/>
-            <a:ext cx="1874520" cy="365760"/>
+          <p:cNvPr id="42" name="Text 40"/>
+          <p:cNvSpPr/>
+          <p:nvPr/>
+        </p:nvSpPr>
+        <p:spPr>
+          <a:xfrm>
+            <a:off x="6336792" y="3913632"/>
+            <a:ext cx="1965960" cy="347472"/>
           </a:xfrm>
           <a:prstGeom prst="rect">
             <a:avLst/>
@@ -12999,7 +13106,7 @@
               <a:buNone/>
             </a:pPr>
             <a:r>
-              <a:rPr lang="en-US" sz="1150" dirty="0">
+              <a:rPr lang="en-US" sz="1100" dirty="0">
                 <a:solidFill>
                   <a:srgbClr val="1D1D1F"/>
                 </a:solidFill>
@@ -13007,22 +13114,22 @@
                 <a:ea typeface="Pretendard SemiBold" pitchFamily="34" charset="-122"/>
                 <a:cs typeface="Pretendard SemiBold" pitchFamily="34" charset="-120"/>
               </a:rPr>
-              <a:t>블로그 썸네일</a:t>
-            </a:r>
-            <a:endParaRPr lang="en-US" sz="1150" dirty="0"/>
-          </a:p>
-        </p:txBody>
-      </p:sp>
-      <p:sp>
-        <p:nvSpPr>
-          <p:cNvPr id="40" name="Text 38"/>
-          <p:cNvSpPr/>
-          <p:nvPr/>
-        </p:nvSpPr>
-        <p:spPr>
-          <a:xfrm>
-            <a:off x="8257032" y="4096512"/>
-            <a:ext cx="3154680" cy="365760"/>
+              <a:t>페이지 · URL 통계</a:t>
+            </a:r>
+            <a:endParaRPr lang="en-US" sz="1100" dirty="0"/>
+          </a:p>
+        </p:txBody>
+      </p:sp>
+      <p:sp>
+        <p:nvSpPr>
+          <p:cNvPr id="43" name="Text 41"/>
+          <p:cNvSpPr/>
+          <p:nvPr/>
+        </p:nvSpPr>
+        <p:spPr>
+          <a:xfrm>
+            <a:off x="8348472" y="3913632"/>
+            <a:ext cx="3063240" cy="347472"/>
           </a:xfrm>
           <a:prstGeom prst="rect">
             <a:avLst/>
@@ -13041,7 +13148,7 @@
               <a:buNone/>
             </a:pPr>
             <a:r>
-              <a:rPr lang="en-US" sz="1050" dirty="0">
+              <a:rPr lang="en-US" sz="1000" dirty="0">
                 <a:solidFill>
                   <a:srgbClr val="55555A"/>
                 </a:solidFill>
@@ -13049,21 +13156,21 @@
                 <a:ea typeface="Pretendard" pitchFamily="34" charset="-122"/>
                 <a:cs typeface="Pretendard" pitchFamily="34" charset="-120"/>
               </a:rPr>
-              <a:t>→ marketing 1-1. 썸네일</a:t>
-            </a:r>
-            <a:endParaRPr lang="en-US" sz="1050" dirty="0"/>
-          </a:p>
-        </p:txBody>
-      </p:sp>
-      <p:sp>
-        <p:nvSpPr>
-          <p:cNvPr id="41" name="Shape 39"/>
-          <p:cNvSpPr/>
-          <p:nvPr/>
-        </p:nvSpPr>
-        <p:spPr>
-          <a:xfrm>
-            <a:off x="6336792" y="4498848"/>
+              <a:t>→ [DS] 3-11</a:t>
+            </a:r>
+            <a:endParaRPr lang="en-US" sz="1000" dirty="0"/>
+          </a:p>
+        </p:txBody>
+      </p:sp>
+      <p:sp>
+        <p:nvSpPr>
+          <p:cNvPr id="44" name="Shape 42"/>
+          <p:cNvSpPr/>
+          <p:nvPr/>
+        </p:nvSpPr>
+        <p:spPr>
+          <a:xfrm>
+            <a:off x="6336792" y="4270248"/>
             <a:ext cx="5074920" cy="0"/>
           </a:xfrm>
           <a:prstGeom prst="line">
@@ -13080,14 +13187,14 @@
       </p:sp>
       <p:sp>
         <p:nvSpPr>
-          <p:cNvPr id="42" name="Text 40"/>
-          <p:cNvSpPr/>
-          <p:nvPr/>
-        </p:nvSpPr>
-        <p:spPr>
-          <a:xfrm>
-            <a:off x="6336792" y="4553712"/>
-            <a:ext cx="1874520" cy="365760"/>
+          <p:cNvPr id="45" name="Text 43"/>
+          <p:cNvSpPr/>
+          <p:nvPr/>
+        </p:nvSpPr>
+        <p:spPr>
+          <a:xfrm>
+            <a:off x="6336792" y="4315968"/>
+            <a:ext cx="1965960" cy="347472"/>
           </a:xfrm>
           <a:prstGeom prst="rect">
             <a:avLst/>
@@ -13106,7 +13213,7 @@
               <a:buNone/>
             </a:pPr>
             <a:r>
-              <a:rPr lang="en-US" sz="1150" dirty="0">
+              <a:rPr lang="en-US" sz="1100" dirty="0">
                 <a:solidFill>
                   <a:srgbClr val="1D1D1F"/>
                 </a:solidFill>
@@ -13114,22 +13221,22 @@
                 <a:ea typeface="Pretendard SemiBold" pitchFamily="34" charset="-122"/>
                 <a:cs typeface="Pretendard SemiBold" pitchFamily="34" charset="-120"/>
               </a:rPr>
-              <a:t>아이콘 제작</a:t>
-            </a:r>
-            <a:endParaRPr lang="en-US" sz="1150" dirty="0"/>
-          </a:p>
-        </p:txBody>
-      </p:sp>
-      <p:sp>
-        <p:nvSpPr>
-          <p:cNvPr id="43" name="Text 41"/>
-          <p:cNvSpPr/>
-          <p:nvPr/>
-        </p:nvSpPr>
-        <p:spPr>
-          <a:xfrm>
-            <a:off x="8257032" y="4553712"/>
-            <a:ext cx="3154680" cy="365760"/>
+              <a:t>계정 · 내 주소</a:t>
+            </a:r>
+            <a:endParaRPr lang="en-US" sz="1100" dirty="0"/>
+          </a:p>
+        </p:txBody>
+      </p:sp>
+      <p:sp>
+        <p:nvSpPr>
+          <p:cNvPr id="46" name="Text 44"/>
+          <p:cNvSpPr/>
+          <p:nvPr/>
+        </p:nvSpPr>
+        <p:spPr>
+          <a:xfrm>
+            <a:off x="8348472" y="4315968"/>
+            <a:ext cx="3063240" cy="347472"/>
           </a:xfrm>
           <a:prstGeom prst="rect">
             <a:avLst/>
@@ -13148,7 +13255,7 @@
               <a:buNone/>
             </a:pPr>
             <a:r>
-              <a:rPr lang="en-US" sz="1050" dirty="0">
+              <a:rPr lang="en-US" sz="1000" dirty="0">
                 <a:solidFill>
                   <a:srgbClr val="55555A"/>
                 </a:solidFill>
@@ -13156,21 +13263,342 @@
                 <a:ea typeface="Pretendard" pitchFamily="34" charset="-122"/>
                 <a:cs typeface="Pretendard" pitchFamily="34" charset="-120"/>
               </a:rPr>
-              <a:t>→ [DS] skills/icon-use</a:t>
-            </a:r>
-            <a:endParaRPr lang="en-US" sz="1050" dirty="0"/>
-          </a:p>
-        </p:txBody>
-      </p:sp>
-      <p:sp>
-        <p:nvSpPr>
-          <p:cNvPr id="44" name="Text 42"/>
-          <p:cNvSpPr/>
-          <p:nvPr/>
-        </p:nvSpPr>
-        <p:spPr>
-          <a:xfrm>
-            <a:off x="777240" y="5806440"/>
+              <a:t>→ [DS] 3-8 · 3-5</a:t>
+            </a:r>
+            <a:endParaRPr lang="en-US" sz="1000" dirty="0"/>
+          </a:p>
+        </p:txBody>
+      </p:sp>
+      <p:sp>
+        <p:nvSpPr>
+          <p:cNvPr id="47" name="Shape 45"/>
+          <p:cNvSpPr/>
+          <p:nvPr/>
+        </p:nvSpPr>
+        <p:spPr>
+          <a:xfrm>
+            <a:off x="6336792" y="4672584"/>
+            <a:ext cx="5074920" cy="0"/>
+          </a:xfrm>
+          <a:prstGeom prst="line">
+            <a:avLst/>
+          </a:prstGeom>
+          <a:noFill/>
+          <a:ln w="6350">
+            <a:solidFill>
+              <a:srgbClr val="F0F0F0"/>
+            </a:solidFill>
+            <a:prstDash val="solid"/>
+          </a:ln>
+        </p:spPr>
+      </p:sp>
+      <p:sp>
+        <p:nvSpPr>
+          <p:cNvPr id="48" name="Text 46"/>
+          <p:cNvSpPr/>
+          <p:nvPr/>
+        </p:nvSpPr>
+        <p:spPr>
+          <a:xfrm>
+            <a:off x="6336792" y="4718304"/>
+            <a:ext cx="1965960" cy="347472"/>
+          </a:xfrm>
+          <a:prstGeom prst="rect">
+            <a:avLst/>
+          </a:prstGeom>
+          <a:noFill/>
+          <a:ln/>
+        </p:spPr>
+        <p:txBody>
+          <a:bodyPr wrap="square" lIns="0" tIns="0" rIns="0" bIns="0" rtlCol="0" anchor="ctr"/>
+          <a:lstStyle/>
+          <a:p>
+            <a:pPr algn="l" indent="0" marL="0">
+              <a:lnSpc>
+                <a:spcPct val="130000"/>
+              </a:lnSpc>
+              <a:buNone/>
+            </a:pPr>
+            <a:r>
+              <a:rPr lang="en-US" sz="1100" dirty="0">
+                <a:solidFill>
+                  <a:srgbClr val="1D1D1F"/>
+                </a:solidFill>
+                <a:latin typeface="Pretendard SemiBold" pitchFamily="34" charset="0"/>
+                <a:ea typeface="Pretendard SemiBold" pitchFamily="34" charset="-122"/>
+                <a:cs typeface="Pretendard SemiBold" pitchFamily="34" charset="-120"/>
+              </a:rPr>
+              <a:t>권한</a:t>
+            </a:r>
+            <a:endParaRPr lang="en-US" sz="1100" dirty="0"/>
+          </a:p>
+        </p:txBody>
+      </p:sp>
+      <p:sp>
+        <p:nvSpPr>
+          <p:cNvPr id="49" name="Text 47"/>
+          <p:cNvSpPr/>
+          <p:nvPr/>
+        </p:nvSpPr>
+        <p:spPr>
+          <a:xfrm>
+            <a:off x="8348472" y="4718304"/>
+            <a:ext cx="3063240" cy="347472"/>
+          </a:xfrm>
+          <a:prstGeom prst="rect">
+            <a:avLst/>
+          </a:prstGeom>
+          <a:noFill/>
+          <a:ln/>
+        </p:spPr>
+        <p:txBody>
+          <a:bodyPr wrap="square" lIns="0" tIns="0" rIns="0" bIns="0" rtlCol="0" anchor="ctr"/>
+          <a:lstStyle/>
+          <a:p>
+            <a:pPr algn="l" indent="0" marL="0">
+              <a:lnSpc>
+                <a:spcPct val="130000"/>
+              </a:lnSpc>
+              <a:buNone/>
+            </a:pPr>
+            <a:r>
+              <a:rPr lang="en-US" sz="1000" dirty="0">
+                <a:solidFill>
+                  <a:srgbClr val="55555A"/>
+                </a:solidFill>
+                <a:latin typeface="Pretendard" pitchFamily="34" charset="0"/>
+                <a:ea typeface="Pretendard" pitchFamily="34" charset="-122"/>
+                <a:cs typeface="Pretendard" pitchFamily="34" charset="-120"/>
+              </a:rPr>
+              <a:t>→ [DS] 3-13</a:t>
+            </a:r>
+            <a:endParaRPr lang="en-US" sz="1000" dirty="0"/>
+          </a:p>
+        </p:txBody>
+      </p:sp>
+      <p:sp>
+        <p:nvSpPr>
+          <p:cNvPr id="50" name="Shape 48"/>
+          <p:cNvSpPr/>
+          <p:nvPr/>
+        </p:nvSpPr>
+        <p:spPr>
+          <a:xfrm>
+            <a:off x="6336792" y="5074920"/>
+            <a:ext cx="5074920" cy="0"/>
+          </a:xfrm>
+          <a:prstGeom prst="line">
+            <a:avLst/>
+          </a:prstGeom>
+          <a:noFill/>
+          <a:ln w="6350">
+            <a:solidFill>
+              <a:srgbClr val="F0F0F0"/>
+            </a:solidFill>
+            <a:prstDash val="solid"/>
+          </a:ln>
+        </p:spPr>
+      </p:sp>
+      <p:sp>
+        <p:nvSpPr>
+          <p:cNvPr id="51" name="Text 49"/>
+          <p:cNvSpPr/>
+          <p:nvPr/>
+        </p:nvSpPr>
+        <p:spPr>
+          <a:xfrm>
+            <a:off x="6336792" y="5120640"/>
+            <a:ext cx="1965960" cy="347472"/>
+          </a:xfrm>
+          <a:prstGeom prst="rect">
+            <a:avLst/>
+          </a:prstGeom>
+          <a:noFill/>
+          <a:ln/>
+        </p:spPr>
+        <p:txBody>
+          <a:bodyPr wrap="square" lIns="0" tIns="0" rIns="0" bIns="0" rtlCol="0" anchor="ctr"/>
+          <a:lstStyle/>
+          <a:p>
+            <a:pPr algn="l" indent="0" marL="0">
+              <a:lnSpc>
+                <a:spcPct val="130000"/>
+              </a:lnSpc>
+              <a:buNone/>
+            </a:pPr>
+            <a:r>
+              <a:rPr lang="en-US" sz="1100" dirty="0">
+                <a:solidFill>
+                  <a:srgbClr val="1D1D1F"/>
+                </a:solidFill>
+                <a:latin typeface="Pretendard SemiBold" pitchFamily="34" charset="0"/>
+                <a:ea typeface="Pretendard SemiBold" pitchFamily="34" charset="-122"/>
+                <a:cs typeface="Pretendard SemiBold" pitchFamily="34" charset="-120"/>
+              </a:rPr>
+              <a:t>요금 · 결제</a:t>
+            </a:r>
+            <a:endParaRPr lang="en-US" sz="1100" dirty="0"/>
+          </a:p>
+        </p:txBody>
+      </p:sp>
+      <p:sp>
+        <p:nvSpPr>
+          <p:cNvPr id="52" name="Text 50"/>
+          <p:cNvSpPr/>
+          <p:nvPr/>
+        </p:nvSpPr>
+        <p:spPr>
+          <a:xfrm>
+            <a:off x="8348472" y="5120640"/>
+            <a:ext cx="3063240" cy="347472"/>
+          </a:xfrm>
+          <a:prstGeom prst="rect">
+            <a:avLst/>
+          </a:prstGeom>
+          <a:noFill/>
+          <a:ln/>
+        </p:spPr>
+        <p:txBody>
+          <a:bodyPr wrap="square" lIns="0" tIns="0" rIns="0" bIns="0" rtlCol="0" anchor="ctr"/>
+          <a:lstStyle/>
+          <a:p>
+            <a:pPr algn="l" indent="0" marL="0">
+              <a:lnSpc>
+                <a:spcPct val="130000"/>
+              </a:lnSpc>
+              <a:buNone/>
+            </a:pPr>
+            <a:r>
+              <a:rPr lang="en-US" sz="1000" dirty="0">
+                <a:solidFill>
+                  <a:srgbClr val="55555A"/>
+                </a:solidFill>
+                <a:latin typeface="Pretendard" pitchFamily="34" charset="0"/>
+                <a:ea typeface="Pretendard" pitchFamily="34" charset="-122"/>
+                <a:cs typeface="Pretendard" pitchFamily="34" charset="-120"/>
+              </a:rPr>
+              <a:t>→ [DS] 3-8 §크레딧</a:t>
+            </a:r>
+            <a:endParaRPr lang="en-US" sz="1000" dirty="0"/>
+          </a:p>
+        </p:txBody>
+      </p:sp>
+      <p:sp>
+        <p:nvSpPr>
+          <p:cNvPr id="53" name="Shape 51"/>
+          <p:cNvSpPr/>
+          <p:nvPr/>
+        </p:nvSpPr>
+        <p:spPr>
+          <a:xfrm>
+            <a:off x="6336792" y="5477256"/>
+            <a:ext cx="5074920" cy="0"/>
+          </a:xfrm>
+          <a:prstGeom prst="line">
+            <a:avLst/>
+          </a:prstGeom>
+          <a:noFill/>
+          <a:ln w="6350">
+            <a:solidFill>
+              <a:srgbClr val="F0F0F0"/>
+            </a:solidFill>
+            <a:prstDash val="solid"/>
+          </a:ln>
+        </p:spPr>
+      </p:sp>
+      <p:sp>
+        <p:nvSpPr>
+          <p:cNvPr id="54" name="Text 52"/>
+          <p:cNvSpPr/>
+          <p:nvPr/>
+        </p:nvSpPr>
+        <p:spPr>
+          <a:xfrm>
+            <a:off x="6336792" y="5522976"/>
+            <a:ext cx="1965960" cy="347472"/>
+          </a:xfrm>
+          <a:prstGeom prst="rect">
+            <a:avLst/>
+          </a:prstGeom>
+          <a:noFill/>
+          <a:ln/>
+        </p:spPr>
+        <p:txBody>
+          <a:bodyPr wrap="square" lIns="0" tIns="0" rIns="0" bIns="0" rtlCol="0" anchor="ctr"/>
+          <a:lstStyle/>
+          <a:p>
+            <a:pPr algn="l" indent="0" marL="0">
+              <a:lnSpc>
+                <a:spcPct val="130000"/>
+              </a:lnSpc>
+              <a:buNone/>
+            </a:pPr>
+            <a:r>
+              <a:rPr lang="en-US" sz="1100" dirty="0">
+                <a:solidFill>
+                  <a:srgbClr val="1D1D1F"/>
+                </a:solidFill>
+                <a:latin typeface="Pretendard SemiBold" pitchFamily="34" charset="0"/>
+                <a:ea typeface="Pretendard SemiBold" pitchFamily="34" charset="-122"/>
+                <a:cs typeface="Pretendard SemiBold" pitchFamily="34" charset="-120"/>
+              </a:rPr>
+              <a:t>템플릿 페이지 생성</a:t>
+            </a:r>
+            <a:endParaRPr lang="en-US" sz="1100" dirty="0"/>
+          </a:p>
+        </p:txBody>
+      </p:sp>
+      <p:sp>
+        <p:nvSpPr>
+          <p:cNvPr id="55" name="Text 53"/>
+          <p:cNvSpPr/>
+          <p:nvPr/>
+        </p:nvSpPr>
+        <p:spPr>
+          <a:xfrm>
+            <a:off x="8348472" y="5522976"/>
+            <a:ext cx="3063240" cy="347472"/>
+          </a:xfrm>
+          <a:prstGeom prst="rect">
+            <a:avLst/>
+          </a:prstGeom>
+          <a:noFill/>
+          <a:ln/>
+        </p:spPr>
+        <p:txBody>
+          <a:bodyPr wrap="square" lIns="0" tIns="0" rIns="0" bIns="0" rtlCol="0" anchor="ctr"/>
+          <a:lstStyle/>
+          <a:p>
+            <a:pPr algn="l" indent="0" marL="0">
+              <a:lnSpc>
+                <a:spcPct val="130000"/>
+              </a:lnSpc>
+              <a:buNone/>
+            </a:pPr>
+            <a:r>
+              <a:rPr lang="en-US" sz="1000" dirty="0">
+                <a:solidFill>
+                  <a:srgbClr val="55555A"/>
+                </a:solidFill>
+                <a:latin typeface="Pretendard" pitchFamily="34" charset="0"/>
+                <a:ea typeface="Pretendard" pitchFamily="34" charset="-122"/>
+                <a:cs typeface="Pretendard" pitchFamily="34" charset="-120"/>
+              </a:rPr>
+              <a:t>→ [DS] 3-14 · [T] 1-1</a:t>
+            </a:r>
+            <a:endParaRPr lang="en-US" sz="1000" dirty="0"/>
+          </a:p>
+        </p:txBody>
+      </p:sp>
+      <p:sp>
+        <p:nvSpPr>
+          <p:cNvPr id="56" name="Text 54"/>
+          <p:cNvSpPr/>
+          <p:nvPr/>
+        </p:nvSpPr>
+        <p:spPr>
+          <a:xfrm>
+            <a:off x="777240" y="5870448"/>
             <a:ext cx="10637215" cy="274320"/>
           </a:xfrm>
           <a:prstGeom prst="rect">
@@ -13198,7 +13626,7 @@
                 <a:ea typeface="Pretendard Medium" pitchFamily="34" charset="-122"/>
                 <a:cs typeface="Pretendard Medium" pitchFamily="34" charset="-120"/>
               </a:rPr>
-              <a:t>핵심 — CdBd 기능뿐 아니라 룩북·QR·마케팅 작업까지 전부. 어느 볼트에서 켜도 이 한 파일로 다 압니다.</a:t>
+              <a:t>핵심 — CdBd 기능만 통합합니다. 룩북·소식지·QR·블로그 같은 제작 작업은 넣지 않습니다.</a:t>
             </a:r>
             <a:endParaRPr lang="en-US" sz="1100" dirty="0"/>
           </a:p>

</xml_diff>